<commit_message>
Update initialization documentation with new and modified topology images
</commit_message>
<xml_diff>
--- a/docs/initialization/topology_catalog.pptx
+++ b/docs/initialization/topology_catalog.pptx
@@ -10971,7 +10971,7 @@
             </a:r>
             <a:r>
               <a:rPr lang="en-US" dirty="0"/>
-              <a:t> single gen/WT/PV</a:t>
+              <a:t> single gen/WT/PV/BESS</a:t>
             </a:r>
           </a:p>
           <a:p>
@@ -10992,7 +10992,7 @@
             </a:r>
             <a:r>
               <a:rPr lang="en-US" dirty="0"/>
-              <a:t> single gen/WT/PV + Line</a:t>
+              <a:t> single gen/WT/PV/BESS + Line</a:t>
             </a:r>
           </a:p>
           <a:p>
@@ -11013,7 +11013,7 @@
             </a:r>
             <a:r>
               <a:rPr lang="en-US" dirty="0"/>
-              <a:t> single gen/WT/PV + Aux Load </a:t>
+              <a:t> single gen/WT/PV/BESS + Aux Load </a:t>
             </a:r>
           </a:p>
           <a:p>
@@ -11034,7 +11034,7 @@
             </a:r>
             <a:r>
               <a:rPr lang="en-US" dirty="0"/>
-              <a:t> single gen/WT/PV + Aux Load + Line</a:t>
+              <a:t> single gen/WT/PV/BESS + Aux Load + Line</a:t>
             </a:r>
           </a:p>
           <a:p>
@@ -11047,7 +11047,7 @@
             </a:r>
             <a:r>
               <a:rPr lang="en-US" dirty="0"/>
-              <a:t> multiple WT/PV</a:t>
+              <a:t> multiple WT/PV/BESS</a:t>
             </a:r>
           </a:p>
           <a:p>
@@ -11068,7 +11068,7 @@
             </a:r>
             <a:r>
               <a:rPr lang="en-US" dirty="0"/>
-              <a:t> multiple WT/PV + Line</a:t>
+              <a:t> multiple WT/PV/BESS + Line</a:t>
             </a:r>
           </a:p>
           <a:p>
@@ -11089,7 +11089,7 @@
             </a:r>
             <a:r>
               <a:rPr lang="en-US" dirty="0"/>
-              <a:t> multiple WT/PV + Aux Load</a:t>
+              <a:t> multiple WT/PV/BESS + Aux Load</a:t>
             </a:r>
           </a:p>
           <a:p>
@@ -11110,7 +11110,7 @@
             </a:r>
             <a:r>
               <a:rPr lang="en-US" dirty="0"/>
-              <a:t> multiple WT/PV + Aux Load + Line</a:t>
+              <a:t> multiple WT/PV/BESS + Aux Load + Line</a:t>
             </a:r>
           </a:p>
         </p:txBody>
@@ -11155,7 +11155,7 @@
             </a:pPr>
             <a:r>
               <a:rPr lang="en-US" sz="1400" i="1" dirty="0"/>
-              <a:t>For Zone 1 WT/PV, the only one allowed is “S”</a:t>
+              <a:t>For Zone 1 WT/PV/BESS, the only one allowed is “S”</a:t>
             </a:r>
           </a:p>
         </p:txBody>
@@ -11671,7 +11671,7 @@
             </a:r>
             <a:r>
               <a:rPr lang="en-US" sz="2000" dirty="0"/>
-              <a:t> single gen/WT/PV</a:t>
+              <a:t> single gen/WT/PV/BESS</a:t>
             </a:r>
           </a:p>
           <a:p>
@@ -11692,7 +11692,7 @@
             </a:r>
             <a:r>
               <a:rPr lang="en-US" sz="2000" dirty="0"/>
-              <a:t> single gen/WT/PV + Line</a:t>
+              <a:t> single gen/WT/PV/BESS + Line</a:t>
             </a:r>
           </a:p>
         </p:txBody>
@@ -12030,7 +12030,7 @@
         </p:nvSpPr>
         <p:spPr>
           <a:xfrm>
-            <a:off x="2040581" y="1619962"/>
+            <a:off x="2040581" y="1318210"/>
             <a:ext cx="2877669" cy="215444"/>
           </a:xfrm>
           <a:prstGeom prst="rect">
@@ -12163,7 +12163,7 @@
         </p:nvSpPr>
         <p:spPr>
           <a:xfrm>
-            <a:off x="2040581" y="1923000"/>
+            <a:off x="2040581" y="1621248"/>
             <a:ext cx="2877669" cy="215444"/>
           </a:xfrm>
           <a:prstGeom prst="rect">
@@ -12204,6 +12204,72 @@
                 <a:cs typeface="Courier New" panose="02070309020205020404" pitchFamily="49" charset="0"/>
               </a:rPr>
               <a:t>PV_Array</a:t>
+            </a:r>
+            <a:r>
+              <a:rPr lang="en-US" sz="1400" dirty="0">
+                <a:latin typeface="Courier New" panose="02070309020205020404" pitchFamily="49" charset="0"/>
+                <a:cs typeface="Courier New" panose="02070309020205020404" pitchFamily="49" charset="0"/>
+              </a:rPr>
+              <a:t>”</a:t>
+            </a:r>
+          </a:p>
+        </p:txBody>
+      </p:sp>
+      <p:sp>
+        <p:nvSpPr>
+          <p:cNvPr id="4" name="CuadroTexto 3">
+            <a:extLst>
+              <a:ext uri="{FF2B5EF4-FFF2-40B4-BE49-F238E27FC236}">
+                <a16:creationId xmlns:a16="http://schemas.microsoft.com/office/drawing/2014/main" id="{331152A1-8121-83E9-6047-D899AC2A225D}"/>
+              </a:ext>
+            </a:extLst>
+          </p:cNvPr>
+          <p:cNvSpPr txBox="1"/>
+          <p:nvPr/>
+        </p:nvSpPr>
+        <p:spPr>
+          <a:xfrm>
+            <a:off x="2040581" y="1924286"/>
+            <a:ext cx="2877669" cy="215444"/>
+          </a:xfrm>
+          <a:prstGeom prst="rect">
+            <a:avLst/>
+          </a:prstGeom>
+          <a:noFill/>
+        </p:spPr>
+        <p:txBody>
+          <a:bodyPr wrap="square" lIns="0" tIns="0" rIns="0" bIns="0" rtlCol="0">
+            <a:spAutoFit/>
+          </a:bodyPr>
+          <a:lstStyle/>
+          <a:p>
+            <a:r>
+              <a:rPr lang="en-US" sz="1400" dirty="0">
+                <a:latin typeface="Courier New" panose="02070309020205020404" pitchFamily="49" charset="0"/>
+                <a:cs typeface="Courier New" panose="02070309020205020404" pitchFamily="49" charset="0"/>
+              </a:rPr>
+              <a:t>id/</a:t>
+            </a:r>
+            <a:r>
+              <a:rPr lang="en-US" sz="1400" dirty="0" err="1">
+                <a:latin typeface="Courier New" panose="02070309020205020404" pitchFamily="49" charset="0"/>
+                <a:cs typeface="Courier New" panose="02070309020205020404" pitchFamily="49" charset="0"/>
+              </a:rPr>
+              <a:t>parId</a:t>
+            </a:r>
+            <a:r>
+              <a:rPr lang="en-US" sz="1400" dirty="0">
+                <a:latin typeface="Courier New" panose="02070309020205020404" pitchFamily="49" charset="0"/>
+                <a:cs typeface="Courier New" panose="02070309020205020404" pitchFamily="49" charset="0"/>
+              </a:rPr>
+              <a:t> = “</a:t>
+            </a:r>
+            <a:r>
+              <a:rPr lang="en-US" sz="1400" dirty="0" err="1">
+                <a:latin typeface="Courier New" panose="02070309020205020404" pitchFamily="49" charset="0"/>
+                <a:cs typeface="Courier New" panose="02070309020205020404" pitchFamily="49" charset="0"/>
+              </a:rPr>
+              <a:t>Bess</a:t>
             </a:r>
             <a:r>
               <a:rPr lang="en-US" sz="1400" dirty="0">
@@ -12229,7 +12295,7 @@
         </p:nvSpPr>
         <p:spPr>
           <a:xfrm>
-            <a:off x="2040580" y="1316924"/>
+            <a:off x="2040580" y="1015172"/>
             <a:ext cx="2859025" cy="215444"/>
           </a:xfrm>
           <a:prstGeom prst="rect">
@@ -13186,7 +13252,7 @@
             </a:r>
             <a:r>
               <a:rPr lang="en-US" sz="2000" dirty="0"/>
-              <a:t> single gen/WT/PV + Aux Load </a:t>
+              <a:t> single gen/WT/PV/BESS + Aux Load </a:t>
             </a:r>
           </a:p>
           <a:p>
@@ -13207,7 +13273,7 @@
             </a:r>
             <a:r>
               <a:rPr lang="en-US" sz="2000" dirty="0"/>
-              <a:t> single gen/WT/PV + Aux Load + Line</a:t>
+              <a:t> single gen/WT/PV/BESS + Aux Load + Line</a:t>
             </a:r>
           </a:p>
         </p:txBody>
@@ -13550,7 +13616,7 @@
         </p:nvSpPr>
         <p:spPr>
           <a:xfrm>
-            <a:off x="1101500" y="1373613"/>
+            <a:off x="1101500" y="1071861"/>
             <a:ext cx="2877669" cy="215444"/>
           </a:xfrm>
           <a:prstGeom prst="rect">
@@ -13616,7 +13682,7 @@
         </p:nvSpPr>
         <p:spPr>
           <a:xfrm>
-            <a:off x="1101500" y="1676651"/>
+            <a:off x="1101500" y="1374899"/>
             <a:ext cx="2877669" cy="215444"/>
           </a:xfrm>
           <a:prstGeom prst="rect">
@@ -13657,6 +13723,72 @@
                 <a:cs typeface="Courier New" panose="02070309020205020404" pitchFamily="49" charset="0"/>
               </a:rPr>
               <a:t>PV_Array</a:t>
+            </a:r>
+            <a:r>
+              <a:rPr lang="en-US" sz="1400" dirty="0">
+                <a:latin typeface="Courier New" panose="02070309020205020404" pitchFamily="49" charset="0"/>
+                <a:cs typeface="Courier New" panose="02070309020205020404" pitchFamily="49" charset="0"/>
+              </a:rPr>
+              <a:t>”</a:t>
+            </a:r>
+          </a:p>
+        </p:txBody>
+      </p:sp>
+      <p:sp>
+        <p:nvSpPr>
+          <p:cNvPr id="7" name="CuadroTexto 6">
+            <a:extLst>
+              <a:ext uri="{FF2B5EF4-FFF2-40B4-BE49-F238E27FC236}">
+                <a16:creationId xmlns:a16="http://schemas.microsoft.com/office/drawing/2014/main" id="{16B3F710-9075-82D5-3677-C6C48D19BAD1}"/>
+              </a:ext>
+            </a:extLst>
+          </p:cNvPr>
+          <p:cNvSpPr txBox="1"/>
+          <p:nvPr/>
+        </p:nvSpPr>
+        <p:spPr>
+          <a:xfrm>
+            <a:off x="1101500" y="1677937"/>
+            <a:ext cx="2877669" cy="215444"/>
+          </a:xfrm>
+          <a:prstGeom prst="rect">
+            <a:avLst/>
+          </a:prstGeom>
+          <a:noFill/>
+        </p:spPr>
+        <p:txBody>
+          <a:bodyPr wrap="square" lIns="0" tIns="0" rIns="0" bIns="0" rtlCol="0">
+            <a:spAutoFit/>
+          </a:bodyPr>
+          <a:lstStyle/>
+          <a:p>
+            <a:r>
+              <a:rPr lang="en-US" sz="1400" dirty="0">
+                <a:latin typeface="Courier New" panose="02070309020205020404" pitchFamily="49" charset="0"/>
+                <a:cs typeface="Courier New" panose="02070309020205020404" pitchFamily="49" charset="0"/>
+              </a:rPr>
+              <a:t>id/</a:t>
+            </a:r>
+            <a:r>
+              <a:rPr lang="en-US" sz="1400" dirty="0" err="1">
+                <a:latin typeface="Courier New" panose="02070309020205020404" pitchFamily="49" charset="0"/>
+                <a:cs typeface="Courier New" panose="02070309020205020404" pitchFamily="49" charset="0"/>
+              </a:rPr>
+              <a:t>parId</a:t>
+            </a:r>
+            <a:r>
+              <a:rPr lang="en-US" sz="1400" dirty="0">
+                <a:latin typeface="Courier New" panose="02070309020205020404" pitchFamily="49" charset="0"/>
+                <a:cs typeface="Courier New" panose="02070309020205020404" pitchFamily="49" charset="0"/>
+              </a:rPr>
+              <a:t> = “</a:t>
+            </a:r>
+            <a:r>
+              <a:rPr lang="en-US" sz="1400" dirty="0" err="1">
+                <a:latin typeface="Courier New" panose="02070309020205020404" pitchFamily="49" charset="0"/>
+                <a:cs typeface="Courier New" panose="02070309020205020404" pitchFamily="49" charset="0"/>
+              </a:rPr>
+              <a:t>Bess</a:t>
             </a:r>
             <a:r>
               <a:rPr lang="en-US" sz="1400" dirty="0">
@@ -13682,7 +13814,7 @@
         </p:nvSpPr>
         <p:spPr>
           <a:xfrm>
-            <a:off x="1101499" y="1070575"/>
+            <a:off x="1101499" y="768823"/>
             <a:ext cx="2859025" cy="215444"/>
           </a:xfrm>
           <a:prstGeom prst="rect">
@@ -14625,7 +14757,7 @@
             </a:r>
             <a:r>
               <a:rPr lang="en-US" sz="2000" dirty="0"/>
-              <a:t> multiple WT/PV</a:t>
+              <a:t> multiple WT/PV/BESS</a:t>
             </a:r>
           </a:p>
           <a:p>
@@ -14646,7 +14778,7 @@
             </a:r>
             <a:r>
               <a:rPr lang="en-US" sz="2000" dirty="0"/>
-              <a:t> multiple WT/PV + Line</a:t>
+              <a:t> multiple WT/PV/BESS + Line</a:t>
             </a:r>
             <a:endParaRPr lang="en-US" sz="2000" dirty="0">
               <a:solidFill>
@@ -16795,7 +16927,7 @@
                 <a:latin typeface="Courier New" panose="02070309020205020404" pitchFamily="49" charset="0"/>
                 <a:cs typeface="Courier New" panose="02070309020205020404" pitchFamily="49" charset="0"/>
               </a:rPr>
-              <a:t>PPM_Xfmr</a:t>
+              <a:t>Main_Xfmr</a:t>
             </a:r>
             <a:r>
               <a:rPr lang="en-US" sz="1400" dirty="0">
@@ -17438,7 +17570,7 @@
             </a:r>
             <a:r>
               <a:rPr lang="en-US" sz="2000" dirty="0"/>
-              <a:t> multiple WT/PV + Aux Load</a:t>
+              <a:t> multiple WT/PV/BESS + Aux Load</a:t>
             </a:r>
           </a:p>
           <a:p>
@@ -17459,7 +17591,7 @@
             </a:r>
             <a:r>
               <a:rPr lang="en-US" sz="2000" dirty="0"/>
-              <a:t> multiple WT/PV + Aux Load + Line</a:t>
+              <a:t> multiple WT/PV/BESS + Aux Load + Line</a:t>
             </a:r>
           </a:p>
         </p:txBody>
@@ -19860,7 +19992,7 @@
                 <a:latin typeface="Courier New" panose="02070309020205020404" pitchFamily="49" charset="0"/>
                 <a:cs typeface="Courier New" panose="02070309020205020404" pitchFamily="49" charset="0"/>
               </a:rPr>
-              <a:t>PPM_Xfmr</a:t>
+              <a:t>Main_Xfmr</a:t>
             </a:r>
             <a:r>
               <a:rPr lang="en-US" sz="1400" dirty="0">
@@ -20693,11 +20825,11 @@
             <a:pPr algn="ctr"/>
             <a:r>
               <a:rPr lang="en-US" sz="2000" b="1" dirty="0"/>
-              <a:t>For PPMs, Zone 1: allow only Topology “S”:</a:t>
+              <a:t>For PPMs/BESS, Zone 1: allow only Topology “S”:</a:t>
             </a:r>
             <a:r>
               <a:rPr lang="en-US" sz="2000" dirty="0"/>
-              <a:t> (single WT/PV)</a:t>
+              <a:t> (single WT/PV/BESS)</a:t>
             </a:r>
           </a:p>
         </p:txBody>

</xml_diff>

<commit_message>
docs: describe the producer topologies as the RTE catalog defines them
</commit_message>
<xml_diff>
--- a/docs/initialization/topology_catalog.pptx
+++ b/docs/initialization/topology_catalog.pptx
@@ -177,6 +177,976 @@
 </p:presentation>
 </file>
 
+<file path=ppt/revisionInfo.xml><?xml version="1.0" encoding="utf-8"?>
+<p1510:revInfo xmlns:a="http://schemas.openxmlformats.org/drawingml/2006/main" xmlns:r="http://schemas.openxmlformats.org/officeDocument/2006/relationships" xmlns:p1510="http://schemas.microsoft.com/office/powerpoint/2015/10/main">
+  <p1510:revLst>
+    <p1510:client id="{00000000-0000-0000-0000-000000000000}" v="10" dt="2026-09-03T08:06:27.755"/>
+    <p1510:client id="{9A36CF15-CAE4-4630-A012-11FE975CFDBB}" v="1" dt="2026-09-03T07:56:56.746"/>
+    <p1510:client id="{CA849B27-3901-3543-9926-CB83C5BCD1F7}" v="2" dt="2026-09-03T07:23:45.783"/>
+  </p1510:revLst>
+</p1510:revInfo>
+</file>
+
+<file path=ppt/changesInfos/changesInfo1.xml><?xml version="1.0" encoding="utf-8"?>
+<pc:chgInfo xmlns:a="http://schemas.openxmlformats.org/drawingml/2006/main" xmlns:r="http://schemas.openxmlformats.org/officeDocument/2006/relationships" xmlns:ac="http://schemas.microsoft.com/office/drawing/2013/main/command" xmlns:pc="http://schemas.microsoft.com/office/powerpoint/2013/main/command">
+  <pc:docChgLst>
+    <pc:chgData name="Marcos De Miguel Cruz" userId="S::demiguelm@aia.es::dff9766d-3fe8-4659-a0c1-e1b87a709fe4" providerId="AD" clId="Web-{00000000-0000-0000-0000-000000000000}"/>
+    <pc:docChg chg="modSld">
+      <pc:chgData name="Marcos De Miguel Cruz" userId="S::demiguelm@aia.es::dff9766d-3fe8-4659-a0c1-e1b87a709fe4" providerId="AD" clId="Web-{00000000-0000-0000-0000-000000000000}" dt="2026-09-03T08:06:25.505" v="3" actId="20577"/>
+      <pc:docMkLst>
+        <pc:docMk/>
+      </pc:docMkLst>
+      <pc:sldChg chg="modSp">
+        <pc:chgData name="Marcos De Miguel Cruz" userId="S::demiguelm@aia.es::dff9766d-3fe8-4659-a0c1-e1b87a709fe4" providerId="AD" clId="Web-{00000000-0000-0000-0000-000000000000}" dt="2026-09-03T08:06:25.505" v="3" actId="20577"/>
+        <pc:sldMkLst>
+          <pc:docMk/>
+          <pc:sldMk cId="1841050961" sldId="365"/>
+        </pc:sldMkLst>
+        <pc:spChg chg="mod">
+          <ac:chgData name="Marcos De Miguel Cruz" userId="S::demiguelm@aia.es::dff9766d-3fe8-4659-a0c1-e1b87a709fe4" providerId="AD" clId="Web-{00000000-0000-0000-0000-000000000000}" dt="2026-09-03T08:06:25.505" v="3" actId="20577"/>
+          <ac:spMkLst>
+            <pc:docMk/>
+            <pc:sldMk cId="1841050961" sldId="365"/>
+            <ac:spMk id="62" creationId="{F22DD016-C797-0772-4590-E4455B7D7549}"/>
+          </ac:spMkLst>
+        </pc:spChg>
+      </pc:sldChg>
+    </pc:docChg>
+  </pc:docChgLst>
+  <pc:docChgLst>
+    <pc:chgData name="Jose Luis Marin" userId="3f401816-0403-4e64-94bc-52b7ba2907f3" providerId="ADAL" clId="{605105EB-6CED-5A53-A41C-D9F7740771D7}"/>
+    <pc:docChg chg="undo custSel modSld">
+      <pc:chgData name="Jose Luis Marin" userId="3f401816-0403-4e64-94bc-52b7ba2907f3" providerId="ADAL" clId="{605105EB-6CED-5A53-A41C-D9F7740771D7}" dt="2026-09-03T07:26:23.755" v="1412" actId="20577"/>
+      <pc:docMkLst>
+        <pc:docMk/>
+      </pc:docMkLst>
+      <pc:sldChg chg="modSp mod">
+        <pc:chgData name="Jose Luis Marin" userId="3f401816-0403-4e64-94bc-52b7ba2907f3" providerId="ADAL" clId="{605105EB-6CED-5A53-A41C-D9F7740771D7}" dt="2026-09-03T07:06:25.510" v="176" actId="1076"/>
+        <pc:sldMkLst>
+          <pc:docMk/>
+          <pc:sldMk cId="1345159927" sldId="361"/>
+        </pc:sldMkLst>
+        <pc:spChg chg="mod">
+          <ac:chgData name="Jose Luis Marin" userId="3f401816-0403-4e64-94bc-52b7ba2907f3" providerId="ADAL" clId="{605105EB-6CED-5A53-A41C-D9F7740771D7}" dt="2026-09-03T07:04:49.555" v="90" actId="1036"/>
+          <ac:spMkLst>
+            <pc:docMk/>
+            <pc:sldMk cId="1345159927" sldId="361"/>
+            <ac:spMk id="2" creationId="{4AC540DC-55ED-20B4-B288-6C5D9C93D0B5}"/>
+          </ac:spMkLst>
+        </pc:spChg>
+        <pc:spChg chg="mod">
+          <ac:chgData name="Jose Luis Marin" userId="3f401816-0403-4e64-94bc-52b7ba2907f3" providerId="ADAL" clId="{605105EB-6CED-5A53-A41C-D9F7740771D7}" dt="2026-09-03T07:06:25.510" v="176" actId="1076"/>
+          <ac:spMkLst>
+            <pc:docMk/>
+            <pc:sldMk cId="1345159927" sldId="361"/>
+            <ac:spMk id="3" creationId="{124E0788-544B-38AC-9DCA-7335AC24E5EB}"/>
+          </ac:spMkLst>
+        </pc:spChg>
+        <pc:spChg chg="mod">
+          <ac:chgData name="Jose Luis Marin" userId="3f401816-0403-4e64-94bc-52b7ba2907f3" providerId="ADAL" clId="{605105EB-6CED-5A53-A41C-D9F7740771D7}" dt="2026-09-03T07:04:49.555" v="90" actId="1036"/>
+          <ac:spMkLst>
+            <pc:docMk/>
+            <pc:sldMk cId="1345159927" sldId="361"/>
+            <ac:spMk id="4" creationId="{331152A1-8121-83E9-6047-D899AC2A225D}"/>
+          </ac:spMkLst>
+        </pc:spChg>
+        <pc:spChg chg="mod">
+          <ac:chgData name="Jose Luis Marin" userId="3f401816-0403-4e64-94bc-52b7ba2907f3" providerId="ADAL" clId="{605105EB-6CED-5A53-A41C-D9F7740771D7}" dt="2026-09-03T07:04:49.555" v="90" actId="1036"/>
+          <ac:spMkLst>
+            <pc:docMk/>
+            <pc:sldMk cId="1345159927" sldId="361"/>
+            <ac:spMk id="5" creationId="{ADEA08FD-B8F5-08FF-F77F-613ED847AAFD}"/>
+          </ac:spMkLst>
+        </pc:spChg>
+        <pc:spChg chg="mod">
+          <ac:chgData name="Jose Luis Marin" userId="3f401816-0403-4e64-94bc-52b7ba2907f3" providerId="ADAL" clId="{605105EB-6CED-5A53-A41C-D9F7740771D7}" dt="2026-09-03T07:06:21.085" v="175" actId="1076"/>
+          <ac:spMkLst>
+            <pc:docMk/>
+            <pc:sldMk cId="1345159927" sldId="361"/>
+            <ac:spMk id="7" creationId="{49BFAF12-3276-D0AE-D019-EA9E0FB5D354}"/>
+          </ac:spMkLst>
+        </pc:spChg>
+        <pc:spChg chg="mod">
+          <ac:chgData name="Jose Luis Marin" userId="3f401816-0403-4e64-94bc-52b7ba2907f3" providerId="ADAL" clId="{605105EB-6CED-5A53-A41C-D9F7740771D7}" dt="2026-09-03T07:04:34.615" v="55" actId="1038"/>
+          <ac:spMkLst>
+            <pc:docMk/>
+            <pc:sldMk cId="1345159927" sldId="361"/>
+            <ac:spMk id="18" creationId="{DC26748F-CB1F-CFFD-C1AB-A740CF691A73}"/>
+          </ac:spMkLst>
+        </pc:spChg>
+        <pc:spChg chg="mod">
+          <ac:chgData name="Jose Luis Marin" userId="3f401816-0403-4e64-94bc-52b7ba2907f3" providerId="ADAL" clId="{605105EB-6CED-5A53-A41C-D9F7740771D7}" dt="2026-09-03T07:06:01.509" v="172" actId="1076"/>
+          <ac:spMkLst>
+            <pc:docMk/>
+            <pc:sldMk cId="1345159927" sldId="361"/>
+            <ac:spMk id="22" creationId="{FA1F6BEF-3E16-24A5-D9F6-67D59411D645}"/>
+          </ac:spMkLst>
+        </pc:spChg>
+        <pc:spChg chg="mod">
+          <ac:chgData name="Jose Luis Marin" userId="3f401816-0403-4e64-94bc-52b7ba2907f3" providerId="ADAL" clId="{605105EB-6CED-5A53-A41C-D9F7740771D7}" dt="2026-09-03T07:04:34.615" v="55" actId="1038"/>
+          <ac:spMkLst>
+            <pc:docMk/>
+            <pc:sldMk cId="1345159927" sldId="361"/>
+            <ac:spMk id="23" creationId="{F5D7EA7C-0477-E7CF-AD1B-19CFABC78EC3}"/>
+          </ac:spMkLst>
+        </pc:spChg>
+        <pc:spChg chg="mod">
+          <ac:chgData name="Jose Luis Marin" userId="3f401816-0403-4e64-94bc-52b7ba2907f3" providerId="ADAL" clId="{605105EB-6CED-5A53-A41C-D9F7740771D7}" dt="2026-09-03T07:04:34.615" v="55" actId="1038"/>
+          <ac:spMkLst>
+            <pc:docMk/>
+            <pc:sldMk cId="1345159927" sldId="361"/>
+            <ac:spMk id="24" creationId="{AC34A577-8001-3DCD-2B76-EECF560CCD8A}"/>
+          </ac:spMkLst>
+        </pc:spChg>
+        <pc:grpChg chg="mod">
+          <ac:chgData name="Jose Luis Marin" userId="3f401816-0403-4e64-94bc-52b7ba2907f3" providerId="ADAL" clId="{605105EB-6CED-5A53-A41C-D9F7740771D7}" dt="2026-09-03T07:05:40.705" v="130" actId="1035"/>
+          <ac:grpSpMkLst>
+            <pc:docMk/>
+            <pc:sldMk cId="1345159927" sldId="361"/>
+            <ac:grpSpMk id="26" creationId="{239516C0-AB8E-25D5-FB3F-4D7A77D5D9E2}"/>
+          </ac:grpSpMkLst>
+        </pc:grpChg>
+        <pc:cxnChg chg="mod">
+          <ac:chgData name="Jose Luis Marin" userId="3f401816-0403-4e64-94bc-52b7ba2907f3" providerId="ADAL" clId="{605105EB-6CED-5A53-A41C-D9F7740771D7}" dt="2026-09-03T07:05:48.385" v="170" actId="1037"/>
+          <ac:cxnSpMkLst>
+            <pc:docMk/>
+            <pc:sldMk cId="1345159927" sldId="361"/>
+            <ac:cxnSpMk id="13" creationId="{ADA46642-9A30-F44B-F1EA-08E38FC1F970}"/>
+          </ac:cxnSpMkLst>
+        </pc:cxnChg>
+        <pc:cxnChg chg="mod">
+          <ac:chgData name="Jose Luis Marin" userId="3f401816-0403-4e64-94bc-52b7ba2907f3" providerId="ADAL" clId="{605105EB-6CED-5A53-A41C-D9F7740771D7}" dt="2026-09-03T07:03:38.918" v="3" actId="1076"/>
+          <ac:cxnSpMkLst>
+            <pc:docMk/>
+            <pc:sldMk cId="1345159927" sldId="361"/>
+            <ac:cxnSpMk id="14" creationId="{FD62EF68-0717-02DF-141D-E777529749B0}"/>
+          </ac:cxnSpMkLst>
+        </pc:cxnChg>
+        <pc:cxnChg chg="mod">
+          <ac:chgData name="Jose Luis Marin" userId="3f401816-0403-4e64-94bc-52b7ba2907f3" providerId="ADAL" clId="{605105EB-6CED-5A53-A41C-D9F7740771D7}" dt="2026-09-03T07:04:34.615" v="55" actId="1038"/>
+          <ac:cxnSpMkLst>
+            <pc:docMk/>
+            <pc:sldMk cId="1345159927" sldId="361"/>
+            <ac:cxnSpMk id="17" creationId="{41C3C4FC-B0C0-A82C-D605-860CAB617B00}"/>
+          </ac:cxnSpMkLst>
+        </pc:cxnChg>
+        <pc:cxnChg chg="mod">
+          <ac:chgData name="Jose Luis Marin" userId="3f401816-0403-4e64-94bc-52b7ba2907f3" providerId="ADAL" clId="{605105EB-6CED-5A53-A41C-D9F7740771D7}" dt="2026-09-03T07:04:34.615" v="55" actId="1038"/>
+          <ac:cxnSpMkLst>
+            <pc:docMk/>
+            <pc:sldMk cId="1345159927" sldId="361"/>
+            <ac:cxnSpMk id="20" creationId="{2ADD77D0-4C72-CA7A-CE63-3E25C707286D}"/>
+          </ac:cxnSpMkLst>
+        </pc:cxnChg>
+        <pc:cxnChg chg="mod">
+          <ac:chgData name="Jose Luis Marin" userId="3f401816-0403-4e64-94bc-52b7ba2907f3" providerId="ADAL" clId="{605105EB-6CED-5A53-A41C-D9F7740771D7}" dt="2026-09-03T07:05:54.306" v="171" actId="1076"/>
+          <ac:cxnSpMkLst>
+            <pc:docMk/>
+            <pc:sldMk cId="1345159927" sldId="361"/>
+            <ac:cxnSpMk id="21" creationId="{B75B1BE9-6EBF-2C4E-70DC-EDF0BF2492E8}"/>
+          </ac:cxnSpMkLst>
+        </pc:cxnChg>
+      </pc:sldChg>
+      <pc:sldChg chg="modSp mod">
+        <pc:chgData name="Jose Luis Marin" userId="3f401816-0403-4e64-94bc-52b7ba2907f3" providerId="ADAL" clId="{605105EB-6CED-5A53-A41C-D9F7740771D7}" dt="2026-09-03T07:11:30.893" v="475" actId="1076"/>
+        <pc:sldMkLst>
+          <pc:docMk/>
+          <pc:sldMk cId="4015711507" sldId="363"/>
+        </pc:sldMkLst>
+        <pc:spChg chg="mod">
+          <ac:chgData name="Jose Luis Marin" userId="3f401816-0403-4e64-94bc-52b7ba2907f3" providerId="ADAL" clId="{605105EB-6CED-5A53-A41C-D9F7740771D7}" dt="2026-09-03T07:09:17.234" v="315" actId="1036"/>
+          <ac:spMkLst>
+            <pc:docMk/>
+            <pc:sldMk cId="4015711507" sldId="363"/>
+            <ac:spMk id="4" creationId="{F2FC22C4-7EB9-F3DA-BA24-6CEB448EA5B9}"/>
+          </ac:spMkLst>
+        </pc:spChg>
+        <pc:spChg chg="mod">
+          <ac:chgData name="Jose Luis Marin" userId="3f401816-0403-4e64-94bc-52b7ba2907f3" providerId="ADAL" clId="{605105EB-6CED-5A53-A41C-D9F7740771D7}" dt="2026-09-03T07:09:17.234" v="315" actId="1036"/>
+          <ac:spMkLst>
+            <pc:docMk/>
+            <pc:sldMk cId="4015711507" sldId="363"/>
+            <ac:spMk id="7" creationId="{16B3F710-9075-82D5-3677-C6C48D19BAD1}"/>
+          </ac:spMkLst>
+        </pc:spChg>
+        <pc:spChg chg="mod">
+          <ac:chgData name="Jose Luis Marin" userId="3f401816-0403-4e64-94bc-52b7ba2907f3" providerId="ADAL" clId="{605105EB-6CED-5A53-A41C-D9F7740771D7}" dt="2026-09-03T07:09:17.234" v="315" actId="1036"/>
+          <ac:spMkLst>
+            <pc:docMk/>
+            <pc:sldMk cId="4015711507" sldId="363"/>
+            <ac:spMk id="16" creationId="{7E2F9523-2D4F-0CFC-18CB-FEEDBBABE1FE}"/>
+          </ac:spMkLst>
+        </pc:spChg>
+        <pc:spChg chg="mod">
+          <ac:chgData name="Jose Luis Marin" userId="3f401816-0403-4e64-94bc-52b7ba2907f3" providerId="ADAL" clId="{605105EB-6CED-5A53-A41C-D9F7740771D7}" dt="2026-09-03T07:09:47.591" v="389" actId="1038"/>
+          <ac:spMkLst>
+            <pc:docMk/>
+            <pc:sldMk cId="4015711507" sldId="363"/>
+            <ac:spMk id="18" creationId="{DC26748F-CB1F-CFFD-C1AB-A740CF691A73}"/>
+          </ac:spMkLst>
+        </pc:spChg>
+        <pc:spChg chg="mod">
+          <ac:chgData name="Jose Luis Marin" userId="3f401816-0403-4e64-94bc-52b7ba2907f3" providerId="ADAL" clId="{605105EB-6CED-5A53-A41C-D9F7740771D7}" dt="2026-09-03T07:11:30.893" v="475" actId="1076"/>
+          <ac:spMkLst>
+            <pc:docMk/>
+            <pc:sldMk cId="4015711507" sldId="363"/>
+            <ac:spMk id="22" creationId="{FA1F6BEF-3E16-24A5-D9F6-67D59411D645}"/>
+          </ac:spMkLst>
+        </pc:spChg>
+        <pc:spChg chg="mod">
+          <ac:chgData name="Jose Luis Marin" userId="3f401816-0403-4e64-94bc-52b7ba2907f3" providerId="ADAL" clId="{605105EB-6CED-5A53-A41C-D9F7740771D7}" dt="2026-09-03T07:09:47.591" v="389" actId="1038"/>
+          <ac:spMkLst>
+            <pc:docMk/>
+            <pc:sldMk cId="4015711507" sldId="363"/>
+            <ac:spMk id="23" creationId="{F5D7EA7C-0477-E7CF-AD1B-19CFABC78EC3}"/>
+          </ac:spMkLst>
+        </pc:spChg>
+        <pc:spChg chg="mod">
+          <ac:chgData name="Jose Luis Marin" userId="3f401816-0403-4e64-94bc-52b7ba2907f3" providerId="ADAL" clId="{605105EB-6CED-5A53-A41C-D9F7740771D7}" dt="2026-09-03T07:09:47.591" v="389" actId="1038"/>
+          <ac:spMkLst>
+            <pc:docMk/>
+            <pc:sldMk cId="4015711507" sldId="363"/>
+            <ac:spMk id="24" creationId="{AC34A577-8001-3DCD-2B76-EECF560CCD8A}"/>
+          </ac:spMkLst>
+        </pc:spChg>
+        <pc:spChg chg="mod">
+          <ac:chgData name="Jose Luis Marin" userId="3f401816-0403-4e64-94bc-52b7ba2907f3" providerId="ADAL" clId="{605105EB-6CED-5A53-A41C-D9F7740771D7}" dt="2026-09-03T07:11:18.542" v="455" actId="1076"/>
+          <ac:spMkLst>
+            <pc:docMk/>
+            <pc:sldMk cId="4015711507" sldId="363"/>
+            <ac:spMk id="28" creationId="{A933839B-E2F0-2767-867C-C3D21571B116}"/>
+          </ac:spMkLst>
+        </pc:spChg>
+        <pc:spChg chg="mod">
+          <ac:chgData name="Jose Luis Marin" userId="3f401816-0403-4e64-94bc-52b7ba2907f3" providerId="ADAL" clId="{605105EB-6CED-5A53-A41C-D9F7740771D7}" dt="2026-09-03T07:08:58.989" v="300" actId="1037"/>
+          <ac:spMkLst>
+            <pc:docMk/>
+            <pc:sldMk cId="4015711507" sldId="363"/>
+            <ac:spMk id="29" creationId="{43B28C03-AE61-7194-DAAD-8D3E3CA0FCFF}"/>
+          </ac:spMkLst>
+        </pc:spChg>
+        <pc:spChg chg="mod">
+          <ac:chgData name="Jose Luis Marin" userId="3f401816-0403-4e64-94bc-52b7ba2907f3" providerId="ADAL" clId="{605105EB-6CED-5A53-A41C-D9F7740771D7}" dt="2026-09-03T07:09:47.591" v="389" actId="1038"/>
+          <ac:spMkLst>
+            <pc:docMk/>
+            <pc:sldMk cId="4015711507" sldId="363"/>
+            <ac:spMk id="30" creationId="{7EEFCEAF-DBA9-D087-A1D1-D50925979DBF}"/>
+          </ac:spMkLst>
+        </pc:spChg>
+        <pc:spChg chg="mod">
+          <ac:chgData name="Jose Luis Marin" userId="3f401816-0403-4e64-94bc-52b7ba2907f3" providerId="ADAL" clId="{605105EB-6CED-5A53-A41C-D9F7740771D7}" dt="2026-09-03T07:09:47.591" v="389" actId="1038"/>
+          <ac:spMkLst>
+            <pc:docMk/>
+            <pc:sldMk cId="4015711507" sldId="363"/>
+            <ac:spMk id="31" creationId="{703BC30B-617F-EE1A-1C3C-874678D542F1}"/>
+          </ac:spMkLst>
+        </pc:spChg>
+        <pc:spChg chg="mod">
+          <ac:chgData name="Jose Luis Marin" userId="3f401816-0403-4e64-94bc-52b7ba2907f3" providerId="ADAL" clId="{605105EB-6CED-5A53-A41C-D9F7740771D7}" dt="2026-09-03T07:09:47.591" v="389" actId="1038"/>
+          <ac:spMkLst>
+            <pc:docMk/>
+            <pc:sldMk cId="4015711507" sldId="363"/>
+            <ac:spMk id="32" creationId="{C12B3264-F350-D42A-8718-D3FB967B495A}"/>
+          </ac:spMkLst>
+        </pc:spChg>
+        <pc:spChg chg="mod">
+          <ac:chgData name="Jose Luis Marin" userId="3f401816-0403-4e64-94bc-52b7ba2907f3" providerId="ADAL" clId="{605105EB-6CED-5A53-A41C-D9F7740771D7}" dt="2026-09-03T07:09:47.591" v="389" actId="1038"/>
+          <ac:spMkLst>
+            <pc:docMk/>
+            <pc:sldMk cId="4015711507" sldId="363"/>
+            <ac:spMk id="33" creationId="{56E9C622-174F-E231-93CD-8D7A7B5A6DA7}"/>
+          </ac:spMkLst>
+        </pc:spChg>
+        <pc:grpChg chg="mod">
+          <ac:chgData name="Jose Luis Marin" userId="3f401816-0403-4e64-94bc-52b7ba2907f3" providerId="ADAL" clId="{605105EB-6CED-5A53-A41C-D9F7740771D7}" dt="2026-09-03T07:09:17.234" v="315" actId="1036"/>
+          <ac:grpSpMkLst>
+            <pc:docMk/>
+            <pc:sldMk cId="4015711507" sldId="363"/>
+            <ac:grpSpMk id="10" creationId="{B49D6AA5-A2BF-8217-F5E1-666E1354247E}"/>
+          </ac:grpSpMkLst>
+        </pc:grpChg>
+        <pc:grpChg chg="mod">
+          <ac:chgData name="Jose Luis Marin" userId="3f401816-0403-4e64-94bc-52b7ba2907f3" providerId="ADAL" clId="{605105EB-6CED-5A53-A41C-D9F7740771D7}" dt="2026-09-03T07:10:56.818" v="421" actId="1036"/>
+          <ac:grpSpMkLst>
+            <pc:docMk/>
+            <pc:sldMk cId="4015711507" sldId="363"/>
+            <ac:grpSpMk id="15" creationId="{28A66F8D-94C4-F497-4A40-A412D28DF524}"/>
+          </ac:grpSpMkLst>
+        </pc:grpChg>
+        <pc:grpChg chg="mod">
+          <ac:chgData name="Jose Luis Marin" userId="3f401816-0403-4e64-94bc-52b7ba2907f3" providerId="ADAL" clId="{605105EB-6CED-5A53-A41C-D9F7740771D7}" dt="2026-09-03T07:08:58.989" v="300" actId="1037"/>
+          <ac:grpSpMkLst>
+            <pc:docMk/>
+            <pc:sldMk cId="4015711507" sldId="363"/>
+            <ac:grpSpMk id="19" creationId="{E61B5137-00B9-9406-9B51-A2B496CF6825}"/>
+          </ac:grpSpMkLst>
+        </pc:grpChg>
+        <pc:cxnChg chg="mod">
+          <ac:chgData name="Jose Luis Marin" userId="3f401816-0403-4e64-94bc-52b7ba2907f3" providerId="ADAL" clId="{605105EB-6CED-5A53-A41C-D9F7740771D7}" dt="2026-09-03T07:08:58.989" v="300" actId="1037"/>
+          <ac:cxnSpMkLst>
+            <pc:docMk/>
+            <pc:sldMk cId="4015711507" sldId="363"/>
+            <ac:cxnSpMk id="3" creationId="{27845976-65A6-B724-8110-AA41AD933427}"/>
+          </ac:cxnSpMkLst>
+        </pc:cxnChg>
+        <pc:cxnChg chg="mod">
+          <ac:chgData name="Jose Luis Marin" userId="3f401816-0403-4e64-94bc-52b7ba2907f3" providerId="ADAL" clId="{605105EB-6CED-5A53-A41C-D9F7740771D7}" dt="2026-09-03T07:08:58.989" v="300" actId="1037"/>
+          <ac:cxnSpMkLst>
+            <pc:docMk/>
+            <pc:sldMk cId="4015711507" sldId="363"/>
+            <ac:cxnSpMk id="5" creationId="{970FA249-BA24-DF00-68C7-05BA90C99D2F}"/>
+          </ac:cxnSpMkLst>
+        </pc:cxnChg>
+        <pc:cxnChg chg="mod">
+          <ac:chgData name="Jose Luis Marin" userId="3f401816-0403-4e64-94bc-52b7ba2907f3" providerId="ADAL" clId="{605105EB-6CED-5A53-A41C-D9F7740771D7}" dt="2026-09-03T07:09:17.234" v="315" actId="1036"/>
+          <ac:cxnSpMkLst>
+            <pc:docMk/>
+            <pc:sldMk cId="4015711507" sldId="363"/>
+            <ac:cxnSpMk id="6" creationId="{BFAFD766-BCBB-9C9E-C668-81CADD6D1301}"/>
+          </ac:cxnSpMkLst>
+        </pc:cxnChg>
+        <pc:cxnChg chg="mod">
+          <ac:chgData name="Jose Luis Marin" userId="3f401816-0403-4e64-94bc-52b7ba2907f3" providerId="ADAL" clId="{605105EB-6CED-5A53-A41C-D9F7740771D7}" dt="2026-09-03T07:11:02.406" v="453" actId="1037"/>
+          <ac:cxnSpMkLst>
+            <pc:docMk/>
+            <pc:sldMk cId="4015711507" sldId="363"/>
+            <ac:cxnSpMk id="13" creationId="{ADA46642-9A30-F44B-F1EA-08E38FC1F970}"/>
+          </ac:cxnSpMkLst>
+        </pc:cxnChg>
+        <pc:cxnChg chg="mod">
+          <ac:chgData name="Jose Luis Marin" userId="3f401816-0403-4e64-94bc-52b7ba2907f3" providerId="ADAL" clId="{605105EB-6CED-5A53-A41C-D9F7740771D7}" dt="2026-09-03T07:09:35.654" v="334" actId="1037"/>
+          <ac:cxnSpMkLst>
+            <pc:docMk/>
+            <pc:sldMk cId="4015711507" sldId="363"/>
+            <ac:cxnSpMk id="14" creationId="{FD62EF68-0717-02DF-141D-E777529749B0}"/>
+          </ac:cxnSpMkLst>
+        </pc:cxnChg>
+        <pc:cxnChg chg="mod">
+          <ac:chgData name="Jose Luis Marin" userId="3f401816-0403-4e64-94bc-52b7ba2907f3" providerId="ADAL" clId="{605105EB-6CED-5A53-A41C-D9F7740771D7}" dt="2026-09-03T07:09:47.591" v="389" actId="1038"/>
+          <ac:cxnSpMkLst>
+            <pc:docMk/>
+            <pc:sldMk cId="4015711507" sldId="363"/>
+            <ac:cxnSpMk id="20" creationId="{2ADD77D0-4C72-CA7A-CE63-3E25C707286D}"/>
+          </ac:cxnSpMkLst>
+        </pc:cxnChg>
+        <pc:cxnChg chg="mod">
+          <ac:chgData name="Jose Luis Marin" userId="3f401816-0403-4e64-94bc-52b7ba2907f3" providerId="ADAL" clId="{605105EB-6CED-5A53-A41C-D9F7740771D7}" dt="2026-09-03T07:11:25.438" v="474" actId="1038"/>
+          <ac:cxnSpMkLst>
+            <pc:docMk/>
+            <pc:sldMk cId="4015711507" sldId="363"/>
+            <ac:cxnSpMk id="21" creationId="{B75B1BE9-6EBF-2C4E-70DC-EDF0BF2492E8}"/>
+          </ac:cxnSpMkLst>
+        </pc:cxnChg>
+        <pc:cxnChg chg="mod">
+          <ac:chgData name="Jose Luis Marin" userId="3f401816-0403-4e64-94bc-52b7ba2907f3" providerId="ADAL" clId="{605105EB-6CED-5A53-A41C-D9F7740771D7}" dt="2026-09-03T07:08:58.989" v="300" actId="1037"/>
+          <ac:cxnSpMkLst>
+            <pc:docMk/>
+            <pc:sldMk cId="4015711507" sldId="363"/>
+            <ac:cxnSpMk id="27" creationId="{23534018-F583-3698-7F8D-59C99DD6836C}"/>
+          </ac:cxnSpMkLst>
+        </pc:cxnChg>
+        <pc:cxnChg chg="mod">
+          <ac:chgData name="Jose Luis Marin" userId="3f401816-0403-4e64-94bc-52b7ba2907f3" providerId="ADAL" clId="{605105EB-6CED-5A53-A41C-D9F7740771D7}" dt="2026-09-03T07:10:09.098" v="391" actId="14100"/>
+          <ac:cxnSpMkLst>
+            <pc:docMk/>
+            <pc:sldMk cId="4015711507" sldId="363"/>
+            <ac:cxnSpMk id="35" creationId="{F49A5611-A906-DFBB-C84C-8BF7B0D2C5ED}"/>
+          </ac:cxnSpMkLst>
+        </pc:cxnChg>
+      </pc:sldChg>
+      <pc:sldChg chg="delSp modSp mod">
+        <pc:chgData name="Jose Luis Marin" userId="3f401816-0403-4e64-94bc-52b7ba2907f3" providerId="ADAL" clId="{605105EB-6CED-5A53-A41C-D9F7740771D7}" dt="2026-09-03T07:15:29.312" v="1141" actId="1037"/>
+        <pc:sldMkLst>
+          <pc:docMk/>
+          <pc:sldMk cId="542481487" sldId="364"/>
+        </pc:sldMkLst>
+        <pc:spChg chg="mod">
+          <ac:chgData name="Jose Luis Marin" userId="3f401816-0403-4e64-94bc-52b7ba2907f3" providerId="ADAL" clId="{605105EB-6CED-5A53-A41C-D9F7740771D7}" dt="2026-09-03T07:14:36.783" v="905" actId="1035"/>
+          <ac:spMkLst>
+            <pc:docMk/>
+            <pc:sldMk cId="542481487" sldId="364"/>
+            <ac:spMk id="18" creationId="{DC26748F-CB1F-CFFD-C1AB-A740CF691A73}"/>
+          </ac:spMkLst>
+        </pc:spChg>
+        <pc:spChg chg="mod">
+          <ac:chgData name="Jose Luis Marin" userId="3f401816-0403-4e64-94bc-52b7ba2907f3" providerId="ADAL" clId="{605105EB-6CED-5A53-A41C-D9F7740771D7}" dt="2026-09-03T07:15:17.434" v="1110" actId="1037"/>
+          <ac:spMkLst>
+            <pc:docMk/>
+            <pc:sldMk cId="542481487" sldId="364"/>
+            <ac:spMk id="22" creationId="{FA1F6BEF-3E16-24A5-D9F6-67D59411D645}"/>
+          </ac:spMkLst>
+        </pc:spChg>
+        <pc:spChg chg="mod">
+          <ac:chgData name="Jose Luis Marin" userId="3f401816-0403-4e64-94bc-52b7ba2907f3" providerId="ADAL" clId="{605105EB-6CED-5A53-A41C-D9F7740771D7}" dt="2026-09-03T07:14:36.783" v="905" actId="1035"/>
+          <ac:spMkLst>
+            <pc:docMk/>
+            <pc:sldMk cId="542481487" sldId="364"/>
+            <ac:spMk id="23" creationId="{F5D7EA7C-0477-E7CF-AD1B-19CFABC78EC3}"/>
+          </ac:spMkLst>
+        </pc:spChg>
+        <pc:spChg chg="mod">
+          <ac:chgData name="Jose Luis Marin" userId="3f401816-0403-4e64-94bc-52b7ba2907f3" providerId="ADAL" clId="{605105EB-6CED-5A53-A41C-D9F7740771D7}" dt="2026-09-03T07:14:36.783" v="905" actId="1035"/>
+          <ac:spMkLst>
+            <pc:docMk/>
+            <pc:sldMk cId="542481487" sldId="364"/>
+            <ac:spMk id="24" creationId="{AC34A577-8001-3DCD-2B76-EECF560CCD8A}"/>
+          </ac:spMkLst>
+        </pc:spChg>
+        <pc:spChg chg="mod">
+          <ac:chgData name="Jose Luis Marin" userId="3f401816-0403-4e64-94bc-52b7ba2907f3" providerId="ADAL" clId="{605105EB-6CED-5A53-A41C-D9F7740771D7}" dt="2026-09-03T07:14:36.783" v="905" actId="1035"/>
+          <ac:spMkLst>
+            <pc:docMk/>
+            <pc:sldMk cId="542481487" sldId="364"/>
+            <ac:spMk id="41" creationId="{3CD1C120-C9E1-12CE-1B52-6278B80CB1CC}"/>
+          </ac:spMkLst>
+        </pc:spChg>
+        <pc:spChg chg="del">
+          <ac:chgData name="Jose Luis Marin" userId="3f401816-0403-4e64-94bc-52b7ba2907f3" providerId="ADAL" clId="{605105EB-6CED-5A53-A41C-D9F7740771D7}" dt="2026-09-03T07:12:18.454" v="482" actId="478"/>
+          <ac:spMkLst>
+            <pc:docMk/>
+            <pc:sldMk cId="542481487" sldId="364"/>
+            <ac:spMk id="42" creationId="{7FDEC4E5-6E8B-D7E1-46A8-A6CEFA44E559}"/>
+          </ac:spMkLst>
+        </pc:spChg>
+        <pc:spChg chg="del">
+          <ac:chgData name="Jose Luis Marin" userId="3f401816-0403-4e64-94bc-52b7ba2907f3" providerId="ADAL" clId="{605105EB-6CED-5A53-A41C-D9F7740771D7}" dt="2026-09-03T07:12:21.212" v="483" actId="478"/>
+          <ac:spMkLst>
+            <pc:docMk/>
+            <pc:sldMk cId="542481487" sldId="364"/>
+            <ac:spMk id="54" creationId="{35C9B755-BB1D-842D-8BB3-EAAA42450BE7}"/>
+          </ac:spMkLst>
+        </pc:spChg>
+        <pc:spChg chg="del">
+          <ac:chgData name="Jose Luis Marin" userId="3f401816-0403-4e64-94bc-52b7ba2907f3" providerId="ADAL" clId="{605105EB-6CED-5A53-A41C-D9F7740771D7}" dt="2026-09-03T07:12:24.722" v="484" actId="478"/>
+          <ac:spMkLst>
+            <pc:docMk/>
+            <pc:sldMk cId="542481487" sldId="364"/>
+            <ac:spMk id="55" creationId="{35C5F12A-3A49-3798-7461-FA154758289F}"/>
+          </ac:spMkLst>
+        </pc:spChg>
+        <pc:spChg chg="mod">
+          <ac:chgData name="Jose Luis Marin" userId="3f401816-0403-4e64-94bc-52b7ba2907f3" providerId="ADAL" clId="{605105EB-6CED-5A53-A41C-D9F7740771D7}" dt="2026-09-03T07:14:44.228" v="963" actId="1035"/>
+          <ac:spMkLst>
+            <pc:docMk/>
+            <pc:sldMk cId="542481487" sldId="364"/>
+            <ac:spMk id="56" creationId="{1AF488C7-92FE-42BE-6F06-022AFA710FF7}"/>
+          </ac:spMkLst>
+        </pc:spChg>
+        <pc:spChg chg="mod">
+          <ac:chgData name="Jose Luis Marin" userId="3f401816-0403-4e64-94bc-52b7ba2907f3" providerId="ADAL" clId="{605105EB-6CED-5A53-A41C-D9F7740771D7}" dt="2026-09-03T07:15:29.312" v="1141" actId="1037"/>
+          <ac:spMkLst>
+            <pc:docMk/>
+            <pc:sldMk cId="542481487" sldId="364"/>
+            <ac:spMk id="57" creationId="{696115E3-A82D-3F1D-70B6-12C377B2D343}"/>
+          </ac:spMkLst>
+        </pc:spChg>
+        <pc:grpChg chg="mod">
+          <ac:chgData name="Jose Luis Marin" userId="3f401816-0403-4e64-94bc-52b7ba2907f3" providerId="ADAL" clId="{605105EB-6CED-5A53-A41C-D9F7740771D7}" dt="2026-09-03T07:12:33.994" v="511" actId="1037"/>
+          <ac:grpSpMkLst>
+            <pc:docMk/>
+            <pc:sldMk cId="542481487" sldId="364"/>
+            <ac:grpSpMk id="46" creationId="{14BF57A4-B53E-D857-2E31-34CC7A8FD1F1}"/>
+          </ac:grpSpMkLst>
+        </pc:grpChg>
+        <pc:grpChg chg="del">
+          <ac:chgData name="Jose Luis Marin" userId="3f401816-0403-4e64-94bc-52b7ba2907f3" providerId="ADAL" clId="{605105EB-6CED-5A53-A41C-D9F7740771D7}" dt="2026-09-03T07:12:13.786" v="480" actId="478"/>
+          <ac:grpSpMkLst>
+            <pc:docMk/>
+            <pc:sldMk cId="542481487" sldId="364"/>
+            <ac:grpSpMk id="48" creationId="{5611D643-9A9F-7961-7F2E-5EF5D943F2B0}"/>
+          </ac:grpSpMkLst>
+        </pc:grpChg>
+        <pc:grpChg chg="del">
+          <ac:chgData name="Jose Luis Marin" userId="3f401816-0403-4e64-94bc-52b7ba2907f3" providerId="ADAL" clId="{605105EB-6CED-5A53-A41C-D9F7740771D7}" dt="2026-09-03T07:12:16.097" v="481" actId="478"/>
+          <ac:grpSpMkLst>
+            <pc:docMk/>
+            <pc:sldMk cId="542481487" sldId="364"/>
+            <ac:grpSpMk id="49" creationId="{19C4C2C6-D57B-C860-BEAE-28AE57659C3A}"/>
+          </ac:grpSpMkLst>
+        </pc:grpChg>
+        <pc:grpChg chg="del">
+          <ac:chgData name="Jose Luis Marin" userId="3f401816-0403-4e64-94bc-52b7ba2907f3" providerId="ADAL" clId="{605105EB-6CED-5A53-A41C-D9F7740771D7}" dt="2026-09-03T07:12:26.582" v="485" actId="478"/>
+          <ac:grpSpMkLst>
+            <pc:docMk/>
+            <pc:sldMk cId="542481487" sldId="364"/>
+            <ac:grpSpMk id="50" creationId="{7FC0A988-4416-7349-762E-07019326C893}"/>
+          </ac:grpSpMkLst>
+        </pc:grpChg>
+        <pc:grpChg chg="mod">
+          <ac:chgData name="Jose Luis Marin" userId="3f401816-0403-4e64-94bc-52b7ba2907f3" providerId="ADAL" clId="{605105EB-6CED-5A53-A41C-D9F7740771D7}" dt="2026-09-03T07:14:59.632" v="1049" actId="1037"/>
+          <ac:grpSpMkLst>
+            <pc:docMk/>
+            <pc:sldMk cId="542481487" sldId="364"/>
+            <ac:grpSpMk id="51" creationId="{E6F85B55-BB45-3F0E-6626-CB99F87AB6B0}"/>
+          </ac:grpSpMkLst>
+        </pc:grpChg>
+        <pc:cxnChg chg="del">
+          <ac:chgData name="Jose Luis Marin" userId="3f401816-0403-4e64-94bc-52b7ba2907f3" providerId="ADAL" clId="{605105EB-6CED-5A53-A41C-D9F7740771D7}" dt="2026-09-03T07:12:37.607" v="512" actId="478"/>
+          <ac:cxnSpMkLst>
+            <pc:docMk/>
+            <pc:sldMk cId="542481487" sldId="364"/>
+            <ac:cxnSpMk id="13" creationId="{ADA46642-9A30-F44B-F1EA-08E38FC1F970}"/>
+          </ac:cxnSpMkLst>
+        </pc:cxnChg>
+        <pc:cxnChg chg="mod">
+          <ac:chgData name="Jose Luis Marin" userId="3f401816-0403-4e64-94bc-52b7ba2907f3" providerId="ADAL" clId="{605105EB-6CED-5A53-A41C-D9F7740771D7}" dt="2026-09-03T07:14:36.783" v="905" actId="1035"/>
+          <ac:cxnSpMkLst>
+            <pc:docMk/>
+            <pc:sldMk cId="542481487" sldId="364"/>
+            <ac:cxnSpMk id="17" creationId="{41C3C4FC-B0C0-A82C-D605-860CAB617B00}"/>
+          </ac:cxnSpMkLst>
+        </pc:cxnChg>
+        <pc:cxnChg chg="mod">
+          <ac:chgData name="Jose Luis Marin" userId="3f401816-0403-4e64-94bc-52b7ba2907f3" providerId="ADAL" clId="{605105EB-6CED-5A53-A41C-D9F7740771D7}" dt="2026-09-03T07:14:36.783" v="905" actId="1035"/>
+          <ac:cxnSpMkLst>
+            <pc:docMk/>
+            <pc:sldMk cId="542481487" sldId="364"/>
+            <ac:cxnSpMk id="20" creationId="{2ADD77D0-4C72-CA7A-CE63-3E25C707286D}"/>
+          </ac:cxnSpMkLst>
+        </pc:cxnChg>
+        <pc:cxnChg chg="mod">
+          <ac:chgData name="Jose Luis Marin" userId="3f401816-0403-4e64-94bc-52b7ba2907f3" providerId="ADAL" clId="{605105EB-6CED-5A53-A41C-D9F7740771D7}" dt="2026-09-03T07:15:17.434" v="1110" actId="1037"/>
+          <ac:cxnSpMkLst>
+            <pc:docMk/>
+            <pc:sldMk cId="542481487" sldId="364"/>
+            <ac:cxnSpMk id="21" creationId="{B75B1BE9-6EBF-2C4E-70DC-EDF0BF2492E8}"/>
+          </ac:cxnSpMkLst>
+        </pc:cxnChg>
+        <pc:cxnChg chg="del">
+          <ac:chgData name="Jose Luis Marin" userId="3f401816-0403-4e64-94bc-52b7ba2907f3" providerId="ADAL" clId="{605105EB-6CED-5A53-A41C-D9F7740771D7}" dt="2026-09-03T07:12:39.662" v="513" actId="478"/>
+          <ac:cxnSpMkLst>
+            <pc:docMk/>
+            <pc:sldMk cId="542481487" sldId="364"/>
+            <ac:cxnSpMk id="31" creationId="{017A04F5-169E-5B9A-1345-F6D0C6E3FA03}"/>
+          </ac:cxnSpMkLst>
+        </pc:cxnChg>
+        <pc:cxnChg chg="del">
+          <ac:chgData name="Jose Luis Marin" userId="3f401816-0403-4e64-94bc-52b7ba2907f3" providerId="ADAL" clId="{605105EB-6CED-5A53-A41C-D9F7740771D7}" dt="2026-09-03T07:12:41.911" v="514" actId="478"/>
+          <ac:cxnSpMkLst>
+            <pc:docMk/>
+            <pc:sldMk cId="542481487" sldId="364"/>
+            <ac:cxnSpMk id="38" creationId="{3665E9F0-701C-A024-D1A2-2C9197804D42}"/>
+          </ac:cxnSpMkLst>
+        </pc:cxnChg>
+        <pc:cxnChg chg="mod">
+          <ac:chgData name="Jose Luis Marin" userId="3f401816-0403-4e64-94bc-52b7ba2907f3" providerId="ADAL" clId="{605105EB-6CED-5A53-A41C-D9F7740771D7}" dt="2026-09-03T07:15:07.878" v="1082" actId="1037"/>
+          <ac:cxnSpMkLst>
+            <pc:docMk/>
+            <pc:sldMk cId="542481487" sldId="364"/>
+            <ac:cxnSpMk id="47" creationId="{FE3E788F-64F9-08F6-5585-0301D1331E41}"/>
+          </ac:cxnSpMkLst>
+        </pc:cxnChg>
+        <pc:cxnChg chg="mod">
+          <ac:chgData name="Jose Luis Marin" userId="3f401816-0403-4e64-94bc-52b7ba2907f3" providerId="ADAL" clId="{605105EB-6CED-5A53-A41C-D9F7740771D7}" dt="2026-09-03T07:15:29.312" v="1141" actId="1037"/>
+          <ac:cxnSpMkLst>
+            <pc:docMk/>
+            <pc:sldMk cId="542481487" sldId="364"/>
+            <ac:cxnSpMk id="58" creationId="{D1CE5EC3-7AF5-9AD5-D79E-1E96A13C330C}"/>
+          </ac:cxnSpMkLst>
+        </pc:cxnChg>
+      </pc:sldChg>
+      <pc:sldChg chg="addSp modSp mod">
+        <pc:chgData name="Jose Luis Marin" userId="3f401816-0403-4e64-94bc-52b7ba2907f3" providerId="ADAL" clId="{605105EB-6CED-5A53-A41C-D9F7740771D7}" dt="2026-09-03T07:26:23.755" v="1412" actId="20577"/>
+        <pc:sldMkLst>
+          <pc:docMk/>
+          <pc:sldMk cId="3153295643" sldId="370"/>
+        </pc:sldMkLst>
+        <pc:spChg chg="add mod">
+          <ac:chgData name="Jose Luis Marin" userId="3f401816-0403-4e64-94bc-52b7ba2907f3" providerId="ADAL" clId="{605105EB-6CED-5A53-A41C-D9F7740771D7}" dt="2026-09-03T07:23:17.701" v="1216" actId="1038"/>
+          <ac:spMkLst>
+            <pc:docMk/>
+            <pc:sldMk cId="3153295643" sldId="370"/>
+            <ac:spMk id="4" creationId="{72164238-ACB0-2D6E-CCB7-5175C24FD596}"/>
+          </ac:spMkLst>
+        </pc:spChg>
+        <pc:spChg chg="mod">
+          <ac:chgData name="Jose Luis Marin" userId="3f401816-0403-4e64-94bc-52b7ba2907f3" providerId="ADAL" clId="{605105EB-6CED-5A53-A41C-D9F7740771D7}" dt="2026-09-03T07:23:28.369" v="1241" actId="1036"/>
+          <ac:spMkLst>
+            <pc:docMk/>
+            <pc:sldMk cId="3153295643" sldId="370"/>
+            <ac:spMk id="5" creationId="{DB50D947-A822-EDDD-942E-9F53E3E6D947}"/>
+          </ac:spMkLst>
+        </pc:spChg>
+        <pc:spChg chg="add mod">
+          <ac:chgData name="Jose Luis Marin" userId="3f401816-0403-4e64-94bc-52b7ba2907f3" providerId="ADAL" clId="{605105EB-6CED-5A53-A41C-D9F7740771D7}" dt="2026-09-03T07:25:40.515" v="1396" actId="20577"/>
+          <ac:spMkLst>
+            <pc:docMk/>
+            <pc:sldMk cId="3153295643" sldId="370"/>
+            <ac:spMk id="7" creationId="{2B007961-4749-A060-A217-5FBD03C0099A}"/>
+          </ac:spMkLst>
+        </pc:spChg>
+        <pc:spChg chg="mod">
+          <ac:chgData name="Jose Luis Marin" userId="3f401816-0403-4e64-94bc-52b7ba2907f3" providerId="ADAL" clId="{605105EB-6CED-5A53-A41C-D9F7740771D7}" dt="2026-09-03T07:26:23.755" v="1412" actId="20577"/>
+          <ac:spMkLst>
+            <pc:docMk/>
+            <pc:sldMk cId="3153295643" sldId="370"/>
+            <ac:spMk id="22" creationId="{FA1F6BEF-3E16-24A5-D9F6-67D59411D645}"/>
+          </ac:spMkLst>
+        </pc:spChg>
+      </pc:sldChg>
+    </pc:docChg>
+  </pc:docChgLst>
+  <pc:docChgLst>
+    <pc:chgData name="Marcos De Miguel Cruz" userId="dff9766d-3fe8-4659-a0c1-e1b87a709fe4" providerId="ADAL" clId="{5BEB56D2-D1BE-4B43-B384-DED89CB6F23D}"/>
+    <pc:docChg chg="undo custSel modSld">
+      <pc:chgData name="Marcos De Miguel Cruz" userId="dff9766d-3fe8-4659-a0c1-e1b87a709fe4" providerId="ADAL" clId="{5BEB56D2-D1BE-4B43-B384-DED89CB6F23D}" dt="2026-09-03T08:01:19.030" v="1046" actId="1076"/>
+      <pc:docMkLst>
+        <pc:docMk/>
+      </pc:docMkLst>
+      <pc:sldChg chg="modSp mod">
+        <pc:chgData name="Marcos De Miguel Cruz" userId="dff9766d-3fe8-4659-a0c1-e1b87a709fe4" providerId="ADAL" clId="{5BEB56D2-D1BE-4B43-B384-DED89CB6F23D}" dt="2026-09-03T08:01:19.030" v="1046" actId="1076"/>
+        <pc:sldMkLst>
+          <pc:docMk/>
+          <pc:sldMk cId="4015711507" sldId="363"/>
+        </pc:sldMkLst>
+        <pc:spChg chg="mod">
+          <ac:chgData name="Marcos De Miguel Cruz" userId="dff9766d-3fe8-4659-a0c1-e1b87a709fe4" providerId="ADAL" clId="{5BEB56D2-D1BE-4B43-B384-DED89CB6F23D}" dt="2026-09-03T08:00:50.640" v="980" actId="1076"/>
+          <ac:spMkLst>
+            <pc:docMk/>
+            <pc:sldMk cId="4015711507" sldId="363"/>
+            <ac:spMk id="2" creationId="{C0BFBD65-1FD1-9D4A-E9E9-301DCFD0643A}"/>
+          </ac:spMkLst>
+        </pc:spChg>
+        <pc:spChg chg="mod">
+          <ac:chgData name="Marcos De Miguel Cruz" userId="dff9766d-3fe8-4659-a0c1-e1b87a709fe4" providerId="ADAL" clId="{5BEB56D2-D1BE-4B43-B384-DED89CB6F23D}" dt="2026-09-03T08:01:19.030" v="1046" actId="1076"/>
+          <ac:spMkLst>
+            <pc:docMk/>
+            <pc:sldMk cId="4015711507" sldId="363"/>
+            <ac:spMk id="28" creationId="{A933839B-E2F0-2767-867C-C3D21571B116}"/>
+          </ac:spMkLst>
+        </pc:spChg>
+        <pc:spChg chg="mod">
+          <ac:chgData name="Marcos De Miguel Cruz" userId="dff9766d-3fe8-4659-a0c1-e1b87a709fe4" providerId="ADAL" clId="{5BEB56D2-D1BE-4B43-B384-DED89CB6F23D}" dt="2026-09-03T08:01:14.134" v="1045" actId="1076"/>
+          <ac:spMkLst>
+            <pc:docMk/>
+            <pc:sldMk cId="4015711507" sldId="363"/>
+            <ac:spMk id="30" creationId="{7EEFCEAF-DBA9-D087-A1D1-D50925979DBF}"/>
+          </ac:spMkLst>
+        </pc:spChg>
+        <pc:spChg chg="mod">
+          <ac:chgData name="Marcos De Miguel Cruz" userId="dff9766d-3fe8-4659-a0c1-e1b87a709fe4" providerId="ADAL" clId="{5BEB56D2-D1BE-4B43-B384-DED89CB6F23D}" dt="2026-09-03T08:01:01.690" v="1031" actId="1037"/>
+          <ac:spMkLst>
+            <pc:docMk/>
+            <pc:sldMk cId="4015711507" sldId="363"/>
+            <ac:spMk id="31" creationId="{703BC30B-617F-EE1A-1C3C-874678D542F1}"/>
+          </ac:spMkLst>
+        </pc:spChg>
+        <pc:spChg chg="mod">
+          <ac:chgData name="Marcos De Miguel Cruz" userId="dff9766d-3fe8-4659-a0c1-e1b87a709fe4" providerId="ADAL" clId="{5BEB56D2-D1BE-4B43-B384-DED89CB6F23D}" dt="2026-09-03T08:01:06.686" v="1044" actId="1038"/>
+          <ac:spMkLst>
+            <pc:docMk/>
+            <pc:sldMk cId="4015711507" sldId="363"/>
+            <ac:spMk id="32" creationId="{C12B3264-F350-D42A-8718-D3FB967B495A}"/>
+          </ac:spMkLst>
+        </pc:spChg>
+      </pc:sldChg>
+      <pc:sldChg chg="modSp mod">
+        <pc:chgData name="Marcos De Miguel Cruz" userId="dff9766d-3fe8-4659-a0c1-e1b87a709fe4" providerId="ADAL" clId="{5BEB56D2-D1BE-4B43-B384-DED89CB6F23D}" dt="2026-09-03T08:00:29.615" v="955" actId="1037"/>
+        <pc:sldMkLst>
+          <pc:docMk/>
+          <pc:sldMk cId="542481487" sldId="364"/>
+        </pc:sldMkLst>
+        <pc:spChg chg="mod">
+          <ac:chgData name="Marcos De Miguel Cruz" userId="dff9766d-3fe8-4659-a0c1-e1b87a709fe4" providerId="ADAL" clId="{5BEB56D2-D1BE-4B43-B384-DED89CB6F23D}" dt="2026-09-03T08:00:06.391" v="879" actId="1035"/>
+          <ac:spMkLst>
+            <pc:docMk/>
+            <pc:sldMk cId="542481487" sldId="364"/>
+            <ac:spMk id="22" creationId="{FA1F6BEF-3E16-24A5-D9F6-67D59411D645}"/>
+          </ac:spMkLst>
+        </pc:spChg>
+        <pc:spChg chg="mod">
+          <ac:chgData name="Marcos De Miguel Cruz" userId="dff9766d-3fe8-4659-a0c1-e1b87a709fe4" providerId="ADAL" clId="{5BEB56D2-D1BE-4B43-B384-DED89CB6F23D}" dt="2026-09-03T08:00:29.615" v="955" actId="1037"/>
+          <ac:spMkLst>
+            <pc:docMk/>
+            <pc:sldMk cId="542481487" sldId="364"/>
+            <ac:spMk id="41" creationId="{3CD1C120-C9E1-12CE-1B52-6278B80CB1CC}"/>
+          </ac:spMkLst>
+        </pc:spChg>
+        <pc:spChg chg="mod">
+          <ac:chgData name="Marcos De Miguel Cruz" userId="dff9766d-3fe8-4659-a0c1-e1b87a709fe4" providerId="ADAL" clId="{5BEB56D2-D1BE-4B43-B384-DED89CB6F23D}" dt="2026-09-03T08:00:16.333" v="934" actId="1038"/>
+          <ac:spMkLst>
+            <pc:docMk/>
+            <pc:sldMk cId="542481487" sldId="364"/>
+            <ac:spMk id="56" creationId="{1AF488C7-92FE-42BE-6F06-022AFA710FF7}"/>
+          </ac:spMkLst>
+        </pc:spChg>
+      </pc:sldChg>
+      <pc:sldChg chg="addSp delSp modSp mod">
+        <pc:chgData name="Marcos De Miguel Cruz" userId="dff9766d-3fe8-4659-a0c1-e1b87a709fe4" providerId="ADAL" clId="{5BEB56D2-D1BE-4B43-B384-DED89CB6F23D}" dt="2026-09-03T08:00:38.270" v="978" actId="1036"/>
+        <pc:sldMkLst>
+          <pc:docMk/>
+          <pc:sldMk cId="1841050961" sldId="365"/>
+        </pc:sldMkLst>
+        <pc:spChg chg="mod">
+          <ac:chgData name="Marcos De Miguel Cruz" userId="dff9766d-3fe8-4659-a0c1-e1b87a709fe4" providerId="ADAL" clId="{5BEB56D2-D1BE-4B43-B384-DED89CB6F23D}" dt="2026-09-03T07:59:48.671" v="848" actId="1037"/>
+          <ac:spMkLst>
+            <pc:docMk/>
+            <pc:sldMk cId="1841050961" sldId="365"/>
+            <ac:spMk id="16" creationId="{A4C15E64-AFCA-46CD-43FA-7FF1E55B8198}"/>
+          </ac:spMkLst>
+        </pc:spChg>
+        <pc:spChg chg="mod">
+          <ac:chgData name="Marcos De Miguel Cruz" userId="dff9766d-3fe8-4659-a0c1-e1b87a709fe4" providerId="ADAL" clId="{5BEB56D2-D1BE-4B43-B384-DED89CB6F23D}" dt="2026-09-03T07:57:35.183" v="404" actId="1036"/>
+          <ac:spMkLst>
+            <pc:docMk/>
+            <pc:sldMk cId="1841050961" sldId="365"/>
+            <ac:spMk id="18" creationId="{DC26748F-CB1F-CFFD-C1AB-A740CF691A73}"/>
+          </ac:spMkLst>
+        </pc:spChg>
+        <pc:spChg chg="mod">
+          <ac:chgData name="Marcos De Miguel Cruz" userId="dff9766d-3fe8-4659-a0c1-e1b87a709fe4" providerId="ADAL" clId="{5BEB56D2-D1BE-4B43-B384-DED89CB6F23D}" dt="2026-09-03T07:58:05.854" v="578" actId="1035"/>
+          <ac:spMkLst>
+            <pc:docMk/>
+            <pc:sldMk cId="1841050961" sldId="365"/>
+            <ac:spMk id="22" creationId="{FA1F6BEF-3E16-24A5-D9F6-67D59411D645}"/>
+          </ac:spMkLst>
+        </pc:spChg>
+        <pc:spChg chg="mod">
+          <ac:chgData name="Marcos De Miguel Cruz" userId="dff9766d-3fe8-4659-a0c1-e1b87a709fe4" providerId="ADAL" clId="{5BEB56D2-D1BE-4B43-B384-DED89CB6F23D}" dt="2026-09-03T07:57:35.183" v="404" actId="1036"/>
+          <ac:spMkLst>
+            <pc:docMk/>
+            <pc:sldMk cId="1841050961" sldId="365"/>
+            <ac:spMk id="23" creationId="{F5D7EA7C-0477-E7CF-AD1B-19CFABC78EC3}"/>
+          </ac:spMkLst>
+        </pc:spChg>
+        <pc:spChg chg="mod">
+          <ac:chgData name="Marcos De Miguel Cruz" userId="dff9766d-3fe8-4659-a0c1-e1b87a709fe4" providerId="ADAL" clId="{5BEB56D2-D1BE-4B43-B384-DED89CB6F23D}" dt="2026-09-03T07:57:35.183" v="404" actId="1036"/>
+          <ac:spMkLst>
+            <pc:docMk/>
+            <pc:sldMk cId="1841050961" sldId="365"/>
+            <ac:spMk id="24" creationId="{AC34A577-8001-3DCD-2B76-EECF560CCD8A}"/>
+          </ac:spMkLst>
+        </pc:spChg>
+        <pc:spChg chg="mod">
+          <ac:chgData name="Marcos De Miguel Cruz" userId="dff9766d-3fe8-4659-a0c1-e1b87a709fe4" providerId="ADAL" clId="{5BEB56D2-D1BE-4B43-B384-DED89CB6F23D}" dt="2026-09-03T07:59:34.017" v="834" actId="1037"/>
+          <ac:spMkLst>
+            <pc:docMk/>
+            <pc:sldMk cId="1841050961" sldId="365"/>
+            <ac:spMk id="39" creationId="{DE5F4CF6-3242-9BD5-7691-62DCA31FCCA3}"/>
+          </ac:spMkLst>
+        </pc:spChg>
+        <pc:spChg chg="del">
+          <ac:chgData name="Marcos De Miguel Cruz" userId="dff9766d-3fe8-4659-a0c1-e1b87a709fe4" providerId="ADAL" clId="{5BEB56D2-D1BE-4B43-B384-DED89CB6F23D}" dt="2026-09-03T07:55:28.582" v="0" actId="478"/>
+          <ac:spMkLst>
+            <pc:docMk/>
+            <pc:sldMk cId="1841050961" sldId="365"/>
+            <ac:spMk id="59" creationId="{EC94A037-C994-A096-E237-EB814A33DF6F}"/>
+          </ac:spMkLst>
+        </pc:spChg>
+        <pc:spChg chg="del">
+          <ac:chgData name="Marcos De Miguel Cruz" userId="dff9766d-3fe8-4659-a0c1-e1b87a709fe4" providerId="ADAL" clId="{5BEB56D2-D1BE-4B43-B384-DED89CB6F23D}" dt="2026-09-03T07:55:28.582" v="0" actId="478"/>
+          <ac:spMkLst>
+            <pc:docMk/>
+            <pc:sldMk cId="1841050961" sldId="365"/>
+            <ac:spMk id="60" creationId="{60223174-51C6-9B7C-D62F-A5F0BBA4D0F1}"/>
+          </ac:spMkLst>
+        </pc:spChg>
+        <pc:spChg chg="del">
+          <ac:chgData name="Marcos De Miguel Cruz" userId="dff9766d-3fe8-4659-a0c1-e1b87a709fe4" providerId="ADAL" clId="{5BEB56D2-D1BE-4B43-B384-DED89CB6F23D}" dt="2026-09-03T07:55:28.582" v="0" actId="478"/>
+          <ac:spMkLst>
+            <pc:docMk/>
+            <pc:sldMk cId="1841050961" sldId="365"/>
+            <ac:spMk id="61" creationId="{9399F66E-FCE6-683D-3719-50C3D1FB5941}"/>
+          </ac:spMkLst>
+        </pc:spChg>
+        <pc:spChg chg="mod">
+          <ac:chgData name="Marcos De Miguel Cruz" userId="dff9766d-3fe8-4659-a0c1-e1b87a709fe4" providerId="ADAL" clId="{5BEB56D2-D1BE-4B43-B384-DED89CB6F23D}" dt="2026-09-03T07:57:56.792" v="542" actId="1038"/>
+          <ac:spMkLst>
+            <pc:docMk/>
+            <pc:sldMk cId="1841050961" sldId="365"/>
+            <ac:spMk id="62" creationId="{F22DD016-C797-0772-4590-E4455B7D7549}"/>
+          </ac:spMkLst>
+        </pc:spChg>
+        <pc:spChg chg="mod">
+          <ac:chgData name="Marcos De Miguel Cruz" userId="dff9766d-3fe8-4659-a0c1-e1b87a709fe4" providerId="ADAL" clId="{5BEB56D2-D1BE-4B43-B384-DED89CB6F23D}" dt="2026-09-03T08:00:38.270" v="978" actId="1036"/>
+          <ac:spMkLst>
+            <pc:docMk/>
+            <pc:sldMk cId="1841050961" sldId="365"/>
+            <ac:spMk id="63" creationId="{A79D912E-2451-A5C3-CB8C-87E292DBDA71}"/>
+          </ac:spMkLst>
+        </pc:spChg>
+        <pc:spChg chg="mod">
+          <ac:chgData name="Marcos De Miguel Cruz" userId="dff9766d-3fe8-4659-a0c1-e1b87a709fe4" providerId="ADAL" clId="{5BEB56D2-D1BE-4B43-B384-DED89CB6F23D}" dt="2026-09-03T07:59:34.017" v="834" actId="1037"/>
+          <ac:spMkLst>
+            <pc:docMk/>
+            <pc:sldMk cId="1841050961" sldId="365"/>
+            <ac:spMk id="65" creationId="{05F25109-BABC-A9B3-3E0D-AA7C8986B5E1}"/>
+          </ac:spMkLst>
+        </pc:spChg>
+        <pc:spChg chg="mod">
+          <ac:chgData name="Marcos De Miguel Cruz" userId="dff9766d-3fe8-4659-a0c1-e1b87a709fe4" providerId="ADAL" clId="{5BEB56D2-D1BE-4B43-B384-DED89CB6F23D}" dt="2026-09-03T07:59:34.017" v="834" actId="1037"/>
+          <ac:spMkLst>
+            <pc:docMk/>
+            <pc:sldMk cId="1841050961" sldId="365"/>
+            <ac:spMk id="66" creationId="{2E1DBECE-5BBC-1C88-FBD1-6D85892AFE1C}"/>
+          </ac:spMkLst>
+        </pc:spChg>
+        <pc:spChg chg="mod">
+          <ac:chgData name="Marcos De Miguel Cruz" userId="dff9766d-3fe8-4659-a0c1-e1b87a709fe4" providerId="ADAL" clId="{5BEB56D2-D1BE-4B43-B384-DED89CB6F23D}" dt="2026-09-03T07:56:16.081" v="152" actId="1037"/>
+          <ac:spMkLst>
+            <pc:docMk/>
+            <pc:sldMk cId="1841050961" sldId="365"/>
+            <ac:spMk id="69" creationId="{6E8898E3-5F90-25DF-9334-192843161C70}"/>
+          </ac:spMkLst>
+        </pc:spChg>
+        <pc:grpChg chg="mod">
+          <ac:chgData name="Marcos De Miguel Cruz" userId="dff9766d-3fe8-4659-a0c1-e1b87a709fe4" providerId="ADAL" clId="{5BEB56D2-D1BE-4B43-B384-DED89CB6F23D}" dt="2026-09-03T07:59:34.017" v="834" actId="1037"/>
+          <ac:grpSpMkLst>
+            <pc:docMk/>
+            <pc:sldMk cId="1841050961" sldId="365"/>
+            <ac:grpSpMk id="5" creationId="{31A4DAAE-A838-C1FC-F11E-AA94F23D4227}"/>
+          </ac:grpSpMkLst>
+        </pc:grpChg>
+        <pc:grpChg chg="mod">
+          <ac:chgData name="Marcos De Miguel Cruz" userId="dff9766d-3fe8-4659-a0c1-e1b87a709fe4" providerId="ADAL" clId="{5BEB56D2-D1BE-4B43-B384-DED89CB6F23D}" dt="2026-09-03T07:56:01.088" v="81" actId="1038"/>
+          <ac:grpSpMkLst>
+            <pc:docMk/>
+            <pc:sldMk cId="1841050961" sldId="365"/>
+            <ac:grpSpMk id="46" creationId="{14BF57A4-B53E-D857-2E31-34CC7A8FD1F1}"/>
+          </ac:grpSpMkLst>
+        </pc:grpChg>
+        <pc:grpChg chg="del">
+          <ac:chgData name="Marcos De Miguel Cruz" userId="dff9766d-3fe8-4659-a0c1-e1b87a709fe4" providerId="ADAL" clId="{5BEB56D2-D1BE-4B43-B384-DED89CB6F23D}" dt="2026-09-03T07:55:28.582" v="0" actId="478"/>
+          <ac:grpSpMkLst>
+            <pc:docMk/>
+            <pc:sldMk cId="1841050961" sldId="365"/>
+            <ac:grpSpMk id="48" creationId="{5611D643-9A9F-7961-7F2E-5EF5D943F2B0}"/>
+          </ac:grpSpMkLst>
+        </pc:grpChg>
+        <pc:grpChg chg="del">
+          <ac:chgData name="Marcos De Miguel Cruz" userId="dff9766d-3fe8-4659-a0c1-e1b87a709fe4" providerId="ADAL" clId="{5BEB56D2-D1BE-4B43-B384-DED89CB6F23D}" dt="2026-09-03T07:55:28.582" v="0" actId="478"/>
+          <ac:grpSpMkLst>
+            <pc:docMk/>
+            <pc:sldMk cId="1841050961" sldId="365"/>
+            <ac:grpSpMk id="49" creationId="{19C4C2C6-D57B-C860-BEAE-28AE57659C3A}"/>
+          </ac:grpSpMkLst>
+        </pc:grpChg>
+        <pc:grpChg chg="del">
+          <ac:chgData name="Marcos De Miguel Cruz" userId="dff9766d-3fe8-4659-a0c1-e1b87a709fe4" providerId="ADAL" clId="{5BEB56D2-D1BE-4B43-B384-DED89CB6F23D}" dt="2026-09-03T07:55:28.582" v="0" actId="478"/>
+          <ac:grpSpMkLst>
+            <pc:docMk/>
+            <pc:sldMk cId="1841050961" sldId="365"/>
+            <ac:grpSpMk id="50" creationId="{7FC0A988-4416-7349-762E-07019326C893}"/>
+          </ac:grpSpMkLst>
+        </pc:grpChg>
+        <pc:grpChg chg="mod">
+          <ac:chgData name="Marcos De Miguel Cruz" userId="dff9766d-3fe8-4659-a0c1-e1b87a709fe4" providerId="ADAL" clId="{5BEB56D2-D1BE-4B43-B384-DED89CB6F23D}" dt="2026-09-03T07:57:35.183" v="404" actId="1036"/>
+          <ac:grpSpMkLst>
+            <pc:docMk/>
+            <pc:sldMk cId="1841050961" sldId="365"/>
+            <ac:grpSpMk id="51" creationId="{E6F85B55-BB45-3F0E-6626-CB99F87AB6B0}"/>
+          </ac:grpSpMkLst>
+        </pc:grpChg>
+        <pc:cxnChg chg="mod">
+          <ac:chgData name="Marcos De Miguel Cruz" userId="dff9766d-3fe8-4659-a0c1-e1b87a709fe4" providerId="ADAL" clId="{5BEB56D2-D1BE-4B43-B384-DED89CB6F23D}" dt="2026-09-03T07:59:40.337" v="835" actId="14100"/>
+          <ac:cxnSpMkLst>
+            <pc:docMk/>
+            <pc:sldMk cId="1841050961" sldId="365"/>
+            <ac:cxnSpMk id="3" creationId="{B895C55D-A6E5-7026-D3E9-C632F3E8A182}"/>
+          </ac:cxnSpMkLst>
+        </pc:cxnChg>
+        <pc:cxnChg chg="mod">
+          <ac:chgData name="Marcos De Miguel Cruz" userId="dff9766d-3fe8-4659-a0c1-e1b87a709fe4" providerId="ADAL" clId="{5BEB56D2-D1BE-4B43-B384-DED89CB6F23D}" dt="2026-09-03T07:59:34.017" v="834" actId="1037"/>
+          <ac:cxnSpMkLst>
+            <pc:docMk/>
+            <pc:sldMk cId="1841050961" sldId="365"/>
+            <ac:cxnSpMk id="4" creationId="{0BE003DD-962E-C2C1-E743-50D9A9C70259}"/>
+          </ac:cxnSpMkLst>
+        </pc:cxnChg>
+        <pc:cxnChg chg="del">
+          <ac:chgData name="Marcos De Miguel Cruz" userId="dff9766d-3fe8-4659-a0c1-e1b87a709fe4" providerId="ADAL" clId="{5BEB56D2-D1BE-4B43-B384-DED89CB6F23D}" dt="2026-09-03T07:55:28.582" v="0" actId="478"/>
+          <ac:cxnSpMkLst>
+            <pc:docMk/>
+            <pc:sldMk cId="1841050961" sldId="365"/>
+            <ac:cxnSpMk id="13" creationId="{ADA46642-9A30-F44B-F1EA-08E38FC1F970}"/>
+          </ac:cxnSpMkLst>
+        </pc:cxnChg>
+        <pc:cxnChg chg="mod">
+          <ac:chgData name="Marcos De Miguel Cruz" userId="dff9766d-3fe8-4659-a0c1-e1b87a709fe4" providerId="ADAL" clId="{5BEB56D2-D1BE-4B43-B384-DED89CB6F23D}" dt="2026-09-03T07:55:55.102" v="60" actId="1037"/>
+          <ac:cxnSpMkLst>
+            <pc:docMk/>
+            <pc:sldMk cId="1841050961" sldId="365"/>
+            <ac:cxnSpMk id="14" creationId="{FD62EF68-0717-02DF-141D-E777529749B0}"/>
+          </ac:cxnSpMkLst>
+        </pc:cxnChg>
+        <pc:cxnChg chg="del mod">
+          <ac:chgData name="Marcos De Miguel Cruz" userId="dff9766d-3fe8-4659-a0c1-e1b87a709fe4" providerId="ADAL" clId="{5BEB56D2-D1BE-4B43-B384-DED89CB6F23D}" dt="2026-09-03T07:56:44.096" v="241" actId="478"/>
+          <ac:cxnSpMkLst>
+            <pc:docMk/>
+            <pc:sldMk cId="1841050961" sldId="365"/>
+            <ac:cxnSpMk id="17" creationId="{41C3C4FC-B0C0-A82C-D605-860CAB617B00}"/>
+          </ac:cxnSpMkLst>
+        </pc:cxnChg>
+        <pc:cxnChg chg="mod">
+          <ac:chgData name="Marcos De Miguel Cruz" userId="dff9766d-3fe8-4659-a0c1-e1b87a709fe4" providerId="ADAL" clId="{5BEB56D2-D1BE-4B43-B384-DED89CB6F23D}" dt="2026-09-03T07:59:34.017" v="834" actId="1037"/>
+          <ac:cxnSpMkLst>
+            <pc:docMk/>
+            <pc:sldMk cId="1841050961" sldId="365"/>
+            <ac:cxnSpMk id="19" creationId="{DFD55466-8EDE-FB34-0C3E-47B1F725984E}"/>
+          </ac:cxnSpMkLst>
+        </pc:cxnChg>
+        <pc:cxnChg chg="mod">
+          <ac:chgData name="Marcos De Miguel Cruz" userId="dff9766d-3fe8-4659-a0c1-e1b87a709fe4" providerId="ADAL" clId="{5BEB56D2-D1BE-4B43-B384-DED89CB6F23D}" dt="2026-09-03T07:56:32.349" v="216" actId="1037"/>
+          <ac:cxnSpMkLst>
+            <pc:docMk/>
+            <pc:sldMk cId="1841050961" sldId="365"/>
+            <ac:cxnSpMk id="20" creationId="{2ADD77D0-4C72-CA7A-CE63-3E25C707286D}"/>
+          </ac:cxnSpMkLst>
+        </pc:cxnChg>
+        <pc:cxnChg chg="mod">
+          <ac:chgData name="Marcos De Miguel Cruz" userId="dff9766d-3fe8-4659-a0c1-e1b87a709fe4" providerId="ADAL" clId="{5BEB56D2-D1BE-4B43-B384-DED89CB6F23D}" dt="2026-09-03T07:57:35.183" v="404" actId="1036"/>
+          <ac:cxnSpMkLst>
+            <pc:docMk/>
+            <pc:sldMk cId="1841050961" sldId="365"/>
+            <ac:cxnSpMk id="21" creationId="{B75B1BE9-6EBF-2C4E-70DC-EDF0BF2492E8}"/>
+          </ac:cxnSpMkLst>
+        </pc:cxnChg>
+        <pc:cxnChg chg="del">
+          <ac:chgData name="Marcos De Miguel Cruz" userId="dff9766d-3fe8-4659-a0c1-e1b87a709fe4" providerId="ADAL" clId="{5BEB56D2-D1BE-4B43-B384-DED89CB6F23D}" dt="2026-09-03T07:55:28.582" v="0" actId="478"/>
+          <ac:cxnSpMkLst>
+            <pc:docMk/>
+            <pc:sldMk cId="1841050961" sldId="365"/>
+            <ac:cxnSpMk id="31" creationId="{017A04F5-169E-5B9A-1345-F6D0C6E3FA03}"/>
+          </ac:cxnSpMkLst>
+        </pc:cxnChg>
+        <pc:cxnChg chg="del">
+          <ac:chgData name="Marcos De Miguel Cruz" userId="dff9766d-3fe8-4659-a0c1-e1b87a709fe4" providerId="ADAL" clId="{5BEB56D2-D1BE-4B43-B384-DED89CB6F23D}" dt="2026-09-03T07:55:28.582" v="0" actId="478"/>
+          <ac:cxnSpMkLst>
+            <pc:docMk/>
+            <pc:sldMk cId="1841050961" sldId="365"/>
+            <ac:cxnSpMk id="38" creationId="{3665E9F0-701C-A024-D1A2-2C9197804D42}"/>
+          </ac:cxnSpMkLst>
+        </pc:cxnChg>
+        <pc:cxnChg chg="add mod">
+          <ac:chgData name="Marcos De Miguel Cruz" userId="dff9766d-3fe8-4659-a0c1-e1b87a709fe4" providerId="ADAL" clId="{5BEB56D2-D1BE-4B43-B384-DED89CB6F23D}" dt="2026-09-03T07:57:35.183" v="404" actId="1036"/>
+          <ac:cxnSpMkLst>
+            <pc:docMk/>
+            <pc:sldMk cId="1841050961" sldId="365"/>
+            <ac:cxnSpMk id="41" creationId="{F8AB0245-F9DD-6757-E509-5F9D5BD8C9FF}"/>
+          </ac:cxnSpMkLst>
+        </pc:cxnChg>
+        <pc:cxnChg chg="mod">
+          <ac:chgData name="Marcos De Miguel Cruz" userId="dff9766d-3fe8-4659-a0c1-e1b87a709fe4" providerId="ADAL" clId="{5BEB56D2-D1BE-4B43-B384-DED89CB6F23D}" dt="2026-09-03T07:57:35.183" v="404" actId="1036"/>
+          <ac:cxnSpMkLst>
+            <pc:docMk/>
+            <pc:sldMk cId="1841050961" sldId="365"/>
+            <ac:cxnSpMk id="47" creationId="{FE3E788F-64F9-08F6-5585-0301D1331E41}"/>
+          </ac:cxnSpMkLst>
+        </pc:cxnChg>
+        <pc:cxnChg chg="mod">
+          <ac:chgData name="Marcos De Miguel Cruz" userId="dff9766d-3fe8-4659-a0c1-e1b87a709fe4" providerId="ADAL" clId="{5BEB56D2-D1BE-4B43-B384-DED89CB6F23D}" dt="2026-09-03T07:56:16.081" v="152" actId="1037"/>
+          <ac:cxnSpMkLst>
+            <pc:docMk/>
+            <pc:sldMk cId="1841050961" sldId="365"/>
+            <ac:cxnSpMk id="70" creationId="{1D07FB9E-71B7-22BF-28B6-E1BC28A41EED}"/>
+          </ac:cxnSpMkLst>
+        </pc:cxnChg>
+      </pc:sldChg>
+    </pc:docChg>
+  </pc:docChgLst>
+</pc:chgInfo>
+</file>
+
 <file path=ppt/handoutMasters/handoutMaster1.xml><?xml version="1.0" encoding="utf-8"?>
 <p:handoutMaster xmlns:a="http://schemas.openxmlformats.org/drawingml/2006/main" xmlns:r="http://schemas.openxmlformats.org/officeDocument/2006/relationships" xmlns:p="http://schemas.openxmlformats.org/presentationml/2006/main">
   <p:cSld>
@@ -259,7 +1229,7 @@
           <a:p>
             <a:fld id="{42691DDE-BA6A-4F57-909C-98F49C72955F}" type="datetimeFigureOut">
               <a:rPr lang="en-GB" smtClean="0"/>
-              <a:t>26/06/2023</a:t>
+              <a:t>03/09/2026</a:t>
             </a:fld>
             <a:endParaRPr lang="en-GB"/>
           </a:p>
@@ -424,7 +1394,7 @@
           <a:p>
             <a:fld id="{CBAAC5B1-F58D-4268-BB75-9856A9D794A6}" type="datetimeFigureOut">
               <a:rPr lang="en-GB" smtClean="0"/>
-              <a:t>26/06/2023</a:t>
+              <a:t>03/09/2026</a:t>
             </a:fld>
             <a:endParaRPr lang="en-GB"/>
           </a:p>
@@ -2624,7 +3594,7 @@
           <a:p>
             <a:fld id="{E0034AEE-487B-4AD3-9E6B-6BDE3604E6A8}" type="datetimeFigureOut">
               <a:rPr lang="es-ES" smtClean="0"/>
-              <a:t>26/6/23</a:t>
+              <a:t>03/09/2026</a:t>
             </a:fld>
             <a:endParaRPr lang="es-ES"/>
           </a:p>
@@ -10971,7 +11941,7 @@
             </a:r>
             <a:r>
               <a:rPr lang="en-US" dirty="0"/>
-              <a:t> single gen/WT/PV/BESS</a:t>
+              <a:t> single gen/WT/PV</a:t>
             </a:r>
           </a:p>
           <a:p>
@@ -10992,7 +11962,7 @@
             </a:r>
             <a:r>
               <a:rPr lang="en-US" dirty="0"/>
-              <a:t> single gen/WT/PV/BESS + Line</a:t>
+              <a:t> single gen/WT/PV + Line</a:t>
             </a:r>
           </a:p>
           <a:p>
@@ -11013,7 +11983,7 @@
             </a:r>
             <a:r>
               <a:rPr lang="en-US" dirty="0"/>
-              <a:t> single gen/WT/PV/BESS + Aux Load </a:t>
+              <a:t> single gen/WT/PV + Aux Load </a:t>
             </a:r>
           </a:p>
           <a:p>
@@ -11034,7 +12004,7 @@
             </a:r>
             <a:r>
               <a:rPr lang="en-US" dirty="0"/>
-              <a:t> single gen/WT/PV/BESS + Aux Load + Line</a:t>
+              <a:t> single gen/WT/PV + Aux Load + Line</a:t>
             </a:r>
           </a:p>
           <a:p>
@@ -11047,7 +12017,7 @@
             </a:r>
             <a:r>
               <a:rPr lang="en-US" dirty="0"/>
-              <a:t> multiple WT/PV/BESS</a:t>
+              <a:t> multiple WT/PV</a:t>
             </a:r>
           </a:p>
           <a:p>
@@ -11068,7 +12038,7 @@
             </a:r>
             <a:r>
               <a:rPr lang="en-US" dirty="0"/>
-              <a:t> multiple WT/PV/BESS + Line</a:t>
+              <a:t> multiple WT/PV + Line</a:t>
             </a:r>
           </a:p>
           <a:p>
@@ -11089,7 +12059,7 @@
             </a:r>
             <a:r>
               <a:rPr lang="en-US" dirty="0"/>
-              <a:t> multiple WT/PV/BESS + Aux Load</a:t>
+              <a:t> multiple WT/PV + Aux Load</a:t>
             </a:r>
           </a:p>
           <a:p>
@@ -11110,7 +12080,7 @@
             </a:r>
             <a:r>
               <a:rPr lang="en-US" dirty="0"/>
-              <a:t> multiple WT/PV/BESS + Aux Load + Line</a:t>
+              <a:t> multiple WT/PV + Aux Load + Line</a:t>
             </a:r>
           </a:p>
         </p:txBody>
@@ -11155,7 +12125,7 @@
             </a:pPr>
             <a:r>
               <a:rPr lang="en-US" sz="1400" i="1" dirty="0"/>
-              <a:t>For Zone 1 WT/PV/BESS, the only one allowed is “S”</a:t>
+              <a:t>For Zone 1 WT/PV, the only one allowed is “S”</a:t>
             </a:r>
           </a:p>
         </p:txBody>
@@ -11428,7 +12398,7 @@
         </p:nvGrpSpPr>
         <p:grpSpPr>
           <a:xfrm>
-            <a:off x="4726978" y="2442652"/>
+            <a:off x="7661380" y="2438440"/>
             <a:ext cx="659272" cy="471329"/>
             <a:chOff x="3884292" y="2200605"/>
             <a:chExt cx="659272" cy="471329"/>
@@ -11565,7 +12535,7 @@
         </p:nvCxnSpPr>
         <p:spPr>
           <a:xfrm>
-            <a:off x="5396717" y="2677773"/>
+            <a:off x="8315615" y="2676652"/>
             <a:ext cx="1060189" cy="0"/>
           </a:xfrm>
           <a:prstGeom prst="line">
@@ -11609,7 +12579,7 @@
         </p:nvCxnSpPr>
         <p:spPr>
           <a:xfrm>
-            <a:off x="6456906" y="2391406"/>
+            <a:off x="4717146" y="2388652"/>
             <a:ext cx="0" cy="576000"/>
           </a:xfrm>
           <a:prstGeom prst="line">
@@ -11671,7 +12641,7 @@
             </a:r>
             <a:r>
               <a:rPr lang="en-US" sz="2000" dirty="0"/>
-              <a:t> single gen/WT/PV/BESS</a:t>
+              <a:t> single gen/WT/PV</a:t>
             </a:r>
           </a:p>
           <a:p>
@@ -11692,7 +12662,7 @@
             </a:r>
             <a:r>
               <a:rPr lang="en-US" sz="2000" dirty="0"/>
-              <a:t> single gen/WT/PV/BESS + Line</a:t>
+              <a:t> single gen/WT/PV + Line</a:t>
             </a:r>
           </a:p>
         </p:txBody>
@@ -11714,7 +12684,7 @@
         </p:nvCxnSpPr>
         <p:spPr>
           <a:xfrm>
-            <a:off x="6456906" y="2676652"/>
+            <a:off x="4707623" y="2676652"/>
             <a:ext cx="923047" cy="0"/>
           </a:xfrm>
           <a:prstGeom prst="line">
@@ -11756,7 +12726,7 @@
         </p:nvSpPr>
         <p:spPr bwMode="ltGray">
           <a:xfrm>
-            <a:off x="7379953" y="2534084"/>
+            <a:off x="5630670" y="2534084"/>
             <a:ext cx="1130710" cy="285136"/>
           </a:xfrm>
           <a:prstGeom prst="rect">
@@ -11815,7 +12785,7 @@
         </p:nvCxnSpPr>
         <p:spPr>
           <a:xfrm>
-            <a:off x="8510663" y="2676652"/>
+            <a:off x="6761380" y="2676652"/>
             <a:ext cx="900000" cy="0"/>
           </a:xfrm>
           <a:prstGeom prst="line">
@@ -11859,7 +12829,7 @@
         </p:nvCxnSpPr>
         <p:spPr>
           <a:xfrm>
-            <a:off x="9428796" y="2388652"/>
+            <a:off x="9375804" y="2384440"/>
             <a:ext cx="0" cy="576000"/>
           </a:xfrm>
           <a:prstGeom prst="line">
@@ -11901,7 +12871,7 @@
         </p:nvSpPr>
         <p:spPr>
           <a:xfrm>
-            <a:off x="9213192" y="3036653"/>
+            <a:off x="9240919" y="3120370"/>
             <a:ext cx="431208" cy="246221"/>
           </a:xfrm>
           <a:prstGeom prst="rect">
@@ -11936,7 +12906,7 @@
         </p:nvSpPr>
         <p:spPr>
           <a:xfrm>
-            <a:off x="7167445" y="2904926"/>
+            <a:off x="5418162" y="2904926"/>
             <a:ext cx="1508659" cy="215444"/>
           </a:xfrm>
           <a:prstGeom prst="rect">
@@ -11972,7 +12942,7 @@
         </p:nvSpPr>
         <p:spPr bwMode="ltGray">
           <a:xfrm>
-            <a:off x="7080661" y="2159337"/>
+            <a:off x="5331378" y="2159337"/>
             <a:ext cx="1729293" cy="1123537"/>
           </a:xfrm>
           <a:prstGeom prst="rect">
@@ -12030,7 +13000,7 @@
         </p:nvSpPr>
         <p:spPr>
           <a:xfrm>
-            <a:off x="2040581" y="1318210"/>
+            <a:off x="967156" y="1639840"/>
             <a:ext cx="2877669" cy="215444"/>
           </a:xfrm>
           <a:prstGeom prst="rect">
@@ -12096,7 +13066,7 @@
         </p:nvSpPr>
         <p:spPr>
           <a:xfrm>
-            <a:off x="3567344" y="3121557"/>
+            <a:off x="6930025" y="2046323"/>
             <a:ext cx="2877669" cy="215444"/>
           </a:xfrm>
           <a:prstGeom prst="rect">
@@ -12137,7 +13107,7 @@
                 <a:latin typeface="Courier New" panose="02070309020205020404" pitchFamily="49" charset="0"/>
                 <a:cs typeface="Courier New" panose="02070309020205020404" pitchFamily="49" charset="0"/>
               </a:rPr>
-              <a:t>StepUp_Xfmr</a:t>
+              <a:t>Main_Xfmr</a:t>
             </a:r>
             <a:r>
               <a:rPr lang="en-US" sz="1400" dirty="0">
@@ -12163,7 +13133,7 @@
         </p:nvSpPr>
         <p:spPr>
           <a:xfrm>
-            <a:off x="2040581" y="1621248"/>
+            <a:off x="967156" y="1942878"/>
             <a:ext cx="2877669" cy="215444"/>
           </a:xfrm>
           <a:prstGeom prst="rect">
@@ -12204,72 +13174,6 @@
                 <a:cs typeface="Courier New" panose="02070309020205020404" pitchFamily="49" charset="0"/>
               </a:rPr>
               <a:t>PV_Array</a:t>
-            </a:r>
-            <a:r>
-              <a:rPr lang="en-US" sz="1400" dirty="0">
-                <a:latin typeface="Courier New" panose="02070309020205020404" pitchFamily="49" charset="0"/>
-                <a:cs typeface="Courier New" panose="02070309020205020404" pitchFamily="49" charset="0"/>
-              </a:rPr>
-              <a:t>”</a:t>
-            </a:r>
-          </a:p>
-        </p:txBody>
-      </p:sp>
-      <p:sp>
-        <p:nvSpPr>
-          <p:cNvPr id="4" name="CuadroTexto 3">
-            <a:extLst>
-              <a:ext uri="{FF2B5EF4-FFF2-40B4-BE49-F238E27FC236}">
-                <a16:creationId xmlns:a16="http://schemas.microsoft.com/office/drawing/2014/main" id="{331152A1-8121-83E9-6047-D899AC2A225D}"/>
-              </a:ext>
-            </a:extLst>
-          </p:cNvPr>
-          <p:cNvSpPr txBox="1"/>
-          <p:nvPr/>
-        </p:nvSpPr>
-        <p:spPr>
-          <a:xfrm>
-            <a:off x="2040581" y="1924286"/>
-            <a:ext cx="2877669" cy="215444"/>
-          </a:xfrm>
-          <a:prstGeom prst="rect">
-            <a:avLst/>
-          </a:prstGeom>
-          <a:noFill/>
-        </p:spPr>
-        <p:txBody>
-          <a:bodyPr wrap="square" lIns="0" tIns="0" rIns="0" bIns="0" rtlCol="0">
-            <a:spAutoFit/>
-          </a:bodyPr>
-          <a:lstStyle/>
-          <a:p>
-            <a:r>
-              <a:rPr lang="en-US" sz="1400" dirty="0">
-                <a:latin typeface="Courier New" panose="02070309020205020404" pitchFamily="49" charset="0"/>
-                <a:cs typeface="Courier New" panose="02070309020205020404" pitchFamily="49" charset="0"/>
-              </a:rPr>
-              <a:t>id/</a:t>
-            </a:r>
-            <a:r>
-              <a:rPr lang="en-US" sz="1400" dirty="0" err="1">
-                <a:latin typeface="Courier New" panose="02070309020205020404" pitchFamily="49" charset="0"/>
-                <a:cs typeface="Courier New" panose="02070309020205020404" pitchFamily="49" charset="0"/>
-              </a:rPr>
-              <a:t>parId</a:t>
-            </a:r>
-            <a:r>
-              <a:rPr lang="en-US" sz="1400" dirty="0">
-                <a:latin typeface="Courier New" panose="02070309020205020404" pitchFamily="49" charset="0"/>
-                <a:cs typeface="Courier New" panose="02070309020205020404" pitchFamily="49" charset="0"/>
-              </a:rPr>
-              <a:t> = “</a:t>
-            </a:r>
-            <a:r>
-              <a:rPr lang="en-US" sz="1400" dirty="0" err="1">
-                <a:latin typeface="Courier New" panose="02070309020205020404" pitchFamily="49" charset="0"/>
-                <a:cs typeface="Courier New" panose="02070309020205020404" pitchFamily="49" charset="0"/>
-              </a:rPr>
-              <a:t>Bess</a:t>
             </a:r>
             <a:r>
               <a:rPr lang="en-US" sz="1400" dirty="0">
@@ -12295,7 +13199,7 @@
         </p:nvSpPr>
         <p:spPr>
           <a:xfrm>
-            <a:off x="2040580" y="1015172"/>
+            <a:off x="967155" y="1336802"/>
             <a:ext cx="2859025" cy="215444"/>
           </a:xfrm>
           <a:prstGeom prst="rect">
@@ -12361,7 +13265,7 @@
         </p:nvSpPr>
         <p:spPr>
           <a:xfrm>
-            <a:off x="6229927" y="1727797"/>
+            <a:off x="4378222" y="3425442"/>
             <a:ext cx="3435556" cy="215444"/>
           </a:xfrm>
           <a:prstGeom prst="rect">
@@ -12460,7 +13364,7 @@
         </p:nvCxnSpPr>
         <p:spPr>
           <a:xfrm>
-            <a:off x="3961754" y="2227101"/>
+            <a:off x="3961754" y="2107833"/>
             <a:ext cx="1060189" cy="0"/>
           </a:xfrm>
           <a:prstGeom prst="line">
@@ -12502,7 +13406,7 @@
         </p:nvGrpSpPr>
         <p:grpSpPr>
           <a:xfrm>
-            <a:off x="3241754" y="1867102"/>
+            <a:off x="3241754" y="1747834"/>
             <a:ext cx="720000" cy="720000"/>
             <a:chOff x="1671483" y="2015613"/>
             <a:chExt cx="720000" cy="720000"/>
@@ -12682,7 +13586,7 @@
         </p:nvGrpSpPr>
         <p:grpSpPr>
           <a:xfrm>
-            <a:off x="5031775" y="1993101"/>
+            <a:off x="7995994" y="1979211"/>
             <a:ext cx="659272" cy="471329"/>
             <a:chOff x="3884292" y="2200605"/>
             <a:chExt cx="659272" cy="471329"/>
@@ -12819,7 +13723,7 @@
         </p:nvCxnSpPr>
         <p:spPr>
           <a:xfrm>
-            <a:off x="5701514" y="2228222"/>
+            <a:off x="8655068" y="2227101"/>
             <a:ext cx="1060189" cy="0"/>
           </a:xfrm>
           <a:prstGeom prst="line">
@@ -12863,7 +13767,7 @@
         </p:nvCxnSpPr>
         <p:spPr>
           <a:xfrm>
-            <a:off x="6761703" y="1941855"/>
+            <a:off x="5032302" y="1941855"/>
             <a:ext cx="0" cy="576000"/>
           </a:xfrm>
           <a:prstGeom prst="line">
@@ -12908,7 +13812,7 @@
         </p:nvCxnSpPr>
         <p:spPr>
           <a:xfrm>
-            <a:off x="6761703" y="2227101"/>
+            <a:off x="5042237" y="2227101"/>
             <a:ext cx="923047" cy="0"/>
           </a:xfrm>
           <a:prstGeom prst="line">
@@ -12950,7 +13854,7 @@
         </p:nvSpPr>
         <p:spPr bwMode="ltGray">
           <a:xfrm>
-            <a:off x="7684750" y="2084533"/>
+            <a:off x="5965284" y="2084533"/>
             <a:ext cx="1130710" cy="285136"/>
           </a:xfrm>
           <a:prstGeom prst="rect">
@@ -13009,7 +13913,7 @@
         </p:nvCxnSpPr>
         <p:spPr>
           <a:xfrm>
-            <a:off x="8815460" y="2227101"/>
+            <a:off x="7095994" y="2227101"/>
             <a:ext cx="900000" cy="0"/>
           </a:xfrm>
           <a:prstGeom prst="line">
@@ -13053,7 +13957,7 @@
         </p:nvCxnSpPr>
         <p:spPr>
           <a:xfrm>
-            <a:off x="9733593" y="1939101"/>
+            <a:off x="9713719" y="1925211"/>
             <a:ext cx="0" cy="576000"/>
           </a:xfrm>
           <a:prstGeom prst="line">
@@ -13095,7 +13999,7 @@
         </p:nvSpPr>
         <p:spPr>
           <a:xfrm>
-            <a:off x="9517989" y="2587102"/>
+            <a:off x="9531598" y="1594574"/>
             <a:ext cx="431208" cy="246221"/>
           </a:xfrm>
           <a:prstGeom prst="rect">
@@ -13130,7 +14034,7 @@
         </p:nvSpPr>
         <p:spPr>
           <a:xfrm>
-            <a:off x="7472242" y="2455375"/>
+            <a:off x="5752776" y="2455375"/>
             <a:ext cx="1508659" cy="215444"/>
           </a:xfrm>
           <a:prstGeom prst="rect">
@@ -13166,7 +14070,7 @@
         </p:nvSpPr>
         <p:spPr bwMode="ltGray">
           <a:xfrm>
-            <a:off x="7385458" y="1709786"/>
+            <a:off x="5665992" y="1709786"/>
             <a:ext cx="1729293" cy="1123537"/>
           </a:xfrm>
           <a:prstGeom prst="rect">
@@ -13252,7 +14156,7 @@
             </a:r>
             <a:r>
               <a:rPr lang="en-US" sz="2000" dirty="0"/>
-              <a:t> single gen/WT/PV/BESS + Aux Load </a:t>
+              <a:t> single gen/WT/PV + Aux Load </a:t>
             </a:r>
           </a:p>
           <a:p>
@@ -13273,7 +14177,7 @@
             </a:r>
             <a:r>
               <a:rPr lang="en-US" sz="2000" dirty="0"/>
-              <a:t> single gen/WT/PV/BESS + Aux Load + Line</a:t>
+              <a:t> single gen/WT/PV + Aux Load + Line</a:t>
             </a:r>
           </a:p>
         </p:txBody>
@@ -13294,7 +14198,7 @@
         </p:nvCxnSpPr>
         <p:spPr>
           <a:xfrm>
-            <a:off x="6201264" y="2369669"/>
+            <a:off x="4471863" y="2369669"/>
             <a:ext cx="560439" cy="0"/>
           </a:xfrm>
           <a:prstGeom prst="line">
@@ -13338,7 +14242,7 @@
         </p:nvCxnSpPr>
         <p:spPr>
           <a:xfrm>
-            <a:off x="6216013" y="2373811"/>
+            <a:off x="4486612" y="2373811"/>
             <a:ext cx="0" cy="426582"/>
           </a:xfrm>
           <a:prstGeom prst="line">
@@ -13380,7 +14284,7 @@
         </p:nvGrpSpPr>
         <p:grpSpPr>
           <a:xfrm rot="5400000">
-            <a:off x="5886376" y="2892947"/>
+            <a:off x="4156975" y="2892947"/>
             <a:ext cx="659272" cy="471329"/>
             <a:chOff x="3884292" y="2200605"/>
             <a:chExt cx="659272" cy="471329"/>
@@ -13517,7 +14421,7 @@
         </p:nvCxnSpPr>
         <p:spPr>
           <a:xfrm>
-            <a:off x="6201264" y="3458248"/>
+            <a:off x="4471863" y="3458248"/>
             <a:ext cx="0" cy="247487"/>
           </a:xfrm>
           <a:prstGeom prst="line">
@@ -13559,7 +14463,7 @@
         </p:nvSpPr>
         <p:spPr bwMode="ltGray">
           <a:xfrm>
-            <a:off x="5985264" y="3652593"/>
+            <a:off x="4255863" y="3652593"/>
             <a:ext cx="432000" cy="553651"/>
           </a:xfrm>
           <a:prstGeom prst="downArrow">
@@ -13616,7 +14520,7 @@
         </p:nvSpPr>
         <p:spPr>
           <a:xfrm>
-            <a:off x="1101500" y="1071861"/>
+            <a:off x="1101500" y="1254345"/>
             <a:ext cx="2877669" cy="215444"/>
           </a:xfrm>
           <a:prstGeom prst="rect">
@@ -13682,7 +14586,7 @@
         </p:nvSpPr>
         <p:spPr>
           <a:xfrm>
-            <a:off x="1101500" y="1374899"/>
+            <a:off x="1101500" y="1557383"/>
             <a:ext cx="2877669" cy="215444"/>
           </a:xfrm>
           <a:prstGeom prst="rect">
@@ -13723,72 +14627,6 @@
                 <a:cs typeface="Courier New" panose="02070309020205020404" pitchFamily="49" charset="0"/>
               </a:rPr>
               <a:t>PV_Array</a:t>
-            </a:r>
-            <a:r>
-              <a:rPr lang="en-US" sz="1400" dirty="0">
-                <a:latin typeface="Courier New" panose="02070309020205020404" pitchFamily="49" charset="0"/>
-                <a:cs typeface="Courier New" panose="02070309020205020404" pitchFamily="49" charset="0"/>
-              </a:rPr>
-              <a:t>”</a:t>
-            </a:r>
-          </a:p>
-        </p:txBody>
-      </p:sp>
-      <p:sp>
-        <p:nvSpPr>
-          <p:cNvPr id="7" name="CuadroTexto 6">
-            <a:extLst>
-              <a:ext uri="{FF2B5EF4-FFF2-40B4-BE49-F238E27FC236}">
-                <a16:creationId xmlns:a16="http://schemas.microsoft.com/office/drawing/2014/main" id="{16B3F710-9075-82D5-3677-C6C48D19BAD1}"/>
-              </a:ext>
-            </a:extLst>
-          </p:cNvPr>
-          <p:cNvSpPr txBox="1"/>
-          <p:nvPr/>
-        </p:nvSpPr>
-        <p:spPr>
-          <a:xfrm>
-            <a:off x="1101500" y="1677937"/>
-            <a:ext cx="2877669" cy="215444"/>
-          </a:xfrm>
-          <a:prstGeom prst="rect">
-            <a:avLst/>
-          </a:prstGeom>
-          <a:noFill/>
-        </p:spPr>
-        <p:txBody>
-          <a:bodyPr wrap="square" lIns="0" tIns="0" rIns="0" bIns="0" rtlCol="0">
-            <a:spAutoFit/>
-          </a:bodyPr>
-          <a:lstStyle/>
-          <a:p>
-            <a:r>
-              <a:rPr lang="en-US" sz="1400" dirty="0">
-                <a:latin typeface="Courier New" panose="02070309020205020404" pitchFamily="49" charset="0"/>
-                <a:cs typeface="Courier New" panose="02070309020205020404" pitchFamily="49" charset="0"/>
-              </a:rPr>
-              <a:t>id/</a:t>
-            </a:r>
-            <a:r>
-              <a:rPr lang="en-US" sz="1400" dirty="0" err="1">
-                <a:latin typeface="Courier New" panose="02070309020205020404" pitchFamily="49" charset="0"/>
-                <a:cs typeface="Courier New" panose="02070309020205020404" pitchFamily="49" charset="0"/>
-              </a:rPr>
-              <a:t>parId</a:t>
-            </a:r>
-            <a:r>
-              <a:rPr lang="en-US" sz="1400" dirty="0">
-                <a:latin typeface="Courier New" panose="02070309020205020404" pitchFamily="49" charset="0"/>
-                <a:cs typeface="Courier New" panose="02070309020205020404" pitchFamily="49" charset="0"/>
-              </a:rPr>
-              <a:t> = “</a:t>
-            </a:r>
-            <a:r>
-              <a:rPr lang="en-US" sz="1400" dirty="0" err="1">
-                <a:latin typeface="Courier New" panose="02070309020205020404" pitchFamily="49" charset="0"/>
-                <a:cs typeface="Courier New" panose="02070309020205020404" pitchFamily="49" charset="0"/>
-              </a:rPr>
-              <a:t>Bess</a:t>
             </a:r>
             <a:r>
               <a:rPr lang="en-US" sz="1400" dirty="0">
@@ -13814,7 +14652,7 @@
         </p:nvSpPr>
         <p:spPr>
           <a:xfrm>
-            <a:off x="1101499" y="768823"/>
+            <a:off x="1101499" y="951307"/>
             <a:ext cx="2859025" cy="215444"/>
           </a:xfrm>
           <a:prstGeom prst="rect">
@@ -13880,7 +14718,7 @@
         </p:nvSpPr>
         <p:spPr>
           <a:xfrm>
-            <a:off x="3899004" y="1741106"/>
+            <a:off x="7279261" y="2619544"/>
             <a:ext cx="2877669" cy="215444"/>
           </a:xfrm>
           <a:prstGeom prst="rect">
@@ -13921,7 +14759,7 @@
                 <a:latin typeface="Courier New" panose="02070309020205020404" pitchFamily="49" charset="0"/>
                 <a:cs typeface="Courier New" panose="02070309020205020404" pitchFamily="49" charset="0"/>
               </a:rPr>
-              <a:t>StepUp_Xfmr</a:t>
+              <a:t>Main_Xfmr</a:t>
             </a:r>
             <a:r>
               <a:rPr lang="en-US" sz="1400" dirty="0">
@@ -13947,7 +14785,7 @@
         </p:nvSpPr>
         <p:spPr>
           <a:xfrm>
-            <a:off x="6761703" y="1422064"/>
+            <a:off x="4828554" y="1419003"/>
             <a:ext cx="3435556" cy="215444"/>
           </a:xfrm>
           <a:prstGeom prst="rect">
@@ -14014,7 +14852,7 @@
         </p:nvSpPr>
         <p:spPr>
           <a:xfrm>
-            <a:off x="6408017" y="3239037"/>
+            <a:off x="1283609" y="3239037"/>
             <a:ext cx="2877669" cy="215444"/>
           </a:xfrm>
           <a:prstGeom prst="rect">
@@ -14081,7 +14919,7 @@
         </p:nvSpPr>
         <p:spPr>
           <a:xfrm>
-            <a:off x="6481483" y="3821696"/>
+            <a:off x="1730055" y="3821696"/>
             <a:ext cx="2366680" cy="215444"/>
           </a:xfrm>
           <a:prstGeom prst="rect">
@@ -14148,7 +14986,7 @@
         </p:nvSpPr>
         <p:spPr>
           <a:xfrm>
-            <a:off x="5388996" y="793782"/>
+            <a:off x="3669530" y="793782"/>
             <a:ext cx="2184973" cy="215444"/>
           </a:xfrm>
           <a:prstGeom prst="rect">
@@ -14211,15 +15049,14 @@
             </a:extLst>
           </p:cNvPr>
           <p:cNvCxnSpPr>
-            <a:stCxn id="33" idx="2"/>
-            <a:endCxn id="28" idx="3"/>
+            <a:cxnSpLocks/>
           </p:cNvCxnSpPr>
           <p:nvPr/>
         </p:nvCxnSpPr>
         <p:spPr>
           <a:xfrm>
-            <a:off x="6481483" y="1009226"/>
-            <a:ext cx="295190" cy="839602"/>
+            <a:off x="4933675" y="1030437"/>
+            <a:ext cx="53188" cy="829449"/>
           </a:xfrm>
           <a:prstGeom prst="straightConnector1">
             <a:avLst/>
@@ -14500,185 +15337,6 @@
           </p:txBody>
         </p:sp>
       </p:grpSp>
-      <p:grpSp>
-        <p:nvGrpSpPr>
-          <p:cNvPr id="48" name="Grupo 47">
-            <a:extLst>
-              <a:ext uri="{FF2B5EF4-FFF2-40B4-BE49-F238E27FC236}">
-                <a16:creationId xmlns:a16="http://schemas.microsoft.com/office/drawing/2014/main" id="{5611D643-9A9F-7961-7F2E-5EF5D943F2B0}"/>
-              </a:ext>
-            </a:extLst>
-          </p:cNvPr>
-          <p:cNvGrpSpPr/>
-          <p:nvPr/>
-        </p:nvGrpSpPr>
-        <p:grpSpPr>
-          <a:xfrm>
-            <a:off x="5550283" y="1019578"/>
-            <a:ext cx="659272" cy="471329"/>
-            <a:chOff x="4572550" y="804425"/>
-            <a:chExt cx="659272" cy="471329"/>
-          </a:xfrm>
-        </p:grpSpPr>
-        <p:sp>
-          <p:nvSpPr>
-            <p:cNvPr id="11" name="Elipse 10">
-              <a:extLst>
-                <a:ext uri="{FF2B5EF4-FFF2-40B4-BE49-F238E27FC236}">
-                  <a16:creationId xmlns:a16="http://schemas.microsoft.com/office/drawing/2014/main" id="{6C1BFBF2-7A71-4234-E500-5F6B7EE5CB69}"/>
-                </a:ext>
-              </a:extLst>
-            </p:cNvPr>
-            <p:cNvSpPr/>
-            <p:nvPr/>
-          </p:nvSpPr>
-          <p:spPr bwMode="ltGray">
-            <a:xfrm>
-              <a:off x="4572550" y="807754"/>
-              <a:ext cx="468000" cy="468000"/>
-            </a:xfrm>
-            <a:prstGeom prst="ellipse">
-              <a:avLst/>
-            </a:prstGeom>
-            <a:noFill/>
-            <a:ln w="25400">
-              <a:solidFill>
-                <a:schemeClr val="tx1"/>
-              </a:solidFill>
-            </a:ln>
-          </p:spPr>
-          <p:style>
-            <a:lnRef idx="2">
-              <a:schemeClr val="accent1">
-                <a:shade val="50000"/>
-              </a:schemeClr>
-            </a:lnRef>
-            <a:fillRef idx="1">
-              <a:schemeClr val="accent1"/>
-            </a:fillRef>
-            <a:effectRef idx="0">
-              <a:schemeClr val="accent1"/>
-            </a:effectRef>
-            <a:fontRef idx="minor">
-              <a:schemeClr val="lt1"/>
-            </a:fontRef>
-          </p:style>
-          <p:txBody>
-            <a:bodyPr rot="0" spcFirstLastPara="0" vertOverflow="overflow" horzOverflow="overflow" vert="horz" wrap="square" lIns="91440" tIns="45720" rIns="91440" bIns="45720" numCol="1" spcCol="0" rtlCol="0" fromWordArt="0" anchor="t" anchorCtr="0" forceAA="0" compatLnSpc="1">
-              <a:prstTxWarp prst="textNoShape">
-                <a:avLst/>
-              </a:prstTxWarp>
-              <a:noAutofit/>
-            </a:bodyPr>
-            <a:lstStyle/>
-            <a:p>
-              <a:pPr algn="l"/>
-              <a:endParaRPr lang="en-US" sz="1600" b="0" dirty="0" err="1"/>
-            </a:p>
-          </p:txBody>
-        </p:sp>
-        <p:sp>
-          <p:nvSpPr>
-            <p:cNvPr id="12" name="Elipse 11">
-              <a:extLst>
-                <a:ext uri="{FF2B5EF4-FFF2-40B4-BE49-F238E27FC236}">
-                  <a16:creationId xmlns:a16="http://schemas.microsoft.com/office/drawing/2014/main" id="{F7D74CC1-BEE3-0B4A-7CA9-F7B8B1346ECB}"/>
-                </a:ext>
-              </a:extLst>
-            </p:cNvPr>
-            <p:cNvSpPr/>
-            <p:nvPr/>
-          </p:nvSpPr>
-          <p:spPr bwMode="ltGray">
-            <a:xfrm>
-              <a:off x="4763822" y="804425"/>
-              <a:ext cx="468000" cy="468000"/>
-            </a:xfrm>
-            <a:prstGeom prst="ellipse">
-              <a:avLst/>
-            </a:prstGeom>
-            <a:noFill/>
-            <a:ln w="25400">
-              <a:solidFill>
-                <a:schemeClr val="tx1"/>
-              </a:solidFill>
-            </a:ln>
-          </p:spPr>
-          <p:style>
-            <a:lnRef idx="2">
-              <a:schemeClr val="accent1">
-                <a:shade val="50000"/>
-              </a:schemeClr>
-            </a:lnRef>
-            <a:fillRef idx="1">
-              <a:schemeClr val="accent1"/>
-            </a:fillRef>
-            <a:effectRef idx="0">
-              <a:schemeClr val="accent1"/>
-            </a:effectRef>
-            <a:fontRef idx="minor">
-              <a:schemeClr val="lt1"/>
-            </a:fontRef>
-          </p:style>
-          <p:txBody>
-            <a:bodyPr rot="0" spcFirstLastPara="0" vertOverflow="overflow" horzOverflow="overflow" vert="horz" wrap="square" lIns="91440" tIns="45720" rIns="91440" bIns="45720" numCol="1" spcCol="0" rtlCol="0" fromWordArt="0" anchor="t" anchorCtr="0" forceAA="0" compatLnSpc="1">
-              <a:prstTxWarp prst="textNoShape">
-                <a:avLst/>
-              </a:prstTxWarp>
-              <a:noAutofit/>
-            </a:bodyPr>
-            <a:lstStyle/>
-            <a:p>
-              <a:pPr algn="l"/>
-              <a:endParaRPr lang="en-US" sz="1600" b="0" dirty="0" err="1"/>
-            </a:p>
-          </p:txBody>
-        </p:sp>
-      </p:grpSp>
-      <p:cxnSp>
-        <p:nvCxnSpPr>
-          <p:cNvPr id="13" name="Conector recto 12">
-            <a:extLst>
-              <a:ext uri="{FF2B5EF4-FFF2-40B4-BE49-F238E27FC236}">
-                <a16:creationId xmlns:a16="http://schemas.microsoft.com/office/drawing/2014/main" id="{ADA46642-9A30-F44B-F1EA-08E38FC1F970}"/>
-              </a:ext>
-            </a:extLst>
-          </p:cNvPr>
-          <p:cNvCxnSpPr>
-            <a:cxnSpLocks/>
-          </p:cNvCxnSpPr>
-          <p:nvPr/>
-        </p:nvCxnSpPr>
-        <p:spPr>
-          <a:xfrm>
-            <a:off x="6220022" y="1254699"/>
-            <a:ext cx="1060189" cy="0"/>
-          </a:xfrm>
-          <a:prstGeom prst="line">
-            <a:avLst/>
-          </a:prstGeom>
-          <a:ln w="25400">
-            <a:solidFill>
-              <a:schemeClr val="tx1"/>
-            </a:solidFill>
-            <a:tailEnd type="none"/>
-          </a:ln>
-        </p:spPr>
-        <p:style>
-          <a:lnRef idx="1">
-            <a:schemeClr val="accent1"/>
-          </a:lnRef>
-          <a:fillRef idx="0">
-            <a:schemeClr val="accent1"/>
-          </a:fillRef>
-          <a:effectRef idx="0">
-            <a:schemeClr val="accent1"/>
-          </a:effectRef>
-          <a:fontRef idx="minor">
-            <a:schemeClr val="tx1"/>
-          </a:fontRef>
-        </p:style>
-      </p:cxnSp>
       <p:cxnSp>
         <p:nvCxnSpPr>
           <p:cNvPr id="14" name="Conector recto 13">
@@ -14695,7 +15353,7 @@
         </p:nvCxnSpPr>
         <p:spPr>
           <a:xfrm>
-            <a:off x="7280211" y="968332"/>
+            <a:off x="5540866" y="968332"/>
             <a:ext cx="0" cy="2880000"/>
           </a:xfrm>
           <a:prstGeom prst="line">
@@ -14757,7 +15415,7 @@
             </a:r>
             <a:r>
               <a:rPr lang="en-US" sz="2000" dirty="0"/>
-              <a:t> multiple WT/PV/BESS</a:t>
+              <a:t> multiple WT/PV</a:t>
             </a:r>
           </a:p>
           <a:p>
@@ -14778,7 +15436,7 @@
             </a:r>
             <a:r>
               <a:rPr lang="en-US" sz="2000" dirty="0"/>
-              <a:t> multiple WT/PV/BESS + Line</a:t>
+              <a:t> multiple WT/PV + Line</a:t>
             </a:r>
             <a:endParaRPr lang="en-US" sz="2000" dirty="0">
               <a:solidFill>
@@ -14799,15 +15457,13 @@
           </p:cNvPr>
           <p:cNvCxnSpPr>
             <a:cxnSpLocks/>
-            <a:stCxn id="53" idx="6"/>
-            <a:endCxn id="18" idx="1"/>
           </p:cNvCxnSpPr>
           <p:nvPr/>
         </p:nvCxnSpPr>
         <p:spPr>
-          <a:xfrm>
-            <a:off x="8583839" y="1253578"/>
-            <a:ext cx="779625" cy="0"/>
+          <a:xfrm flipH="1">
+            <a:off x="5536904" y="2340368"/>
+            <a:ext cx="655177" cy="0"/>
           </a:xfrm>
           <a:prstGeom prst="line">
             <a:avLst/>
@@ -14848,7 +15504,7 @@
         </p:nvSpPr>
         <p:spPr bwMode="ltGray">
           <a:xfrm>
-            <a:off x="9363464" y="1111010"/>
+            <a:off x="6093494" y="2194377"/>
             <a:ext cx="1130710" cy="285136"/>
           </a:xfrm>
           <a:prstGeom prst="rect">
@@ -14907,7 +15563,7 @@
         </p:nvCxnSpPr>
         <p:spPr>
           <a:xfrm>
-            <a:off x="10494174" y="1253578"/>
+            <a:off x="7224204" y="2336945"/>
             <a:ext cx="900000" cy="0"/>
           </a:xfrm>
           <a:prstGeom prst="line">
@@ -14951,7 +15607,7 @@
         </p:nvCxnSpPr>
         <p:spPr>
           <a:xfrm>
-            <a:off x="11412307" y="965578"/>
+            <a:off x="9464241" y="2048945"/>
             <a:ext cx="0" cy="576000"/>
           </a:xfrm>
           <a:prstGeom prst="line">
@@ -14993,7 +15649,7 @@
         </p:nvSpPr>
         <p:spPr>
           <a:xfrm>
-            <a:off x="11196703" y="1613579"/>
+            <a:off x="9248637" y="1710352"/>
             <a:ext cx="431208" cy="246221"/>
           </a:xfrm>
           <a:prstGeom prst="rect">
@@ -15028,7 +15684,7 @@
         </p:nvSpPr>
         <p:spPr>
           <a:xfrm>
-            <a:off x="9150956" y="1481852"/>
+            <a:off x="5880986" y="2565219"/>
             <a:ext cx="1508659" cy="215444"/>
           </a:xfrm>
           <a:prstGeom prst="rect">
@@ -15064,7 +15720,7 @@
         </p:nvSpPr>
         <p:spPr bwMode="ltGray">
           <a:xfrm>
-            <a:off x="9064172" y="736263"/>
+            <a:off x="5794202" y="1819630"/>
             <a:ext cx="1729293" cy="1123537"/>
           </a:xfrm>
           <a:prstGeom prst="rect">
@@ -15332,185 +15988,6 @@
           </p:txBody>
         </p:sp>
       </p:grpSp>
-      <p:grpSp>
-        <p:nvGrpSpPr>
-          <p:cNvPr id="49" name="Grupo 48">
-            <a:extLst>
-              <a:ext uri="{FF2B5EF4-FFF2-40B4-BE49-F238E27FC236}">
-                <a16:creationId xmlns:a16="http://schemas.microsoft.com/office/drawing/2014/main" id="{19C4C2C6-D57B-C860-BEAE-28AE57659C3A}"/>
-              </a:ext>
-            </a:extLst>
-          </p:cNvPr>
-          <p:cNvGrpSpPr/>
-          <p:nvPr/>
-        </p:nvGrpSpPr>
-        <p:grpSpPr>
-          <a:xfrm>
-            <a:off x="5550283" y="1862593"/>
-            <a:ext cx="659272" cy="471329"/>
-            <a:chOff x="4572550" y="1647440"/>
-            <a:chExt cx="659272" cy="471329"/>
-          </a:xfrm>
-        </p:grpSpPr>
-        <p:sp>
-          <p:nvSpPr>
-            <p:cNvPr id="29" name="Elipse 28">
-              <a:extLst>
-                <a:ext uri="{FF2B5EF4-FFF2-40B4-BE49-F238E27FC236}">
-                  <a16:creationId xmlns:a16="http://schemas.microsoft.com/office/drawing/2014/main" id="{0E21FB0E-FBC2-9F4F-58AD-172EDE398D44}"/>
-                </a:ext>
-              </a:extLst>
-            </p:cNvPr>
-            <p:cNvSpPr/>
-            <p:nvPr/>
-          </p:nvSpPr>
-          <p:spPr bwMode="ltGray">
-            <a:xfrm>
-              <a:off x="4572550" y="1650769"/>
-              <a:ext cx="468000" cy="468000"/>
-            </a:xfrm>
-            <a:prstGeom prst="ellipse">
-              <a:avLst/>
-            </a:prstGeom>
-            <a:noFill/>
-            <a:ln w="25400">
-              <a:solidFill>
-                <a:schemeClr val="tx1"/>
-              </a:solidFill>
-            </a:ln>
-          </p:spPr>
-          <p:style>
-            <a:lnRef idx="2">
-              <a:schemeClr val="accent1">
-                <a:shade val="50000"/>
-              </a:schemeClr>
-            </a:lnRef>
-            <a:fillRef idx="1">
-              <a:schemeClr val="accent1"/>
-            </a:fillRef>
-            <a:effectRef idx="0">
-              <a:schemeClr val="accent1"/>
-            </a:effectRef>
-            <a:fontRef idx="minor">
-              <a:schemeClr val="lt1"/>
-            </a:fontRef>
-          </p:style>
-          <p:txBody>
-            <a:bodyPr rot="0" spcFirstLastPara="0" vertOverflow="overflow" horzOverflow="overflow" vert="horz" wrap="square" lIns="91440" tIns="45720" rIns="91440" bIns="45720" numCol="1" spcCol="0" rtlCol="0" fromWordArt="0" anchor="t" anchorCtr="0" forceAA="0" compatLnSpc="1">
-              <a:prstTxWarp prst="textNoShape">
-                <a:avLst/>
-              </a:prstTxWarp>
-              <a:noAutofit/>
-            </a:bodyPr>
-            <a:lstStyle/>
-            <a:p>
-              <a:pPr algn="l"/>
-              <a:endParaRPr lang="en-US" sz="1600" b="0" dirty="0" err="1"/>
-            </a:p>
-          </p:txBody>
-        </p:sp>
-        <p:sp>
-          <p:nvSpPr>
-            <p:cNvPr id="30" name="Elipse 29">
-              <a:extLst>
-                <a:ext uri="{FF2B5EF4-FFF2-40B4-BE49-F238E27FC236}">
-                  <a16:creationId xmlns:a16="http://schemas.microsoft.com/office/drawing/2014/main" id="{06612040-6C33-980E-50F2-8DFBF05E7E47}"/>
-                </a:ext>
-              </a:extLst>
-            </p:cNvPr>
-            <p:cNvSpPr/>
-            <p:nvPr/>
-          </p:nvSpPr>
-          <p:spPr bwMode="ltGray">
-            <a:xfrm>
-              <a:off x="4763822" y="1647440"/>
-              <a:ext cx="468000" cy="468000"/>
-            </a:xfrm>
-            <a:prstGeom prst="ellipse">
-              <a:avLst/>
-            </a:prstGeom>
-            <a:noFill/>
-            <a:ln w="25400">
-              <a:solidFill>
-                <a:schemeClr val="tx1"/>
-              </a:solidFill>
-            </a:ln>
-          </p:spPr>
-          <p:style>
-            <a:lnRef idx="2">
-              <a:schemeClr val="accent1">
-                <a:shade val="50000"/>
-              </a:schemeClr>
-            </a:lnRef>
-            <a:fillRef idx="1">
-              <a:schemeClr val="accent1"/>
-            </a:fillRef>
-            <a:effectRef idx="0">
-              <a:schemeClr val="accent1"/>
-            </a:effectRef>
-            <a:fontRef idx="minor">
-              <a:schemeClr val="lt1"/>
-            </a:fontRef>
-          </p:style>
-          <p:txBody>
-            <a:bodyPr rot="0" spcFirstLastPara="0" vertOverflow="overflow" horzOverflow="overflow" vert="horz" wrap="square" lIns="91440" tIns="45720" rIns="91440" bIns="45720" numCol="1" spcCol="0" rtlCol="0" fromWordArt="0" anchor="t" anchorCtr="0" forceAA="0" compatLnSpc="1">
-              <a:prstTxWarp prst="textNoShape">
-                <a:avLst/>
-              </a:prstTxWarp>
-              <a:noAutofit/>
-            </a:bodyPr>
-            <a:lstStyle/>
-            <a:p>
-              <a:pPr algn="l"/>
-              <a:endParaRPr lang="en-US" sz="1600" b="0" dirty="0" err="1"/>
-            </a:p>
-          </p:txBody>
-        </p:sp>
-      </p:grpSp>
-      <p:cxnSp>
-        <p:nvCxnSpPr>
-          <p:cNvPr id="31" name="Conector recto 30">
-            <a:extLst>
-              <a:ext uri="{FF2B5EF4-FFF2-40B4-BE49-F238E27FC236}">
-                <a16:creationId xmlns:a16="http://schemas.microsoft.com/office/drawing/2014/main" id="{017A04F5-169E-5B9A-1345-F6D0C6E3FA03}"/>
-              </a:ext>
-            </a:extLst>
-          </p:cNvPr>
-          <p:cNvCxnSpPr>
-            <a:cxnSpLocks/>
-          </p:cNvCxnSpPr>
-          <p:nvPr/>
-        </p:nvCxnSpPr>
-        <p:spPr>
-          <a:xfrm>
-            <a:off x="6220022" y="2097714"/>
-            <a:ext cx="1060189" cy="0"/>
-          </a:xfrm>
-          <a:prstGeom prst="line">
-            <a:avLst/>
-          </a:prstGeom>
-          <a:ln w="25400">
-            <a:solidFill>
-              <a:schemeClr val="tx1"/>
-            </a:solidFill>
-            <a:tailEnd type="none"/>
-          </a:ln>
-        </p:spPr>
-        <p:style>
-          <a:lnRef idx="1">
-            <a:schemeClr val="accent1"/>
-          </a:lnRef>
-          <a:fillRef idx="0">
-            <a:schemeClr val="accent1"/>
-          </a:fillRef>
-          <a:effectRef idx="0">
-            <a:schemeClr val="accent1"/>
-          </a:effectRef>
-          <a:fontRef idx="minor">
-            <a:schemeClr val="tx1"/>
-          </a:fontRef>
-        </p:style>
-      </p:cxnSp>
       <p:cxnSp>
         <p:nvCxnSpPr>
           <p:cNvPr id="32" name="Conector recto 31">
@@ -15737,185 +16214,6 @@
       </p:grpSp>
       <p:grpSp>
         <p:nvGrpSpPr>
-          <p:cNvPr id="50" name="Grupo 49">
-            <a:extLst>
-              <a:ext uri="{FF2B5EF4-FFF2-40B4-BE49-F238E27FC236}">
-                <a16:creationId xmlns:a16="http://schemas.microsoft.com/office/drawing/2014/main" id="{7FC0A988-4416-7349-762E-07019326C893}"/>
-              </a:ext>
-            </a:extLst>
-          </p:cNvPr>
-          <p:cNvGrpSpPr/>
-          <p:nvPr/>
-        </p:nvGrpSpPr>
-        <p:grpSpPr>
-          <a:xfrm>
-            <a:off x="5567319" y="3343939"/>
-            <a:ext cx="659272" cy="471329"/>
-            <a:chOff x="4589586" y="3128786"/>
-            <a:chExt cx="659272" cy="471329"/>
-          </a:xfrm>
-        </p:grpSpPr>
-        <p:sp>
-          <p:nvSpPr>
-            <p:cNvPr id="36" name="Elipse 35">
-              <a:extLst>
-                <a:ext uri="{FF2B5EF4-FFF2-40B4-BE49-F238E27FC236}">
-                  <a16:creationId xmlns:a16="http://schemas.microsoft.com/office/drawing/2014/main" id="{9413B694-31C7-4595-F479-221CDBDCEBF8}"/>
-                </a:ext>
-              </a:extLst>
-            </p:cNvPr>
-            <p:cNvSpPr/>
-            <p:nvPr/>
-          </p:nvSpPr>
-          <p:spPr bwMode="ltGray">
-            <a:xfrm>
-              <a:off x="4589586" y="3132115"/>
-              <a:ext cx="468000" cy="468000"/>
-            </a:xfrm>
-            <a:prstGeom prst="ellipse">
-              <a:avLst/>
-            </a:prstGeom>
-            <a:noFill/>
-            <a:ln w="25400">
-              <a:solidFill>
-                <a:schemeClr val="tx1"/>
-              </a:solidFill>
-            </a:ln>
-          </p:spPr>
-          <p:style>
-            <a:lnRef idx="2">
-              <a:schemeClr val="accent1">
-                <a:shade val="50000"/>
-              </a:schemeClr>
-            </a:lnRef>
-            <a:fillRef idx="1">
-              <a:schemeClr val="accent1"/>
-            </a:fillRef>
-            <a:effectRef idx="0">
-              <a:schemeClr val="accent1"/>
-            </a:effectRef>
-            <a:fontRef idx="minor">
-              <a:schemeClr val="lt1"/>
-            </a:fontRef>
-          </p:style>
-          <p:txBody>
-            <a:bodyPr rot="0" spcFirstLastPara="0" vertOverflow="overflow" horzOverflow="overflow" vert="horz" wrap="square" lIns="91440" tIns="45720" rIns="91440" bIns="45720" numCol="1" spcCol="0" rtlCol="0" fromWordArt="0" anchor="t" anchorCtr="0" forceAA="0" compatLnSpc="1">
-              <a:prstTxWarp prst="textNoShape">
-                <a:avLst/>
-              </a:prstTxWarp>
-              <a:noAutofit/>
-            </a:bodyPr>
-            <a:lstStyle/>
-            <a:p>
-              <a:pPr algn="l"/>
-              <a:endParaRPr lang="en-US" sz="1600" b="0" dirty="0" err="1"/>
-            </a:p>
-          </p:txBody>
-        </p:sp>
-        <p:sp>
-          <p:nvSpPr>
-            <p:cNvPr id="37" name="Elipse 36">
-              <a:extLst>
-                <a:ext uri="{FF2B5EF4-FFF2-40B4-BE49-F238E27FC236}">
-                  <a16:creationId xmlns:a16="http://schemas.microsoft.com/office/drawing/2014/main" id="{514581E2-EE27-EE86-73DB-3BD938798124}"/>
-                </a:ext>
-              </a:extLst>
-            </p:cNvPr>
-            <p:cNvSpPr/>
-            <p:nvPr/>
-          </p:nvSpPr>
-          <p:spPr bwMode="ltGray">
-            <a:xfrm>
-              <a:off x="4780858" y="3128786"/>
-              <a:ext cx="468000" cy="468000"/>
-            </a:xfrm>
-            <a:prstGeom prst="ellipse">
-              <a:avLst/>
-            </a:prstGeom>
-            <a:noFill/>
-            <a:ln w="25400">
-              <a:solidFill>
-                <a:schemeClr val="tx1"/>
-              </a:solidFill>
-            </a:ln>
-          </p:spPr>
-          <p:style>
-            <a:lnRef idx="2">
-              <a:schemeClr val="accent1">
-                <a:shade val="50000"/>
-              </a:schemeClr>
-            </a:lnRef>
-            <a:fillRef idx="1">
-              <a:schemeClr val="accent1"/>
-            </a:fillRef>
-            <a:effectRef idx="0">
-              <a:schemeClr val="accent1"/>
-            </a:effectRef>
-            <a:fontRef idx="minor">
-              <a:schemeClr val="lt1"/>
-            </a:fontRef>
-          </p:style>
-          <p:txBody>
-            <a:bodyPr rot="0" spcFirstLastPara="0" vertOverflow="overflow" horzOverflow="overflow" vert="horz" wrap="square" lIns="91440" tIns="45720" rIns="91440" bIns="45720" numCol="1" spcCol="0" rtlCol="0" fromWordArt="0" anchor="t" anchorCtr="0" forceAA="0" compatLnSpc="1">
-              <a:prstTxWarp prst="textNoShape">
-                <a:avLst/>
-              </a:prstTxWarp>
-              <a:noAutofit/>
-            </a:bodyPr>
-            <a:lstStyle/>
-            <a:p>
-              <a:pPr algn="l"/>
-              <a:endParaRPr lang="en-US" sz="1600" b="0" dirty="0" err="1"/>
-            </a:p>
-          </p:txBody>
-        </p:sp>
-      </p:grpSp>
-      <p:cxnSp>
-        <p:nvCxnSpPr>
-          <p:cNvPr id="38" name="Conector recto 37">
-            <a:extLst>
-              <a:ext uri="{FF2B5EF4-FFF2-40B4-BE49-F238E27FC236}">
-                <a16:creationId xmlns:a16="http://schemas.microsoft.com/office/drawing/2014/main" id="{3665E9F0-701C-A024-D1A2-2C9197804D42}"/>
-              </a:ext>
-            </a:extLst>
-          </p:cNvPr>
-          <p:cNvCxnSpPr>
-            <a:cxnSpLocks/>
-          </p:cNvCxnSpPr>
-          <p:nvPr/>
-        </p:nvCxnSpPr>
-        <p:spPr>
-          <a:xfrm>
-            <a:off x="6237058" y="3579060"/>
-            <a:ext cx="1060189" cy="0"/>
-          </a:xfrm>
-          <a:prstGeom prst="line">
-            <a:avLst/>
-          </a:prstGeom>
-          <a:ln w="25400">
-            <a:solidFill>
-              <a:schemeClr val="tx1"/>
-            </a:solidFill>
-            <a:tailEnd type="none"/>
-          </a:ln>
-        </p:spPr>
-        <p:style>
-          <a:lnRef idx="1">
-            <a:schemeClr val="accent1"/>
-          </a:lnRef>
-          <a:fillRef idx="0">
-            <a:schemeClr val="accent1"/>
-          </a:fillRef>
-          <a:effectRef idx="0">
-            <a:schemeClr val="accent1"/>
-          </a:effectRef>
-          <a:fontRef idx="minor">
-            <a:schemeClr val="tx1"/>
-          </a:fontRef>
-        </p:style>
-      </p:cxnSp>
-      <p:grpSp>
-        <p:nvGrpSpPr>
           <p:cNvPr id="46" name="Grupo 45">
             <a:extLst>
               <a:ext uri="{FF2B5EF4-FFF2-40B4-BE49-F238E27FC236}">
@@ -15928,7 +16226,7 @@
         </p:nvGrpSpPr>
         <p:grpSpPr>
           <a:xfrm>
-            <a:off x="5832823" y="2557168"/>
+            <a:off x="4809092" y="2557168"/>
             <a:ext cx="113767" cy="492854"/>
             <a:chOff x="4166832" y="2135537"/>
             <a:chExt cx="113767" cy="492854"/>
@@ -16123,13 +16421,12 @@
           </p:cNvPr>
           <p:cNvCxnSpPr>
             <a:cxnSpLocks/>
-            <a:endCxn id="52" idx="2"/>
           </p:cNvCxnSpPr>
           <p:nvPr/>
         </p:nvCxnSpPr>
         <p:spPr>
           <a:xfrm>
-            <a:off x="7254548" y="1253578"/>
+            <a:off x="8775232" y="2327005"/>
             <a:ext cx="670019" cy="3329"/>
           </a:xfrm>
           <a:prstGeom prst="line">
@@ -16171,7 +16468,7 @@
         </p:nvGrpSpPr>
         <p:grpSpPr>
           <a:xfrm>
-            <a:off x="7924567" y="1019578"/>
+            <a:off x="8123345" y="2093005"/>
             <a:ext cx="659272" cy="471329"/>
             <a:chOff x="4572550" y="804425"/>
             <a:chExt cx="659272" cy="471329"/>
@@ -16646,7 +16943,7 @@
         </p:nvSpPr>
         <p:spPr>
           <a:xfrm>
-            <a:off x="8208012" y="2020689"/>
+            <a:off x="5416291" y="1482011"/>
             <a:ext cx="3435556" cy="215444"/>
           </a:xfrm>
           <a:prstGeom prst="rect">
@@ -16688,179 +16985,6 @@
                 <a:cs typeface="Courier New" panose="02070309020205020404" pitchFamily="49" charset="0"/>
               </a:rPr>
               <a:t>IntNetwork_Line</a:t>
-            </a:r>
-            <a:r>
-              <a:rPr lang="en-US" sz="1400" dirty="0">
-                <a:latin typeface="Courier New" panose="02070309020205020404" pitchFamily="49" charset="0"/>
-                <a:cs typeface="Courier New" panose="02070309020205020404" pitchFamily="49" charset="0"/>
-              </a:rPr>
-              <a:t>”</a:t>
-            </a:r>
-          </a:p>
-        </p:txBody>
-      </p:sp>
-      <p:sp>
-        <p:nvSpPr>
-          <p:cNvPr id="42" name="CuadroTexto 41">
-            <a:extLst>
-              <a:ext uri="{FF2B5EF4-FFF2-40B4-BE49-F238E27FC236}">
-                <a16:creationId xmlns:a16="http://schemas.microsoft.com/office/drawing/2014/main" id="{7FDEC4E5-6E8B-D7E1-46A8-A6CEFA44E559}"/>
-              </a:ext>
-            </a:extLst>
-          </p:cNvPr>
-          <p:cNvSpPr txBox="1"/>
-          <p:nvPr/>
-        </p:nvSpPr>
-        <p:spPr>
-          <a:xfrm>
-            <a:off x="4421093" y="790463"/>
-            <a:ext cx="2877669" cy="215444"/>
-          </a:xfrm>
-          <a:prstGeom prst="rect">
-            <a:avLst/>
-          </a:prstGeom>
-          <a:noFill/>
-        </p:spPr>
-        <p:txBody>
-          <a:bodyPr wrap="square" lIns="0" tIns="0" rIns="0" bIns="0" rtlCol="0">
-            <a:spAutoFit/>
-          </a:bodyPr>
-          <a:lstStyle/>
-          <a:p>
-            <a:pPr algn="ctr"/>
-            <a:r>
-              <a:rPr lang="en-US" sz="1400" dirty="0">
-                <a:latin typeface="Courier New" panose="02070309020205020404" pitchFamily="49" charset="0"/>
-                <a:cs typeface="Courier New" panose="02070309020205020404" pitchFamily="49" charset="0"/>
-              </a:rPr>
-              <a:t>id/</a:t>
-            </a:r>
-            <a:r>
-              <a:rPr lang="en-US" sz="1400" dirty="0" err="1">
-                <a:latin typeface="Courier New" panose="02070309020205020404" pitchFamily="49" charset="0"/>
-                <a:cs typeface="Courier New" panose="02070309020205020404" pitchFamily="49" charset="0"/>
-              </a:rPr>
-              <a:t>parId</a:t>
-            </a:r>
-            <a:r>
-              <a:rPr lang="en-US" sz="1400" dirty="0">
-                <a:latin typeface="Courier New" panose="02070309020205020404" pitchFamily="49" charset="0"/>
-                <a:cs typeface="Courier New" panose="02070309020205020404" pitchFamily="49" charset="0"/>
-              </a:rPr>
-              <a:t> = “StepUp_Xfmr_1”</a:t>
-            </a:r>
-          </a:p>
-        </p:txBody>
-      </p:sp>
-      <p:sp>
-        <p:nvSpPr>
-          <p:cNvPr id="54" name="CuadroTexto 53">
-            <a:extLst>
-              <a:ext uri="{FF2B5EF4-FFF2-40B4-BE49-F238E27FC236}">
-                <a16:creationId xmlns:a16="http://schemas.microsoft.com/office/drawing/2014/main" id="{35C9B755-BB1D-842D-8BB3-EAAA42450BE7}"/>
-              </a:ext>
-            </a:extLst>
-          </p:cNvPr>
-          <p:cNvSpPr txBox="1"/>
-          <p:nvPr/>
-        </p:nvSpPr>
-        <p:spPr>
-          <a:xfrm>
-            <a:off x="4429728" y="1642682"/>
-            <a:ext cx="2877669" cy="215444"/>
-          </a:xfrm>
-          <a:prstGeom prst="rect">
-            <a:avLst/>
-          </a:prstGeom>
-          <a:noFill/>
-        </p:spPr>
-        <p:txBody>
-          <a:bodyPr wrap="square" lIns="0" tIns="0" rIns="0" bIns="0" rtlCol="0">
-            <a:spAutoFit/>
-          </a:bodyPr>
-          <a:lstStyle/>
-          <a:p>
-            <a:pPr algn="ctr"/>
-            <a:r>
-              <a:rPr lang="en-US" sz="1400" dirty="0">
-                <a:latin typeface="Courier New" panose="02070309020205020404" pitchFamily="49" charset="0"/>
-                <a:cs typeface="Courier New" panose="02070309020205020404" pitchFamily="49" charset="0"/>
-              </a:rPr>
-              <a:t>id/</a:t>
-            </a:r>
-            <a:r>
-              <a:rPr lang="en-US" sz="1400" dirty="0" err="1">
-                <a:latin typeface="Courier New" panose="02070309020205020404" pitchFamily="49" charset="0"/>
-                <a:cs typeface="Courier New" panose="02070309020205020404" pitchFamily="49" charset="0"/>
-              </a:rPr>
-              <a:t>parId</a:t>
-            </a:r>
-            <a:r>
-              <a:rPr lang="en-US" sz="1400" dirty="0">
-                <a:latin typeface="Courier New" panose="02070309020205020404" pitchFamily="49" charset="0"/>
-                <a:cs typeface="Courier New" panose="02070309020205020404" pitchFamily="49" charset="0"/>
-              </a:rPr>
-              <a:t> = “StepUp_Xfmr_2”</a:t>
-            </a:r>
-          </a:p>
-        </p:txBody>
-      </p:sp>
-      <p:sp>
-        <p:nvSpPr>
-          <p:cNvPr id="55" name="CuadroTexto 54">
-            <a:extLst>
-              <a:ext uri="{FF2B5EF4-FFF2-40B4-BE49-F238E27FC236}">
-                <a16:creationId xmlns:a16="http://schemas.microsoft.com/office/drawing/2014/main" id="{35C5F12A-3A49-3798-7461-FA154758289F}"/>
-              </a:ext>
-            </a:extLst>
-          </p:cNvPr>
-          <p:cNvSpPr txBox="1"/>
-          <p:nvPr/>
-        </p:nvSpPr>
-        <p:spPr>
-          <a:xfrm>
-            <a:off x="4430070" y="3122300"/>
-            <a:ext cx="2877669" cy="215444"/>
-          </a:xfrm>
-          <a:prstGeom prst="rect">
-            <a:avLst/>
-          </a:prstGeom>
-          <a:noFill/>
-        </p:spPr>
-        <p:txBody>
-          <a:bodyPr wrap="square" lIns="0" tIns="0" rIns="0" bIns="0" rtlCol="0">
-            <a:spAutoFit/>
-          </a:bodyPr>
-          <a:lstStyle/>
-          <a:p>
-            <a:pPr algn="ctr"/>
-            <a:r>
-              <a:rPr lang="en-US" sz="1400" dirty="0">
-                <a:latin typeface="Courier New" panose="02070309020205020404" pitchFamily="49" charset="0"/>
-                <a:cs typeface="Courier New" panose="02070309020205020404" pitchFamily="49" charset="0"/>
-              </a:rPr>
-              <a:t>id/</a:t>
-            </a:r>
-            <a:r>
-              <a:rPr lang="en-US" sz="1400" dirty="0" err="1">
-                <a:latin typeface="Courier New" panose="02070309020205020404" pitchFamily="49" charset="0"/>
-                <a:cs typeface="Courier New" panose="02070309020205020404" pitchFamily="49" charset="0"/>
-              </a:rPr>
-              <a:t>parId</a:t>
-            </a:r>
-            <a:r>
-              <a:rPr lang="en-US" sz="1400" dirty="0">
-                <a:latin typeface="Courier New" panose="02070309020205020404" pitchFamily="49" charset="0"/>
-                <a:cs typeface="Courier New" panose="02070309020205020404" pitchFamily="49" charset="0"/>
-              </a:rPr>
-              <a:t> = “</a:t>
-            </a:r>
-            <a:r>
-              <a:rPr lang="en-US" sz="1400" dirty="0" err="1">
-                <a:latin typeface="Courier New" panose="02070309020205020404" pitchFamily="49" charset="0"/>
-                <a:cs typeface="Courier New" panose="02070309020205020404" pitchFamily="49" charset="0"/>
-              </a:rPr>
-              <a:t>StepUp_Xfmr_n</a:t>
             </a:r>
             <a:r>
               <a:rPr lang="en-US" sz="1400" dirty="0">
@@ -16886,7 +17010,7 @@
         </p:nvSpPr>
         <p:spPr>
           <a:xfrm>
-            <a:off x="7177619" y="431739"/>
+            <a:off x="7631677" y="2708328"/>
             <a:ext cx="2344440" cy="215444"/>
           </a:xfrm>
           <a:prstGeom prst="rect">
@@ -16953,7 +17077,7 @@
         </p:nvSpPr>
         <p:spPr>
           <a:xfrm>
-            <a:off x="8480084" y="3192458"/>
+            <a:off x="6700983" y="3977649"/>
             <a:ext cx="2184973" cy="215444"/>
           </a:xfrm>
           <a:prstGeom prst="rect">
@@ -17023,7 +17147,7 @@
         </p:nvCxnSpPr>
         <p:spPr>
           <a:xfrm flipH="1" flipV="1">
-            <a:off x="7470312" y="2607139"/>
+            <a:off x="5691211" y="3392330"/>
             <a:ext cx="1009772" cy="693041"/>
           </a:xfrm>
           <a:prstGeom prst="straightConnector1">
@@ -17305,185 +17429,6 @@
           </p:txBody>
         </p:sp>
       </p:grpSp>
-      <p:grpSp>
-        <p:nvGrpSpPr>
-          <p:cNvPr id="48" name="Grupo 47">
-            <a:extLst>
-              <a:ext uri="{FF2B5EF4-FFF2-40B4-BE49-F238E27FC236}">
-                <a16:creationId xmlns:a16="http://schemas.microsoft.com/office/drawing/2014/main" id="{5611D643-9A9F-7961-7F2E-5EF5D943F2B0}"/>
-              </a:ext>
-            </a:extLst>
-          </p:cNvPr>
-          <p:cNvGrpSpPr/>
-          <p:nvPr/>
-        </p:nvGrpSpPr>
-        <p:grpSpPr>
-          <a:xfrm>
-            <a:off x="5630972" y="868376"/>
-            <a:ext cx="659272" cy="471329"/>
-            <a:chOff x="4572550" y="804425"/>
-            <a:chExt cx="659272" cy="471329"/>
-          </a:xfrm>
-        </p:grpSpPr>
-        <p:sp>
-          <p:nvSpPr>
-            <p:cNvPr id="11" name="Elipse 10">
-              <a:extLst>
-                <a:ext uri="{FF2B5EF4-FFF2-40B4-BE49-F238E27FC236}">
-                  <a16:creationId xmlns:a16="http://schemas.microsoft.com/office/drawing/2014/main" id="{6C1BFBF2-7A71-4234-E500-5F6B7EE5CB69}"/>
-                </a:ext>
-              </a:extLst>
-            </p:cNvPr>
-            <p:cNvSpPr/>
-            <p:nvPr/>
-          </p:nvSpPr>
-          <p:spPr bwMode="ltGray">
-            <a:xfrm>
-              <a:off x="4572550" y="807754"/>
-              <a:ext cx="468000" cy="468000"/>
-            </a:xfrm>
-            <a:prstGeom prst="ellipse">
-              <a:avLst/>
-            </a:prstGeom>
-            <a:noFill/>
-            <a:ln w="25400">
-              <a:solidFill>
-                <a:schemeClr val="tx1"/>
-              </a:solidFill>
-            </a:ln>
-          </p:spPr>
-          <p:style>
-            <a:lnRef idx="2">
-              <a:schemeClr val="accent1">
-                <a:shade val="50000"/>
-              </a:schemeClr>
-            </a:lnRef>
-            <a:fillRef idx="1">
-              <a:schemeClr val="accent1"/>
-            </a:fillRef>
-            <a:effectRef idx="0">
-              <a:schemeClr val="accent1"/>
-            </a:effectRef>
-            <a:fontRef idx="minor">
-              <a:schemeClr val="lt1"/>
-            </a:fontRef>
-          </p:style>
-          <p:txBody>
-            <a:bodyPr rot="0" spcFirstLastPara="0" vertOverflow="overflow" horzOverflow="overflow" vert="horz" wrap="square" lIns="91440" tIns="45720" rIns="91440" bIns="45720" numCol="1" spcCol="0" rtlCol="0" fromWordArt="0" anchor="t" anchorCtr="0" forceAA="0" compatLnSpc="1">
-              <a:prstTxWarp prst="textNoShape">
-                <a:avLst/>
-              </a:prstTxWarp>
-              <a:noAutofit/>
-            </a:bodyPr>
-            <a:lstStyle/>
-            <a:p>
-              <a:pPr algn="l"/>
-              <a:endParaRPr lang="en-US" sz="1600" b="0" dirty="0" err="1"/>
-            </a:p>
-          </p:txBody>
-        </p:sp>
-        <p:sp>
-          <p:nvSpPr>
-            <p:cNvPr id="12" name="Elipse 11">
-              <a:extLst>
-                <a:ext uri="{FF2B5EF4-FFF2-40B4-BE49-F238E27FC236}">
-                  <a16:creationId xmlns:a16="http://schemas.microsoft.com/office/drawing/2014/main" id="{F7D74CC1-BEE3-0B4A-7CA9-F7B8B1346ECB}"/>
-                </a:ext>
-              </a:extLst>
-            </p:cNvPr>
-            <p:cNvSpPr/>
-            <p:nvPr/>
-          </p:nvSpPr>
-          <p:spPr bwMode="ltGray">
-            <a:xfrm>
-              <a:off x="4763822" y="804425"/>
-              <a:ext cx="468000" cy="468000"/>
-            </a:xfrm>
-            <a:prstGeom prst="ellipse">
-              <a:avLst/>
-            </a:prstGeom>
-            <a:noFill/>
-            <a:ln w="25400">
-              <a:solidFill>
-                <a:schemeClr val="tx1"/>
-              </a:solidFill>
-            </a:ln>
-          </p:spPr>
-          <p:style>
-            <a:lnRef idx="2">
-              <a:schemeClr val="accent1">
-                <a:shade val="50000"/>
-              </a:schemeClr>
-            </a:lnRef>
-            <a:fillRef idx="1">
-              <a:schemeClr val="accent1"/>
-            </a:fillRef>
-            <a:effectRef idx="0">
-              <a:schemeClr val="accent1"/>
-            </a:effectRef>
-            <a:fontRef idx="minor">
-              <a:schemeClr val="lt1"/>
-            </a:fontRef>
-          </p:style>
-          <p:txBody>
-            <a:bodyPr rot="0" spcFirstLastPara="0" vertOverflow="overflow" horzOverflow="overflow" vert="horz" wrap="square" lIns="91440" tIns="45720" rIns="91440" bIns="45720" numCol="1" spcCol="0" rtlCol="0" fromWordArt="0" anchor="t" anchorCtr="0" forceAA="0" compatLnSpc="1">
-              <a:prstTxWarp prst="textNoShape">
-                <a:avLst/>
-              </a:prstTxWarp>
-              <a:noAutofit/>
-            </a:bodyPr>
-            <a:lstStyle/>
-            <a:p>
-              <a:pPr algn="l"/>
-              <a:endParaRPr lang="en-US" sz="1600" b="0" dirty="0" err="1"/>
-            </a:p>
-          </p:txBody>
-        </p:sp>
-      </p:grpSp>
-      <p:cxnSp>
-        <p:nvCxnSpPr>
-          <p:cNvPr id="13" name="Conector recto 12">
-            <a:extLst>
-              <a:ext uri="{FF2B5EF4-FFF2-40B4-BE49-F238E27FC236}">
-                <a16:creationId xmlns:a16="http://schemas.microsoft.com/office/drawing/2014/main" id="{ADA46642-9A30-F44B-F1EA-08E38FC1F970}"/>
-              </a:ext>
-            </a:extLst>
-          </p:cNvPr>
-          <p:cNvCxnSpPr>
-            <a:cxnSpLocks/>
-          </p:cNvCxnSpPr>
-          <p:nvPr/>
-        </p:nvCxnSpPr>
-        <p:spPr>
-          <a:xfrm>
-            <a:off x="6300711" y="1103497"/>
-            <a:ext cx="1060189" cy="0"/>
-          </a:xfrm>
-          <a:prstGeom prst="line">
-            <a:avLst/>
-          </a:prstGeom>
-          <a:ln w="25400">
-            <a:solidFill>
-              <a:schemeClr val="tx1"/>
-            </a:solidFill>
-            <a:tailEnd type="none"/>
-          </a:ln>
-        </p:spPr>
-        <p:style>
-          <a:lnRef idx="1">
-            <a:schemeClr val="accent1"/>
-          </a:lnRef>
-          <a:fillRef idx="0">
-            <a:schemeClr val="accent1"/>
-          </a:fillRef>
-          <a:effectRef idx="0">
-            <a:schemeClr val="accent1"/>
-          </a:effectRef>
-          <a:fontRef idx="minor">
-            <a:schemeClr val="tx1"/>
-          </a:fontRef>
-        </p:style>
-      </p:cxnSp>
       <p:cxnSp>
         <p:nvCxnSpPr>
           <p:cNvPr id="14" name="Conector recto 13">
@@ -17500,7 +17445,7 @@
         </p:nvCxnSpPr>
         <p:spPr>
           <a:xfrm>
-            <a:off x="7360900" y="817130"/>
+            <a:off x="5640372" y="817130"/>
             <a:ext cx="0" cy="3268215"/>
           </a:xfrm>
           <a:prstGeom prst="line">
@@ -17542,7 +17487,7 @@
         </p:nvSpPr>
         <p:spPr>
           <a:xfrm>
-            <a:off x="311714" y="5158443"/>
+            <a:off x="5160446" y="5122347"/>
             <a:ext cx="6538444" cy="923330"/>
           </a:xfrm>
           <a:prstGeom prst="rect">
@@ -17570,7 +17515,7 @@
             </a:r>
             <a:r>
               <a:rPr lang="en-US" sz="2000" dirty="0"/>
-              <a:t> multiple WT/PV/BESS + Aux Load</a:t>
+              <a:t> multiple WT/PV + Aux Load</a:t>
             </a:r>
           </a:p>
           <a:p>
@@ -17591,57 +17536,11 @@
             </a:r>
             <a:r>
               <a:rPr lang="en-US" sz="2000" dirty="0"/>
-              <a:t> multiple WT/PV/BESS + Aux Load + Line</a:t>
+              <a:t> multiple WT/PV + Aux Load + Line</a:t>
             </a:r>
           </a:p>
         </p:txBody>
       </p:sp>
-      <p:cxnSp>
-        <p:nvCxnSpPr>
-          <p:cNvPr id="17" name="Conector recto 16">
-            <a:extLst>
-              <a:ext uri="{FF2B5EF4-FFF2-40B4-BE49-F238E27FC236}">
-                <a16:creationId xmlns:a16="http://schemas.microsoft.com/office/drawing/2014/main" id="{41C3C4FC-B0C0-A82C-D605-860CAB617B00}"/>
-              </a:ext>
-            </a:extLst>
-          </p:cNvPr>
-          <p:cNvCxnSpPr>
-            <a:cxnSpLocks/>
-            <a:stCxn id="53" idx="6"/>
-            <a:endCxn id="18" idx="1"/>
-          </p:cNvCxnSpPr>
-          <p:nvPr/>
-        </p:nvCxnSpPr>
-        <p:spPr>
-          <a:xfrm>
-            <a:off x="8664528" y="1102376"/>
-            <a:ext cx="779625" cy="0"/>
-          </a:xfrm>
-          <a:prstGeom prst="line">
-            <a:avLst/>
-          </a:prstGeom>
-          <a:ln w="25400">
-            <a:solidFill>
-              <a:schemeClr val="tx1"/>
-            </a:solidFill>
-            <a:tailEnd type="none"/>
-          </a:ln>
-        </p:spPr>
-        <p:style>
-          <a:lnRef idx="1">
-            <a:schemeClr val="accent1"/>
-          </a:lnRef>
-          <a:fillRef idx="0">
-            <a:schemeClr val="accent1"/>
-          </a:fillRef>
-          <a:effectRef idx="0">
-            <a:schemeClr val="accent1"/>
-          </a:effectRef>
-          <a:fontRef idx="minor">
-            <a:schemeClr val="tx1"/>
-          </a:fontRef>
-        </p:style>
-      </p:cxnSp>
       <p:sp>
         <p:nvSpPr>
           <p:cNvPr id="18" name="Rectángulo 17">
@@ -17656,7 +17555,7 @@
         </p:nvSpPr>
         <p:spPr bwMode="ltGray">
           <a:xfrm>
-            <a:off x="9444153" y="959808"/>
+            <a:off x="6291871" y="2283288"/>
             <a:ext cx="1130710" cy="285136"/>
           </a:xfrm>
           <a:prstGeom prst="rect">
@@ -17715,7 +17614,7 @@
         </p:nvCxnSpPr>
         <p:spPr>
           <a:xfrm>
-            <a:off x="10574863" y="1102376"/>
+            <a:off x="7422581" y="2425856"/>
             <a:ext cx="900000" cy="0"/>
           </a:xfrm>
           <a:prstGeom prst="line">
@@ -17759,7 +17658,7 @@
         </p:nvCxnSpPr>
         <p:spPr>
           <a:xfrm>
-            <a:off x="11492996" y="814376"/>
+            <a:off x="9964985" y="2137856"/>
             <a:ext cx="0" cy="576000"/>
           </a:xfrm>
           <a:prstGeom prst="line">
@@ -17801,7 +17700,7 @@
         </p:nvSpPr>
         <p:spPr>
           <a:xfrm>
-            <a:off x="11277392" y="1462377"/>
+            <a:off x="9749381" y="1787230"/>
             <a:ext cx="431208" cy="246221"/>
           </a:xfrm>
           <a:prstGeom prst="rect">
@@ -17836,7 +17735,7 @@
         </p:nvSpPr>
         <p:spPr>
           <a:xfrm>
-            <a:off x="9231645" y="1330650"/>
+            <a:off x="6115456" y="2654130"/>
             <a:ext cx="1508659" cy="215444"/>
           </a:xfrm>
           <a:prstGeom prst="rect">
@@ -17872,7 +17771,7 @@
         </p:nvSpPr>
         <p:spPr bwMode="ltGray">
           <a:xfrm>
-            <a:off x="9144861" y="585061"/>
+            <a:off x="5992579" y="1908541"/>
             <a:ext cx="1729293" cy="1123537"/>
           </a:xfrm>
           <a:prstGeom prst="rect">
@@ -18140,185 +18039,6 @@
           </p:txBody>
         </p:sp>
       </p:grpSp>
-      <p:grpSp>
-        <p:nvGrpSpPr>
-          <p:cNvPr id="49" name="Grupo 48">
-            <a:extLst>
-              <a:ext uri="{FF2B5EF4-FFF2-40B4-BE49-F238E27FC236}">
-                <a16:creationId xmlns:a16="http://schemas.microsoft.com/office/drawing/2014/main" id="{19C4C2C6-D57B-C860-BEAE-28AE57659C3A}"/>
-              </a:ext>
-            </a:extLst>
-          </p:cNvPr>
-          <p:cNvGrpSpPr/>
-          <p:nvPr/>
-        </p:nvGrpSpPr>
-        <p:grpSpPr>
-          <a:xfrm>
-            <a:off x="5630972" y="1711391"/>
-            <a:ext cx="659272" cy="471329"/>
-            <a:chOff x="4572550" y="1647440"/>
-            <a:chExt cx="659272" cy="471329"/>
-          </a:xfrm>
-        </p:grpSpPr>
-        <p:sp>
-          <p:nvSpPr>
-            <p:cNvPr id="29" name="Elipse 28">
-              <a:extLst>
-                <a:ext uri="{FF2B5EF4-FFF2-40B4-BE49-F238E27FC236}">
-                  <a16:creationId xmlns:a16="http://schemas.microsoft.com/office/drawing/2014/main" id="{0E21FB0E-FBC2-9F4F-58AD-172EDE398D44}"/>
-                </a:ext>
-              </a:extLst>
-            </p:cNvPr>
-            <p:cNvSpPr/>
-            <p:nvPr/>
-          </p:nvSpPr>
-          <p:spPr bwMode="ltGray">
-            <a:xfrm>
-              <a:off x="4572550" y="1650769"/>
-              <a:ext cx="468000" cy="468000"/>
-            </a:xfrm>
-            <a:prstGeom prst="ellipse">
-              <a:avLst/>
-            </a:prstGeom>
-            <a:noFill/>
-            <a:ln w="25400">
-              <a:solidFill>
-                <a:schemeClr val="tx1"/>
-              </a:solidFill>
-            </a:ln>
-          </p:spPr>
-          <p:style>
-            <a:lnRef idx="2">
-              <a:schemeClr val="accent1">
-                <a:shade val="50000"/>
-              </a:schemeClr>
-            </a:lnRef>
-            <a:fillRef idx="1">
-              <a:schemeClr val="accent1"/>
-            </a:fillRef>
-            <a:effectRef idx="0">
-              <a:schemeClr val="accent1"/>
-            </a:effectRef>
-            <a:fontRef idx="minor">
-              <a:schemeClr val="lt1"/>
-            </a:fontRef>
-          </p:style>
-          <p:txBody>
-            <a:bodyPr rot="0" spcFirstLastPara="0" vertOverflow="overflow" horzOverflow="overflow" vert="horz" wrap="square" lIns="91440" tIns="45720" rIns="91440" bIns="45720" numCol="1" spcCol="0" rtlCol="0" fromWordArt="0" anchor="t" anchorCtr="0" forceAA="0" compatLnSpc="1">
-              <a:prstTxWarp prst="textNoShape">
-                <a:avLst/>
-              </a:prstTxWarp>
-              <a:noAutofit/>
-            </a:bodyPr>
-            <a:lstStyle/>
-            <a:p>
-              <a:pPr algn="l"/>
-              <a:endParaRPr lang="en-US" sz="1600" b="0" dirty="0" err="1"/>
-            </a:p>
-          </p:txBody>
-        </p:sp>
-        <p:sp>
-          <p:nvSpPr>
-            <p:cNvPr id="30" name="Elipse 29">
-              <a:extLst>
-                <a:ext uri="{FF2B5EF4-FFF2-40B4-BE49-F238E27FC236}">
-                  <a16:creationId xmlns:a16="http://schemas.microsoft.com/office/drawing/2014/main" id="{06612040-6C33-980E-50F2-8DFBF05E7E47}"/>
-                </a:ext>
-              </a:extLst>
-            </p:cNvPr>
-            <p:cNvSpPr/>
-            <p:nvPr/>
-          </p:nvSpPr>
-          <p:spPr bwMode="ltGray">
-            <a:xfrm>
-              <a:off x="4763822" y="1647440"/>
-              <a:ext cx="468000" cy="468000"/>
-            </a:xfrm>
-            <a:prstGeom prst="ellipse">
-              <a:avLst/>
-            </a:prstGeom>
-            <a:noFill/>
-            <a:ln w="25400">
-              <a:solidFill>
-                <a:schemeClr val="tx1"/>
-              </a:solidFill>
-            </a:ln>
-          </p:spPr>
-          <p:style>
-            <a:lnRef idx="2">
-              <a:schemeClr val="accent1">
-                <a:shade val="50000"/>
-              </a:schemeClr>
-            </a:lnRef>
-            <a:fillRef idx="1">
-              <a:schemeClr val="accent1"/>
-            </a:fillRef>
-            <a:effectRef idx="0">
-              <a:schemeClr val="accent1"/>
-            </a:effectRef>
-            <a:fontRef idx="minor">
-              <a:schemeClr val="lt1"/>
-            </a:fontRef>
-          </p:style>
-          <p:txBody>
-            <a:bodyPr rot="0" spcFirstLastPara="0" vertOverflow="overflow" horzOverflow="overflow" vert="horz" wrap="square" lIns="91440" tIns="45720" rIns="91440" bIns="45720" numCol="1" spcCol="0" rtlCol="0" fromWordArt="0" anchor="t" anchorCtr="0" forceAA="0" compatLnSpc="1">
-              <a:prstTxWarp prst="textNoShape">
-                <a:avLst/>
-              </a:prstTxWarp>
-              <a:noAutofit/>
-            </a:bodyPr>
-            <a:lstStyle/>
-            <a:p>
-              <a:pPr algn="l"/>
-              <a:endParaRPr lang="en-US" sz="1600" b="0" dirty="0" err="1"/>
-            </a:p>
-          </p:txBody>
-        </p:sp>
-      </p:grpSp>
-      <p:cxnSp>
-        <p:nvCxnSpPr>
-          <p:cNvPr id="31" name="Conector recto 30">
-            <a:extLst>
-              <a:ext uri="{FF2B5EF4-FFF2-40B4-BE49-F238E27FC236}">
-                <a16:creationId xmlns:a16="http://schemas.microsoft.com/office/drawing/2014/main" id="{017A04F5-169E-5B9A-1345-F6D0C6E3FA03}"/>
-              </a:ext>
-            </a:extLst>
-          </p:cNvPr>
-          <p:cNvCxnSpPr>
-            <a:cxnSpLocks/>
-          </p:cNvCxnSpPr>
-          <p:nvPr/>
-        </p:nvCxnSpPr>
-        <p:spPr>
-          <a:xfrm>
-            <a:off x="6300711" y="1946512"/>
-            <a:ext cx="1060189" cy="0"/>
-          </a:xfrm>
-          <a:prstGeom prst="line">
-            <a:avLst/>
-          </a:prstGeom>
-          <a:ln w="25400">
-            <a:solidFill>
-              <a:schemeClr val="tx1"/>
-            </a:solidFill>
-            <a:tailEnd type="none"/>
-          </a:ln>
-        </p:spPr>
-        <p:style>
-          <a:lnRef idx="1">
-            <a:schemeClr val="accent1"/>
-          </a:lnRef>
-          <a:fillRef idx="0">
-            <a:schemeClr val="accent1"/>
-          </a:fillRef>
-          <a:effectRef idx="0">
-            <a:schemeClr val="accent1"/>
-          </a:effectRef>
-          <a:fontRef idx="minor">
-            <a:schemeClr val="tx1"/>
-          </a:fontRef>
-        </p:style>
-      </p:cxnSp>
       <p:cxnSp>
         <p:nvCxnSpPr>
           <p:cNvPr id="32" name="Conector recto 31">
@@ -18545,185 +18265,6 @@
       </p:grpSp>
       <p:grpSp>
         <p:nvGrpSpPr>
-          <p:cNvPr id="50" name="Grupo 49">
-            <a:extLst>
-              <a:ext uri="{FF2B5EF4-FFF2-40B4-BE49-F238E27FC236}">
-                <a16:creationId xmlns:a16="http://schemas.microsoft.com/office/drawing/2014/main" id="{7FC0A988-4416-7349-762E-07019326C893}"/>
-              </a:ext>
-            </a:extLst>
-          </p:cNvPr>
-          <p:cNvGrpSpPr/>
-          <p:nvPr/>
-        </p:nvGrpSpPr>
-        <p:grpSpPr>
-          <a:xfrm>
-            <a:off x="5648008" y="3192737"/>
-            <a:ext cx="659272" cy="471329"/>
-            <a:chOff x="4589586" y="3128786"/>
-            <a:chExt cx="659272" cy="471329"/>
-          </a:xfrm>
-        </p:grpSpPr>
-        <p:sp>
-          <p:nvSpPr>
-            <p:cNvPr id="36" name="Elipse 35">
-              <a:extLst>
-                <a:ext uri="{FF2B5EF4-FFF2-40B4-BE49-F238E27FC236}">
-                  <a16:creationId xmlns:a16="http://schemas.microsoft.com/office/drawing/2014/main" id="{9413B694-31C7-4595-F479-221CDBDCEBF8}"/>
-                </a:ext>
-              </a:extLst>
-            </p:cNvPr>
-            <p:cNvSpPr/>
-            <p:nvPr/>
-          </p:nvSpPr>
-          <p:spPr bwMode="ltGray">
-            <a:xfrm>
-              <a:off x="4589586" y="3132115"/>
-              <a:ext cx="468000" cy="468000"/>
-            </a:xfrm>
-            <a:prstGeom prst="ellipse">
-              <a:avLst/>
-            </a:prstGeom>
-            <a:noFill/>
-            <a:ln w="25400">
-              <a:solidFill>
-                <a:schemeClr val="tx1"/>
-              </a:solidFill>
-            </a:ln>
-          </p:spPr>
-          <p:style>
-            <a:lnRef idx="2">
-              <a:schemeClr val="accent1">
-                <a:shade val="50000"/>
-              </a:schemeClr>
-            </a:lnRef>
-            <a:fillRef idx="1">
-              <a:schemeClr val="accent1"/>
-            </a:fillRef>
-            <a:effectRef idx="0">
-              <a:schemeClr val="accent1"/>
-            </a:effectRef>
-            <a:fontRef idx="minor">
-              <a:schemeClr val="lt1"/>
-            </a:fontRef>
-          </p:style>
-          <p:txBody>
-            <a:bodyPr rot="0" spcFirstLastPara="0" vertOverflow="overflow" horzOverflow="overflow" vert="horz" wrap="square" lIns="91440" tIns="45720" rIns="91440" bIns="45720" numCol="1" spcCol="0" rtlCol="0" fromWordArt="0" anchor="t" anchorCtr="0" forceAA="0" compatLnSpc="1">
-              <a:prstTxWarp prst="textNoShape">
-                <a:avLst/>
-              </a:prstTxWarp>
-              <a:noAutofit/>
-            </a:bodyPr>
-            <a:lstStyle/>
-            <a:p>
-              <a:pPr algn="l"/>
-              <a:endParaRPr lang="en-US" sz="1600" b="0" dirty="0" err="1"/>
-            </a:p>
-          </p:txBody>
-        </p:sp>
-        <p:sp>
-          <p:nvSpPr>
-            <p:cNvPr id="37" name="Elipse 36">
-              <a:extLst>
-                <a:ext uri="{FF2B5EF4-FFF2-40B4-BE49-F238E27FC236}">
-                  <a16:creationId xmlns:a16="http://schemas.microsoft.com/office/drawing/2014/main" id="{514581E2-EE27-EE86-73DB-3BD938798124}"/>
-                </a:ext>
-              </a:extLst>
-            </p:cNvPr>
-            <p:cNvSpPr/>
-            <p:nvPr/>
-          </p:nvSpPr>
-          <p:spPr bwMode="ltGray">
-            <a:xfrm>
-              <a:off x="4780858" y="3128786"/>
-              <a:ext cx="468000" cy="468000"/>
-            </a:xfrm>
-            <a:prstGeom prst="ellipse">
-              <a:avLst/>
-            </a:prstGeom>
-            <a:noFill/>
-            <a:ln w="25400">
-              <a:solidFill>
-                <a:schemeClr val="tx1"/>
-              </a:solidFill>
-            </a:ln>
-          </p:spPr>
-          <p:style>
-            <a:lnRef idx="2">
-              <a:schemeClr val="accent1">
-                <a:shade val="50000"/>
-              </a:schemeClr>
-            </a:lnRef>
-            <a:fillRef idx="1">
-              <a:schemeClr val="accent1"/>
-            </a:fillRef>
-            <a:effectRef idx="0">
-              <a:schemeClr val="accent1"/>
-            </a:effectRef>
-            <a:fontRef idx="minor">
-              <a:schemeClr val="lt1"/>
-            </a:fontRef>
-          </p:style>
-          <p:txBody>
-            <a:bodyPr rot="0" spcFirstLastPara="0" vertOverflow="overflow" horzOverflow="overflow" vert="horz" wrap="square" lIns="91440" tIns="45720" rIns="91440" bIns="45720" numCol="1" spcCol="0" rtlCol="0" fromWordArt="0" anchor="t" anchorCtr="0" forceAA="0" compatLnSpc="1">
-              <a:prstTxWarp prst="textNoShape">
-                <a:avLst/>
-              </a:prstTxWarp>
-              <a:noAutofit/>
-            </a:bodyPr>
-            <a:lstStyle/>
-            <a:p>
-              <a:pPr algn="l"/>
-              <a:endParaRPr lang="en-US" sz="1600" b="0" dirty="0" err="1"/>
-            </a:p>
-          </p:txBody>
-        </p:sp>
-      </p:grpSp>
-      <p:cxnSp>
-        <p:nvCxnSpPr>
-          <p:cNvPr id="38" name="Conector recto 37">
-            <a:extLst>
-              <a:ext uri="{FF2B5EF4-FFF2-40B4-BE49-F238E27FC236}">
-                <a16:creationId xmlns:a16="http://schemas.microsoft.com/office/drawing/2014/main" id="{3665E9F0-701C-A024-D1A2-2C9197804D42}"/>
-              </a:ext>
-            </a:extLst>
-          </p:cNvPr>
-          <p:cNvCxnSpPr>
-            <a:cxnSpLocks/>
-          </p:cNvCxnSpPr>
-          <p:nvPr/>
-        </p:nvCxnSpPr>
-        <p:spPr>
-          <a:xfrm>
-            <a:off x="6317747" y="3427858"/>
-            <a:ext cx="1060189" cy="0"/>
-          </a:xfrm>
-          <a:prstGeom prst="line">
-            <a:avLst/>
-          </a:prstGeom>
-          <a:ln w="25400">
-            <a:solidFill>
-              <a:schemeClr val="tx1"/>
-            </a:solidFill>
-            <a:tailEnd type="none"/>
-          </a:ln>
-        </p:spPr>
-        <p:style>
-          <a:lnRef idx="1">
-            <a:schemeClr val="accent1"/>
-          </a:lnRef>
-          <a:fillRef idx="0">
-            <a:schemeClr val="accent1"/>
-          </a:fillRef>
-          <a:effectRef idx="0">
-            <a:schemeClr val="accent1"/>
-          </a:effectRef>
-          <a:fontRef idx="minor">
-            <a:schemeClr val="tx1"/>
-          </a:fontRef>
-        </p:style>
-      </p:cxnSp>
-      <p:grpSp>
-        <p:nvGrpSpPr>
           <p:cNvPr id="46" name="Grupo 45">
             <a:extLst>
               <a:ext uri="{FF2B5EF4-FFF2-40B4-BE49-F238E27FC236}">
@@ -18736,8 +18277,8 @@
         </p:nvGrpSpPr>
         <p:grpSpPr>
           <a:xfrm>
-            <a:off x="5913512" y="2405966"/>
-            <a:ext cx="113767" cy="492854"/>
+            <a:off x="5059257" y="2405966"/>
+            <a:ext cx="113768" cy="492854"/>
             <a:chOff x="4166832" y="2135537"/>
             <a:chExt cx="113767" cy="492854"/>
           </a:xfrm>
@@ -18931,14 +18472,13 @@
           </p:cNvPr>
           <p:cNvCxnSpPr>
             <a:cxnSpLocks/>
-            <a:endCxn id="52" idx="2"/>
           </p:cNvCxnSpPr>
           <p:nvPr/>
         </p:nvCxnSpPr>
         <p:spPr>
           <a:xfrm>
-            <a:off x="7335237" y="1102376"/>
-            <a:ext cx="670019" cy="3329"/>
+            <a:off x="5614708" y="2425856"/>
+            <a:ext cx="670020" cy="3329"/>
           </a:xfrm>
           <a:prstGeom prst="line">
             <a:avLst/>
@@ -18979,7 +18519,7 @@
         </p:nvGrpSpPr>
         <p:grpSpPr>
           <a:xfrm>
-            <a:off x="8005256" y="868376"/>
+            <a:off x="8318082" y="2191856"/>
             <a:ext cx="659272" cy="471329"/>
             <a:chOff x="4572550" y="804425"/>
             <a:chExt cx="659272" cy="471329"/>
@@ -19116,8 +18656,8 @@
         </p:nvCxnSpPr>
         <p:spPr>
           <a:xfrm>
-            <a:off x="6770965" y="3792136"/>
-            <a:ext cx="560439" cy="0"/>
+            <a:off x="4665419" y="3786738"/>
+            <a:ext cx="945457" cy="5398"/>
           </a:xfrm>
           <a:prstGeom prst="line">
             <a:avLst/>
@@ -19160,7 +18700,7 @@
         </p:nvCxnSpPr>
         <p:spPr>
           <a:xfrm>
-            <a:off x="6785714" y="3796278"/>
+            <a:off x="4668138" y="3796278"/>
             <a:ext cx="0" cy="426582"/>
           </a:xfrm>
           <a:prstGeom prst="line">
@@ -19202,7 +18742,7 @@
         </p:nvGrpSpPr>
         <p:grpSpPr>
           <a:xfrm rot="5400000">
-            <a:off x="6456077" y="4315414"/>
+            <a:off x="4338501" y="4315414"/>
             <a:ext cx="659272" cy="471329"/>
             <a:chOff x="3884292" y="2200605"/>
             <a:chExt cx="659272" cy="471329"/>
@@ -19339,7 +18879,7 @@
         </p:nvCxnSpPr>
         <p:spPr>
           <a:xfrm>
-            <a:off x="6770965" y="4880715"/>
+            <a:off x="4665419" y="4880715"/>
             <a:ext cx="0" cy="247487"/>
           </a:xfrm>
           <a:prstGeom prst="line">
@@ -19381,8 +18921,8 @@
         </p:nvSpPr>
         <p:spPr bwMode="ltGray">
           <a:xfrm>
-            <a:off x="6554965" y="5075060"/>
-            <a:ext cx="432000" cy="553651"/>
+            <a:off x="4449421" y="5075060"/>
+            <a:ext cx="432001" cy="553651"/>
           </a:xfrm>
           <a:prstGeom prst="downArrow">
             <a:avLst/>
@@ -19766,179 +19306,6 @@
       </p:sp>
       <p:sp>
         <p:nvSpPr>
-          <p:cNvPr id="59" name="CuadroTexto 58">
-            <a:extLst>
-              <a:ext uri="{FF2B5EF4-FFF2-40B4-BE49-F238E27FC236}">
-                <a16:creationId xmlns:a16="http://schemas.microsoft.com/office/drawing/2014/main" id="{EC94A037-C994-A096-E237-EB814A33DF6F}"/>
-              </a:ext>
-            </a:extLst>
-          </p:cNvPr>
-          <p:cNvSpPr txBox="1"/>
-          <p:nvPr/>
-        </p:nvSpPr>
-        <p:spPr>
-          <a:xfrm>
-            <a:off x="4492813" y="647030"/>
-            <a:ext cx="2877669" cy="215444"/>
-          </a:xfrm>
-          <a:prstGeom prst="rect">
-            <a:avLst/>
-          </a:prstGeom>
-          <a:noFill/>
-        </p:spPr>
-        <p:txBody>
-          <a:bodyPr wrap="square" lIns="0" tIns="0" rIns="0" bIns="0" rtlCol="0">
-            <a:spAutoFit/>
-          </a:bodyPr>
-          <a:lstStyle/>
-          <a:p>
-            <a:pPr algn="ctr"/>
-            <a:r>
-              <a:rPr lang="en-US" sz="1400" dirty="0">
-                <a:latin typeface="Courier New" panose="02070309020205020404" pitchFamily="49" charset="0"/>
-                <a:cs typeface="Courier New" panose="02070309020205020404" pitchFamily="49" charset="0"/>
-              </a:rPr>
-              <a:t>id/</a:t>
-            </a:r>
-            <a:r>
-              <a:rPr lang="en-US" sz="1400" dirty="0" err="1">
-                <a:latin typeface="Courier New" panose="02070309020205020404" pitchFamily="49" charset="0"/>
-                <a:cs typeface="Courier New" panose="02070309020205020404" pitchFamily="49" charset="0"/>
-              </a:rPr>
-              <a:t>parId</a:t>
-            </a:r>
-            <a:r>
-              <a:rPr lang="en-US" sz="1400" dirty="0">
-                <a:latin typeface="Courier New" panose="02070309020205020404" pitchFamily="49" charset="0"/>
-                <a:cs typeface="Courier New" panose="02070309020205020404" pitchFamily="49" charset="0"/>
-              </a:rPr>
-              <a:t> = “StepUp_Xfmr_1”</a:t>
-            </a:r>
-          </a:p>
-        </p:txBody>
-      </p:sp>
-      <p:sp>
-        <p:nvSpPr>
-          <p:cNvPr id="60" name="CuadroTexto 59">
-            <a:extLst>
-              <a:ext uri="{FF2B5EF4-FFF2-40B4-BE49-F238E27FC236}">
-                <a16:creationId xmlns:a16="http://schemas.microsoft.com/office/drawing/2014/main" id="{60223174-51C6-9B7C-D62F-A5F0BBA4D0F1}"/>
-              </a:ext>
-            </a:extLst>
-          </p:cNvPr>
-          <p:cNvSpPr txBox="1"/>
-          <p:nvPr/>
-        </p:nvSpPr>
-        <p:spPr>
-          <a:xfrm>
-            <a:off x="4501448" y="1499249"/>
-            <a:ext cx="2877669" cy="215444"/>
-          </a:xfrm>
-          <a:prstGeom prst="rect">
-            <a:avLst/>
-          </a:prstGeom>
-          <a:noFill/>
-        </p:spPr>
-        <p:txBody>
-          <a:bodyPr wrap="square" lIns="0" tIns="0" rIns="0" bIns="0" rtlCol="0">
-            <a:spAutoFit/>
-          </a:bodyPr>
-          <a:lstStyle/>
-          <a:p>
-            <a:pPr algn="ctr"/>
-            <a:r>
-              <a:rPr lang="en-US" sz="1400" dirty="0">
-                <a:latin typeface="Courier New" panose="02070309020205020404" pitchFamily="49" charset="0"/>
-                <a:cs typeface="Courier New" panose="02070309020205020404" pitchFamily="49" charset="0"/>
-              </a:rPr>
-              <a:t>id/</a:t>
-            </a:r>
-            <a:r>
-              <a:rPr lang="en-US" sz="1400" dirty="0" err="1">
-                <a:latin typeface="Courier New" panose="02070309020205020404" pitchFamily="49" charset="0"/>
-                <a:cs typeface="Courier New" panose="02070309020205020404" pitchFamily="49" charset="0"/>
-              </a:rPr>
-              <a:t>parId</a:t>
-            </a:r>
-            <a:r>
-              <a:rPr lang="en-US" sz="1400" dirty="0">
-                <a:latin typeface="Courier New" panose="02070309020205020404" pitchFamily="49" charset="0"/>
-                <a:cs typeface="Courier New" panose="02070309020205020404" pitchFamily="49" charset="0"/>
-              </a:rPr>
-              <a:t> = “StepUp_Xfmr_2”</a:t>
-            </a:r>
-          </a:p>
-        </p:txBody>
-      </p:sp>
-      <p:sp>
-        <p:nvSpPr>
-          <p:cNvPr id="61" name="CuadroTexto 60">
-            <a:extLst>
-              <a:ext uri="{FF2B5EF4-FFF2-40B4-BE49-F238E27FC236}">
-                <a16:creationId xmlns:a16="http://schemas.microsoft.com/office/drawing/2014/main" id="{9399F66E-FCE6-683D-3719-50C3D1FB5941}"/>
-              </a:ext>
-            </a:extLst>
-          </p:cNvPr>
-          <p:cNvSpPr txBox="1"/>
-          <p:nvPr/>
-        </p:nvSpPr>
-        <p:spPr>
-          <a:xfrm>
-            <a:off x="4501790" y="2978867"/>
-            <a:ext cx="2877669" cy="215444"/>
-          </a:xfrm>
-          <a:prstGeom prst="rect">
-            <a:avLst/>
-          </a:prstGeom>
-          <a:noFill/>
-        </p:spPr>
-        <p:txBody>
-          <a:bodyPr wrap="square" lIns="0" tIns="0" rIns="0" bIns="0" rtlCol="0">
-            <a:spAutoFit/>
-          </a:bodyPr>
-          <a:lstStyle/>
-          <a:p>
-            <a:pPr algn="ctr"/>
-            <a:r>
-              <a:rPr lang="en-US" sz="1400" dirty="0">
-                <a:latin typeface="Courier New" panose="02070309020205020404" pitchFamily="49" charset="0"/>
-                <a:cs typeface="Courier New" panose="02070309020205020404" pitchFamily="49" charset="0"/>
-              </a:rPr>
-              <a:t>id/</a:t>
-            </a:r>
-            <a:r>
-              <a:rPr lang="en-US" sz="1400" dirty="0" err="1">
-                <a:latin typeface="Courier New" panose="02070309020205020404" pitchFamily="49" charset="0"/>
-                <a:cs typeface="Courier New" panose="02070309020205020404" pitchFamily="49" charset="0"/>
-              </a:rPr>
-              <a:t>parId</a:t>
-            </a:r>
-            <a:r>
-              <a:rPr lang="en-US" sz="1400" dirty="0">
-                <a:latin typeface="Courier New" panose="02070309020205020404" pitchFamily="49" charset="0"/>
-                <a:cs typeface="Courier New" panose="02070309020205020404" pitchFamily="49" charset="0"/>
-              </a:rPr>
-              <a:t> = “</a:t>
-            </a:r>
-            <a:r>
-              <a:rPr lang="en-US" sz="1400" dirty="0" err="1">
-                <a:latin typeface="Courier New" panose="02070309020205020404" pitchFamily="49" charset="0"/>
-                <a:cs typeface="Courier New" panose="02070309020205020404" pitchFamily="49" charset="0"/>
-              </a:rPr>
-              <a:t>StepUp_Xfmr_n</a:t>
-            </a:r>
-            <a:r>
-              <a:rPr lang="en-US" sz="1400" dirty="0">
-                <a:latin typeface="Courier New" panose="02070309020205020404" pitchFamily="49" charset="0"/>
-                <a:cs typeface="Courier New" panose="02070309020205020404" pitchFamily="49" charset="0"/>
-              </a:rPr>
-              <a:t>”</a:t>
-            </a:r>
-          </a:p>
-        </p:txBody>
-      </p:sp>
-      <p:sp>
-        <p:nvSpPr>
           <p:cNvPr id="62" name="CuadroTexto 61">
             <a:extLst>
               <a:ext uri="{FF2B5EF4-FFF2-40B4-BE49-F238E27FC236}">
@@ -19951,7 +19318,7 @@
         </p:nvSpPr>
         <p:spPr>
           <a:xfrm>
-            <a:off x="7150727" y="367110"/>
+            <a:off x="7800434" y="2797498"/>
             <a:ext cx="2344440" cy="215444"/>
           </a:xfrm>
           <a:prstGeom prst="rect">
@@ -19960,7 +19327,7 @@
           <a:noFill/>
         </p:spPr>
         <p:txBody>
-          <a:bodyPr wrap="square" lIns="0" tIns="0" rIns="0" bIns="0" rtlCol="0">
+          <a:bodyPr wrap="square" lIns="0" tIns="0" rIns="0" bIns="0" rtlCol="0" anchor="t">
             <a:spAutoFit/>
           </a:bodyPr>
           <a:lstStyle/>
@@ -19968,36 +19335,36 @@
             <a:pPr algn="ctr"/>
             <a:r>
               <a:rPr lang="en-US" sz="1400" dirty="0">
-                <a:latin typeface="Courier New" panose="02070309020205020404" pitchFamily="49" charset="0"/>
-                <a:cs typeface="Courier New" panose="02070309020205020404" pitchFamily="49" charset="0"/>
+                <a:latin typeface="Courier New"/>
+                <a:cs typeface="Courier New"/>
               </a:rPr>
               <a:t>id/</a:t>
             </a:r>
             <a:r>
               <a:rPr lang="en-US" sz="1400" dirty="0" err="1">
-                <a:latin typeface="Courier New" panose="02070309020205020404" pitchFamily="49" charset="0"/>
-                <a:cs typeface="Courier New" panose="02070309020205020404" pitchFamily="49" charset="0"/>
+                <a:latin typeface="Courier New"/>
+                <a:cs typeface="Courier New"/>
               </a:rPr>
               <a:t>parId</a:t>
             </a:r>
             <a:r>
               <a:rPr lang="en-US" sz="1400" dirty="0">
-                <a:latin typeface="Courier New" panose="02070309020205020404" pitchFamily="49" charset="0"/>
-                <a:cs typeface="Courier New" panose="02070309020205020404" pitchFamily="49" charset="0"/>
+                <a:latin typeface="Courier New"/>
+                <a:cs typeface="Courier New"/>
               </a:rPr>
               <a:t> = “</a:t>
             </a:r>
             <a:r>
               <a:rPr lang="en-US" sz="1400" dirty="0" err="1">
-                <a:latin typeface="Courier New" panose="02070309020205020404" pitchFamily="49" charset="0"/>
-                <a:cs typeface="Courier New" panose="02070309020205020404" pitchFamily="49" charset="0"/>
+                <a:latin typeface="Courier New"/>
+                <a:cs typeface="Courier New"/>
               </a:rPr>
               <a:t>Main_Xfmr</a:t>
             </a:r>
             <a:r>
               <a:rPr lang="en-US" sz="1400" dirty="0">
-                <a:latin typeface="Courier New" panose="02070309020205020404" pitchFamily="49" charset="0"/>
-                <a:cs typeface="Courier New" panose="02070309020205020404" pitchFamily="49" charset="0"/>
+                <a:latin typeface="Courier New"/>
+                <a:cs typeface="Courier New"/>
               </a:rPr>
               <a:t>”</a:t>
             </a:r>
@@ -20018,7 +19385,7 @@
         </p:nvSpPr>
         <p:spPr>
           <a:xfrm>
-            <a:off x="8291729" y="1904217"/>
+            <a:off x="5524466" y="1603428"/>
             <a:ext cx="3435556" cy="215444"/>
           </a:xfrm>
           <a:prstGeom prst="rect">
@@ -20085,7 +19452,7 @@
         </p:nvSpPr>
         <p:spPr>
           <a:xfrm>
-            <a:off x="7055021" y="4551416"/>
+            <a:off x="1436256" y="4551416"/>
             <a:ext cx="2877669" cy="215444"/>
           </a:xfrm>
           <a:prstGeom prst="rect">
@@ -20152,7 +19519,7 @@
         </p:nvSpPr>
         <p:spPr>
           <a:xfrm>
-            <a:off x="7128487" y="5134075"/>
+            <a:off x="1870674" y="5134075"/>
             <a:ext cx="2366680" cy="215444"/>
           </a:xfrm>
           <a:prstGeom prst="rect">
@@ -20219,7 +19586,7 @@
         </p:nvSpPr>
         <p:spPr>
           <a:xfrm>
-            <a:off x="8480084" y="3192458"/>
+            <a:off x="6735496" y="3866229"/>
             <a:ext cx="2184973" cy="215444"/>
           </a:xfrm>
           <a:prstGeom prst="rect">
@@ -20289,7 +19656,7 @@
         </p:nvCxnSpPr>
         <p:spPr>
           <a:xfrm flipH="1" flipV="1">
-            <a:off x="7470312" y="2607139"/>
+            <a:off x="5725724" y="3280910"/>
             <a:ext cx="1009772" cy="693041"/>
           </a:xfrm>
           <a:prstGeom prst="straightConnector1">
@@ -20300,6 +19667,50 @@
               <a:srgbClr val="FF0000"/>
             </a:solidFill>
             <a:tailEnd type="triangle"/>
+          </a:ln>
+        </p:spPr>
+        <p:style>
+          <a:lnRef idx="1">
+            <a:schemeClr val="accent1"/>
+          </a:lnRef>
+          <a:fillRef idx="0">
+            <a:schemeClr val="accent1"/>
+          </a:fillRef>
+          <a:effectRef idx="0">
+            <a:schemeClr val="accent1"/>
+          </a:effectRef>
+          <a:fontRef idx="minor">
+            <a:schemeClr val="tx1"/>
+          </a:fontRef>
+        </p:style>
+      </p:cxnSp>
+      <p:cxnSp>
+        <p:nvCxnSpPr>
+          <p:cNvPr id="41" name="Conector recto 40">
+            <a:extLst>
+              <a:ext uri="{FF2B5EF4-FFF2-40B4-BE49-F238E27FC236}">
+                <a16:creationId xmlns:a16="http://schemas.microsoft.com/office/drawing/2014/main" id="{F8AB0245-F9DD-6757-E509-5F9D5BD8C9FF}"/>
+              </a:ext>
+            </a:extLst>
+          </p:cNvPr>
+          <p:cNvCxnSpPr>
+            <a:cxnSpLocks/>
+          </p:cNvCxnSpPr>
+          <p:nvPr/>
+        </p:nvCxnSpPr>
+        <p:spPr>
+          <a:xfrm>
+            <a:off x="8977354" y="2429348"/>
+            <a:ext cx="900000" cy="0"/>
+          </a:xfrm>
+          <a:prstGeom prst="line">
+            <a:avLst/>
+          </a:prstGeom>
+          <a:ln w="25400">
+            <a:solidFill>
+              <a:schemeClr val="tx1"/>
+            </a:solidFill>
+            <a:tailEnd type="none"/>
           </a:ln>
         </p:spPr>
         <p:style>
@@ -20825,11 +20236,11 @@
             <a:pPr algn="ctr"/>
             <a:r>
               <a:rPr lang="en-US" sz="2000" b="1" dirty="0"/>
-              <a:t>For PPMs/BESS, Zone 1: allow only Topology “S”:</a:t>
+              <a:t>For PPMs, Zone 1: allow only Topology “S”:</a:t>
             </a:r>
             <a:r>
               <a:rPr lang="en-US" sz="2000" dirty="0"/>
-              <a:t> (single WT/PV/BESS)</a:t>
+              <a:t> (single WT/PV)</a:t>
             </a:r>
           </a:p>
         </p:txBody>
@@ -20849,7 +20260,7 @@
         <p:spPr>
           <a:xfrm>
             <a:off x="8948682" y="3182779"/>
-            <a:ext cx="397545" cy="246221"/>
+            <a:ext cx="1402628" cy="246221"/>
           </a:xfrm>
           <a:prstGeom prst="rect">
             <a:avLst/>
@@ -20864,7 +20275,7 @@
           <a:p>
             <a:r>
               <a:rPr lang="en-US" sz="1600" dirty="0"/>
-              <a:t>CB1</a:t>
+              <a:t>Internal Node 1</a:t>
             </a:r>
           </a:p>
         </p:txBody>
@@ -21015,7 +20426,7 @@
         </p:nvSpPr>
         <p:spPr>
           <a:xfrm>
-            <a:off x="6386457" y="2228778"/>
+            <a:off x="6426213" y="2000178"/>
             <a:ext cx="2877669" cy="215444"/>
           </a:xfrm>
           <a:prstGeom prst="rect">
@@ -21056,7 +20467,7 @@
                 <a:latin typeface="Courier New" panose="02070309020205020404" pitchFamily="49" charset="0"/>
                 <a:cs typeface="Courier New" panose="02070309020205020404" pitchFamily="49" charset="0"/>
               </a:rPr>
-              <a:t>StepUp_Xfmr</a:t>
+              <a:t>Group_Xfmr</a:t>
             </a:r>
             <a:r>
               <a:rPr lang="en-US" sz="1400" dirty="0">
@@ -21064,6 +20475,115 @@
                 <a:cs typeface="Courier New" panose="02070309020205020404" pitchFamily="49" charset="0"/>
               </a:rPr>
               <a:t>”</a:t>
+            </a:r>
+          </a:p>
+        </p:txBody>
+      </p:sp>
+      <p:sp>
+        <p:nvSpPr>
+          <p:cNvPr id="4" name="Rectángulo 3">
+            <a:extLst>
+              <a:ext uri="{FF2B5EF4-FFF2-40B4-BE49-F238E27FC236}">
+                <a16:creationId xmlns:a16="http://schemas.microsoft.com/office/drawing/2014/main" id="{72164238-ACB0-2D6E-CCB7-5175C24FD596}"/>
+              </a:ext>
+            </a:extLst>
+          </p:cNvPr>
+          <p:cNvSpPr/>
+          <p:nvPr/>
+        </p:nvSpPr>
+        <p:spPr bwMode="ltGray">
+          <a:xfrm>
+            <a:off x="7094631" y="2407815"/>
+            <a:ext cx="1350328" cy="862145"/>
+          </a:xfrm>
+          <a:prstGeom prst="rect">
+            <a:avLst/>
+          </a:prstGeom>
+          <a:noFill/>
+          <a:ln w="12700">
+            <a:solidFill>
+              <a:schemeClr val="tx1"/>
+            </a:solidFill>
+            <a:prstDash val="dash"/>
+          </a:ln>
+        </p:spPr>
+        <p:style>
+          <a:lnRef idx="2">
+            <a:schemeClr val="accent1">
+              <a:shade val="50000"/>
+            </a:schemeClr>
+          </a:lnRef>
+          <a:fillRef idx="1">
+            <a:schemeClr val="accent1"/>
+          </a:fillRef>
+          <a:effectRef idx="0">
+            <a:schemeClr val="accent1"/>
+          </a:effectRef>
+          <a:fontRef idx="minor">
+            <a:schemeClr val="lt1"/>
+          </a:fontRef>
+        </p:style>
+        <p:txBody>
+          <a:bodyPr rot="0" spcFirstLastPara="0" vertOverflow="overflow" horzOverflow="overflow" vert="horz" wrap="square" lIns="91440" tIns="45720" rIns="91440" bIns="45720" numCol="1" spcCol="0" rtlCol="0" fromWordArt="0" anchor="t" anchorCtr="0" forceAA="0" compatLnSpc="1">
+            <a:prstTxWarp prst="textNoShape">
+              <a:avLst/>
+            </a:prstTxWarp>
+            <a:noAutofit/>
+          </a:bodyPr>
+          <a:lstStyle/>
+          <a:p>
+            <a:pPr algn="l"/>
+            <a:endParaRPr lang="en-US" sz="1600" b="0" dirty="0" err="1"/>
+          </a:p>
+        </p:txBody>
+      </p:sp>
+      <p:sp>
+        <p:nvSpPr>
+          <p:cNvPr id="7" name="CuadroTexto 6">
+            <a:extLst>
+              <a:ext uri="{FF2B5EF4-FFF2-40B4-BE49-F238E27FC236}">
+                <a16:creationId xmlns:a16="http://schemas.microsoft.com/office/drawing/2014/main" id="{2B007961-4749-A060-A217-5FBD03C0099A}"/>
+              </a:ext>
+            </a:extLst>
+          </p:cNvPr>
+          <p:cNvSpPr txBox="1"/>
+          <p:nvPr/>
+        </p:nvSpPr>
+        <p:spPr>
+          <a:xfrm>
+            <a:off x="1883884" y="5376231"/>
+            <a:ext cx="7866044" cy="492443"/>
+          </a:xfrm>
+          <a:prstGeom prst="rect">
+            <a:avLst/>
+          </a:prstGeom>
+          <a:noFill/>
+        </p:spPr>
+        <p:txBody>
+          <a:bodyPr wrap="square" lIns="0" tIns="0" rIns="0" bIns="0" rtlCol="0">
+            <a:spAutoFit/>
+          </a:bodyPr>
+          <a:lstStyle/>
+          <a:p>
+            <a:r>
+              <a:rPr lang="en-US" sz="1600" i="1" dirty="0"/>
+              <a:t>Note: Group transformer to be modeled explicitly only if flag </a:t>
+            </a:r>
+            <a:r>
+              <a:rPr lang="en-US" sz="1600" i="1" dirty="0" err="1"/>
+              <a:t>ConverterLVControl</a:t>
+            </a:r>
+            <a:r>
+              <a:rPr lang="en-US" sz="1600" i="1" dirty="0"/>
+              <a:t> = True in the </a:t>
+            </a:r>
+            <a:r>
+              <a:rPr lang="en-US" sz="1600" i="1" dirty="0" err="1"/>
+              <a:t>Dynawo</a:t>
+            </a:r>
+            <a:r>
+              <a:rPr lang="en-US" sz="1600" i="1" dirty="0"/>
+              <a:t> model used for Zone 1 </a:t>
             </a:r>
           </a:p>
         </p:txBody>
@@ -22352,9 +21872,21 @@
 </file>
 
 <file path=customXml/item1.xml><?xml version="1.0" encoding="utf-8"?>
-<ct:contentTypeSchema xmlns:ct="http://schemas.microsoft.com/office/2006/metadata/contentType" xmlns:ma="http://schemas.microsoft.com/office/2006/metadata/properties/metaAttributes" ct:_="" ma:_="" ma:contentTypeName="Document" ma:contentTypeID="0x010100681278C9160AD2408B590194F15DBC22" ma:contentTypeVersion="2" ma:contentTypeDescription="Create a new document." ma:contentTypeScope="" ma:versionID="d2ccef407a63d5a89172cf9de4ba5ae8">
-  <xsd:schema xmlns:xsd="http://www.w3.org/2001/XMLSchema" xmlns:xs="http://www.w3.org/2001/XMLSchema" xmlns:p="http://schemas.microsoft.com/office/2006/metadata/properties" xmlns:ns2="349d2e48-d219-423f-a60f-a81395996a24" targetNamespace="http://schemas.microsoft.com/office/2006/metadata/properties" ma:root="true" ma:fieldsID="239a064504d388639a86cd6a9b4bf3b5" ns2:_="">
-    <xsd:import namespace="349d2e48-d219-423f-a60f-a81395996a24"/>
+<p:properties xmlns:p="http://schemas.microsoft.com/office/2006/metadata/properties" xmlns:xsi="http://www.w3.org/2001/XMLSchema-instance" xmlns:pc="http://schemas.microsoft.com/office/infopath/2007/PartnerControls">
+  <documentManagement>
+    <lcf76f155ced4ddcb4097134ff3c332f xmlns="ea94f633-b443-4495-a189-b71518d5e419">
+      <Terms xmlns="http://schemas.microsoft.com/office/infopath/2007/PartnerControls"/>
+    </lcf76f155ced4ddcb4097134ff3c332f>
+    <TaxCatchAll xmlns="375a73e1-ca7c-49e8-944d-c246c30eb518" xsi:nil="true"/>
+  </documentManagement>
+</p:properties>
+</file>
+
+<file path=customXml/item2.xml><?xml version="1.0" encoding="utf-8"?>
+<ct:contentTypeSchema xmlns:ct="http://schemas.microsoft.com/office/2006/metadata/contentType" xmlns:ma="http://schemas.microsoft.com/office/2006/metadata/properties/metaAttributes" ct:_="" ma:_="" ma:contentTypeName="Document" ma:contentTypeID="0x0101001233001E69A463498708B9A6DEF5B1F9" ma:contentTypeVersion="13" ma:contentTypeDescription="Create a new document." ma:contentTypeScope="" ma:versionID="c1113f19233ec6f8f3c49e51f4c38276">
+  <xsd:schema xmlns:xsd="http://www.w3.org/2001/XMLSchema" xmlns:xs="http://www.w3.org/2001/XMLSchema" xmlns:p="http://schemas.microsoft.com/office/2006/metadata/properties" xmlns:ns2="ea94f633-b443-4495-a189-b71518d5e419" xmlns:ns3="375a73e1-ca7c-49e8-944d-c246c30eb518" targetNamespace="http://schemas.microsoft.com/office/2006/metadata/properties" ma:root="true" ma:fieldsID="8678d794e3b0e237f8bf8e3602980d06" ns2:_="" ns3:_="">
+    <xsd:import namespace="ea94f633-b443-4495-a189-b71518d5e419"/>
+    <xsd:import namespace="375a73e1-ca7c-49e8-944d-c246c30eb518"/>
     <xsd:element name="properties">
       <xsd:complexType>
         <xsd:sequence>
@@ -22363,6 +21895,16 @@
               <xsd:all>
                 <xsd:element ref="ns2:MediaServiceMetadata" minOccurs="0"/>
                 <xsd:element ref="ns2:MediaServiceFastMetadata" minOccurs="0"/>
+                <xsd:element ref="ns2:MediaServiceSearchProperties" minOccurs="0"/>
+                <xsd:element ref="ns2:MediaServiceObjectDetectorVersions" minOccurs="0"/>
+                <xsd:element ref="ns2:MediaServiceGenerationTime" minOccurs="0"/>
+                <xsd:element ref="ns2:MediaServiceEventHashCode" minOccurs="0"/>
+                <xsd:element ref="ns2:MediaLengthInSeconds" minOccurs="0"/>
+                <xsd:element ref="ns2:MediaServiceDateTaken" minOccurs="0"/>
+                <xsd:element ref="ns2:lcf76f155ced4ddcb4097134ff3c332f" minOccurs="0"/>
+                <xsd:element ref="ns3:TaxCatchAll" minOccurs="0"/>
+                <xsd:element ref="ns2:MediaServiceOCR" minOccurs="0"/>
+                <xsd:element ref="ns2:MediaServiceLocation" minOccurs="0"/>
               </xsd:all>
             </xsd:complexType>
           </xsd:element>
@@ -22370,7 +21912,7 @@
       </xsd:complexType>
     </xsd:element>
   </xsd:schema>
-  <xsd:schema xmlns:xsd="http://www.w3.org/2001/XMLSchema" xmlns:xs="http://www.w3.org/2001/XMLSchema" xmlns:dms="http://schemas.microsoft.com/office/2006/documentManagement/types" xmlns:pc="http://schemas.microsoft.com/office/infopath/2007/PartnerControls" targetNamespace="349d2e48-d219-423f-a60f-a81395996a24" elementFormDefault="qualified">
+  <xsd:schema xmlns:xsd="http://www.w3.org/2001/XMLSchema" xmlns:xs="http://www.w3.org/2001/XMLSchema" xmlns:dms="http://schemas.microsoft.com/office/2006/documentManagement/types" xmlns:pc="http://schemas.microsoft.com/office/infopath/2007/PartnerControls" targetNamespace="ea94f633-b443-4495-a189-b71518d5e419" elementFormDefault="qualified">
     <xsd:import namespace="http://schemas.microsoft.com/office/2006/documentManagement/types"/>
     <xsd:import namespace="http://schemas.microsoft.com/office/infopath/2007/PartnerControls"/>
     <xsd:element name="MediaServiceMetadata" ma:index="8" nillable="true" ma:displayName="MediaServiceMetadata" ma:hidden="true" ma:internalName="MediaServiceMetadata" ma:readOnly="true">
@@ -22382,6 +21924,70 @@
       <xsd:simpleType>
         <xsd:restriction base="dms:Note"/>
       </xsd:simpleType>
+    </xsd:element>
+    <xsd:element name="MediaServiceSearchProperties" ma:index="10" nillable="true" ma:displayName="MediaServiceSearchProperties" ma:hidden="true" ma:internalName="MediaServiceSearchProperties" ma:readOnly="true">
+      <xsd:simpleType>
+        <xsd:restriction base="dms:Note"/>
+      </xsd:simpleType>
+    </xsd:element>
+    <xsd:element name="MediaServiceObjectDetectorVersions" ma:index="11" nillable="true" ma:displayName="MediaServiceObjectDetectorVersions" ma:hidden="true" ma:indexed="true" ma:internalName="MediaServiceObjectDetectorVersions" ma:readOnly="true">
+      <xsd:simpleType>
+        <xsd:restriction base="dms:Text"/>
+      </xsd:simpleType>
+    </xsd:element>
+    <xsd:element name="MediaServiceGenerationTime" ma:index="12" nillable="true" ma:displayName="MediaServiceGenerationTime" ma:hidden="true" ma:internalName="MediaServiceGenerationTime" ma:readOnly="true">
+      <xsd:simpleType>
+        <xsd:restriction base="dms:Text"/>
+      </xsd:simpleType>
+    </xsd:element>
+    <xsd:element name="MediaServiceEventHashCode" ma:index="13" nillable="true" ma:displayName="MediaServiceEventHashCode" ma:hidden="true" ma:internalName="MediaServiceEventHashCode" ma:readOnly="true">
+      <xsd:simpleType>
+        <xsd:restriction base="dms:Text"/>
+      </xsd:simpleType>
+    </xsd:element>
+    <xsd:element name="MediaLengthInSeconds" ma:index="14" nillable="true" ma:displayName="MediaLengthInSeconds" ma:hidden="true" ma:internalName="MediaLengthInSeconds" ma:readOnly="true">
+      <xsd:simpleType>
+        <xsd:restriction base="dms:Unknown"/>
+      </xsd:simpleType>
+    </xsd:element>
+    <xsd:element name="MediaServiceDateTaken" ma:index="15" nillable="true" ma:displayName="MediaServiceDateTaken" ma:hidden="true" ma:indexed="true" ma:internalName="MediaServiceDateTaken" ma:readOnly="true">
+      <xsd:simpleType>
+        <xsd:restriction base="dms:Text"/>
+      </xsd:simpleType>
+    </xsd:element>
+    <xsd:element name="lcf76f155ced4ddcb4097134ff3c332f" ma:index="17" nillable="true" ma:taxonomy="true" ma:internalName="lcf76f155ced4ddcb4097134ff3c332f" ma:taxonomyFieldName="MediaServiceImageTags" ma:displayName="Image Tags" ma:readOnly="false" ma:fieldId="{5cf76f15-5ced-4ddc-b409-7134ff3c332f}" ma:taxonomyMulti="true" ma:sspId="4b9b5273-c2ab-44a2-a879-b390c9bcfd71" ma:termSetId="09814cd3-568e-fe90-9814-8d621ff8fb84" ma:anchorId="fba54fb3-c3e1-fe81-a776-ca4b69148c4d" ma:open="true" ma:isKeyword="false">
+      <xsd:complexType>
+        <xsd:sequence>
+          <xsd:element ref="pc:Terms" minOccurs="0" maxOccurs="1"/>
+        </xsd:sequence>
+      </xsd:complexType>
+    </xsd:element>
+    <xsd:element name="MediaServiceOCR" ma:index="19" nillable="true" ma:displayName="Extracted Text" ma:internalName="MediaServiceOCR" ma:readOnly="true">
+      <xsd:simpleType>
+        <xsd:restriction base="dms:Note">
+          <xsd:maxLength value="255"/>
+        </xsd:restriction>
+      </xsd:simpleType>
+    </xsd:element>
+    <xsd:element name="MediaServiceLocation" ma:index="20" nillable="true" ma:displayName="Location" ma:description="" ma:indexed="true" ma:internalName="MediaServiceLocation" ma:readOnly="true">
+      <xsd:simpleType>
+        <xsd:restriction base="dms:Text"/>
+      </xsd:simpleType>
+    </xsd:element>
+  </xsd:schema>
+  <xsd:schema xmlns:xsd="http://www.w3.org/2001/XMLSchema" xmlns:xs="http://www.w3.org/2001/XMLSchema" xmlns:dms="http://schemas.microsoft.com/office/2006/documentManagement/types" xmlns:pc="http://schemas.microsoft.com/office/infopath/2007/PartnerControls" targetNamespace="375a73e1-ca7c-49e8-944d-c246c30eb518" elementFormDefault="qualified">
+    <xsd:import namespace="http://schemas.microsoft.com/office/2006/documentManagement/types"/>
+    <xsd:import namespace="http://schemas.microsoft.com/office/infopath/2007/PartnerControls"/>
+    <xsd:element name="TaxCatchAll" ma:index="18" nillable="true" ma:displayName="Taxonomy Catch All Column" ma:hidden="true" ma:list="{3c9be488-3e42-4ddb-9f5e-b869873b5db9}" ma:internalName="TaxCatchAll" ma:showField="CatchAllData" ma:web="375a73e1-ca7c-49e8-944d-c246c30eb518">
+      <xsd:complexType>
+        <xsd:complexContent>
+          <xsd:extension base="dms:MultiChoiceLookup">
+            <xsd:sequence>
+              <xsd:element name="Value" type="dms:Lookup" maxOccurs="unbounded" minOccurs="0" nillable="true"/>
+            </xsd:sequence>
+          </xsd:extension>
+        </xsd:complexContent>
+      </xsd:complexType>
     </xsd:element>
   </xsd:schema>
   <xsd:schema xmlns="http://schemas.openxmlformats.org/package/2006/metadata/core-properties" xmlns:xsd="http://www.w3.org/2001/XMLSchema" xmlns:xsi="http://www.w3.org/2001/XMLSchema-instance" xmlns:dc="http://purl.org/dc/elements/1.1/" xmlns:dcterms="http://purl.org/dc/terms/" xmlns:odoc="http://schemas.microsoft.com/internal/obd" targetNamespace="http://schemas.openxmlformats.org/package/2006/metadata/core-properties" elementFormDefault="qualified" attributeFormDefault="unqualified" blockDefault="#all">
@@ -22483,7 +22089,7 @@
 </ct:contentTypeSchema>
 </file>
 
-<file path=customXml/item2.xml><?xml version="1.0" encoding="utf-8"?>
+<file path=customXml/item3.xml><?xml version="1.0" encoding="utf-8"?>
 <?mso-contentType ?>
 <FormTemplates xmlns="http://schemas.microsoft.com/sharepoint/v3/contenttype/forms">
   <Display>DocumentLibraryForm</Display>
@@ -22492,20 +22098,32 @@
 </FormTemplates>
 </file>
 
-<file path=customXml/item3.xml><?xml version="1.0" encoding="utf-8"?>
-<p:properties xmlns:p="http://schemas.microsoft.com/office/2006/metadata/properties" xmlns:xsi="http://www.w3.org/2001/XMLSchema-instance" xmlns:pc="http://schemas.microsoft.com/office/infopath/2007/PartnerControls">
-  <documentManagement/>
-</p:properties>
+<file path=customXml/itemProps1.xml><?xml version="1.0" encoding="utf-8"?>
+<ds:datastoreItem xmlns:ds="http://schemas.openxmlformats.org/officeDocument/2006/customXml" ds:itemID="{22193883-9DEF-4394-A746-8B0504B231C0}">
+  <ds:schemaRefs>
+    <ds:schemaRef ds:uri="http://purl.org/dc/dcmitype/"/>
+    <ds:schemaRef ds:uri="ea94f633-b443-4495-a189-b71518d5e419"/>
+    <ds:schemaRef ds:uri="http://schemas.microsoft.com/office/2006/documentManagement/types"/>
+    <ds:schemaRef ds:uri="http://schemas.microsoft.com/office/2006/metadata/properties"/>
+    <ds:schemaRef ds:uri="http://purl.org/dc/elements/1.1/"/>
+    <ds:schemaRef ds:uri="375a73e1-ca7c-49e8-944d-c246c30eb518"/>
+    <ds:schemaRef ds:uri="http://schemas.microsoft.com/office/infopath/2007/PartnerControls"/>
+    <ds:schemaRef ds:uri="http://www.w3.org/XML/1998/namespace"/>
+    <ds:schemaRef ds:uri="http://schemas.openxmlformats.org/package/2006/metadata/core-properties"/>
+    <ds:schemaRef ds:uri="http://purl.org/dc/terms/"/>
+  </ds:schemaRefs>
+</ds:datastoreItem>
 </file>
 
-<file path=customXml/itemProps1.xml><?xml version="1.0" encoding="utf-8"?>
-<ds:datastoreItem xmlns:ds="http://schemas.openxmlformats.org/officeDocument/2006/customXml" ds:itemID="{5232082A-399C-4A00-AC49-F1B5B9CDE4BD}">
+<file path=customXml/itemProps2.xml><?xml version="1.0" encoding="utf-8"?>
+<ds:datastoreItem xmlns:ds="http://schemas.openxmlformats.org/officeDocument/2006/customXml" ds:itemID="{7A3525C2-B11A-4C50-8BEE-67D9CE568E03}">
   <ds:schemaRefs>
     <ds:schemaRef ds:uri="http://schemas.microsoft.com/office/2006/metadata/contentType"/>
     <ds:schemaRef ds:uri="http://schemas.microsoft.com/office/2006/metadata/properties/metaAttributes"/>
     <ds:schemaRef ds:uri="http://www.w3.org/2001/XMLSchema"/>
     <ds:schemaRef ds:uri="http://schemas.microsoft.com/office/2006/metadata/properties"/>
-    <ds:schemaRef ds:uri="349d2e48-d219-423f-a60f-a81395996a24"/>
+    <ds:schemaRef ds:uri="ea94f633-b443-4495-a189-b71518d5e419"/>
+    <ds:schemaRef ds:uri="375a73e1-ca7c-49e8-944d-c246c30eb518"/>
     <ds:schemaRef ds:uri="http://schemas.microsoft.com/office/2006/documentManagement/types"/>
     <ds:schemaRef ds:uri="http://schemas.microsoft.com/office/infopath/2007/PartnerControls"/>
     <ds:schemaRef ds:uri="http://schemas.openxmlformats.org/package/2006/metadata/core-properties"/>
@@ -22516,26 +22134,10 @@
 </ds:datastoreItem>
 </file>
 
-<file path=customXml/itemProps2.xml><?xml version="1.0" encoding="utf-8"?>
+<file path=customXml/itemProps3.xml><?xml version="1.0" encoding="utf-8"?>
 <ds:datastoreItem xmlns:ds="http://schemas.openxmlformats.org/officeDocument/2006/customXml" ds:itemID="{BC375B81-FBF5-4924-A5E0-F0376D8E7D52}">
   <ds:schemaRefs>
     <ds:schemaRef ds:uri="http://schemas.microsoft.com/sharepoint/v3/contenttype/forms"/>
   </ds:schemaRefs>
 </ds:datastoreItem>
-</file>
-
-<file path=customXml/itemProps3.xml><?xml version="1.0" encoding="utf-8"?>
-<ds:datastoreItem xmlns:ds="http://schemas.openxmlformats.org/officeDocument/2006/customXml" ds:itemID="{22193883-9DEF-4394-A746-8B0504B231C0}">
-  <ds:schemaRefs>
-    <ds:schemaRef ds:uri="http://schemas.microsoft.com/office/2006/metadata/properties"/>
-    <ds:schemaRef ds:uri="http://purl.org/dc/dcmitype/"/>
-    <ds:schemaRef ds:uri="http://schemas.openxmlformats.org/package/2006/metadata/core-properties"/>
-    <ds:schemaRef ds:uri="349d2e48-d219-423f-a60f-a81395996a24"/>
-    <ds:schemaRef ds:uri="http://schemas.microsoft.com/office/2006/documentManagement/types"/>
-    <ds:schemaRef ds:uri="http://purl.org/dc/elements/1.1/"/>
-    <ds:schemaRef ds:uri="http://schemas.microsoft.com/office/infopath/2007/PartnerControls"/>
-    <ds:schemaRef ds:uri="http://www.w3.org/XML/1998/namespace"/>
-    <ds:schemaRef ds:uri="http://purl.org/dc/terms/"/>
-  </ds:schemaRefs>
-</ds:datastoreItem>
 </file>
</xml_diff>